<commit_message>
docs: update investor deck, activation playbook, and working docs
- Updated IR Deck and Architecture PDF
- Revised ACTIVATION_100USERS.md
- Archived old playbook versions to archive/
- Removed superseded ACTIVATION_PLAYBOOK.md
- Added SLIDE_DRAFT_review.md

Co-Authored-By: Claude Opus 4.6 <noreply@anthropic.com>
</commit_message>
<xml_diff>
--- a/docs/working_docs/investors/IR Deck - yarnnn - March 2026.pptx
+++ b/docs/working_docs/investors/IR Deck - yarnnn - March 2026.pptx
@@ -17,15 +17,15 @@
     <p:sldId id="263" r:id="rId8"/>
     <p:sldId id="260" r:id="rId9"/>
     <p:sldId id="262" r:id="rId10"/>
-    <p:sldId id="261" r:id="rId11"/>
-    <p:sldId id="273" r:id="rId12"/>
-    <p:sldId id="277" r:id="rId13"/>
-    <p:sldId id="266" r:id="rId14"/>
-    <p:sldId id="269" r:id="rId15"/>
-    <p:sldId id="270" r:id="rId16"/>
-    <p:sldId id="272" r:id="rId17"/>
-    <p:sldId id="278" r:id="rId18"/>
-    <p:sldId id="279" r:id="rId19"/>
+    <p:sldId id="273" r:id="rId11"/>
+    <p:sldId id="277" r:id="rId12"/>
+    <p:sldId id="266" r:id="rId13"/>
+    <p:sldId id="269" r:id="rId14"/>
+    <p:sldId id="270" r:id="rId15"/>
+    <p:sldId id="272" r:id="rId16"/>
+    <p:sldId id="278" r:id="rId17"/>
+    <p:sldId id="279" r:id="rId18"/>
+    <p:sldId id="261" r:id="rId19"/>
   </p:sldIdLst>
   <p:sldSz cx="9144000" cy="5143500" type="screen16x9"/>
   <p:notesSz cx="5143500" cy="9144000"/>
@@ -3541,7 +3541,7 @@
     </p:spTree>
     <p:extLst>
       <p:ext uri="{BB962C8B-B14F-4D97-AF65-F5344CB8AC3E}">
-        <p14:creationId xmlns:p14="http://schemas.microsoft.com/office/powerpoint/2010/main" val="1024086991"/>
+        <p14:creationId xmlns:p14="http://schemas.microsoft.com/office/powerpoint/2010/main" val="3439085272"/>
       </p:ext>
     </p:extLst>
   </p:cSld>
@@ -3632,7 +3632,7 @@
     </p:spTree>
     <p:extLst>
       <p:ext uri="{BB962C8B-B14F-4D97-AF65-F5344CB8AC3E}">
-        <p14:creationId xmlns:p14="http://schemas.microsoft.com/office/powerpoint/2010/main" val="3439085272"/>
+        <p14:creationId xmlns:p14="http://schemas.microsoft.com/office/powerpoint/2010/main" val="1024086991"/>
       </p:ext>
     </p:extLst>
   </p:cSld>
@@ -3714,7 +3714,7 @@
           <a:p>
             <a:fld id="{F7021451-1387-4CA6-816F-3879F97B5CBC}" type="slidenum">
               <a:rPr lang="en-US"/>
-              <a:t>16</a:t>
+              <a:t>17</a:t>
             </a:fld>
             <a:endParaRPr lang="en-US"/>
           </a:p>
@@ -3814,7 +3814,7 @@
     </p:spTree>
     <p:extLst>
       <p:ext uri="{BB962C8B-B14F-4D97-AF65-F5344CB8AC3E}">
-        <p14:creationId xmlns:p14="http://schemas.microsoft.com/office/powerpoint/2010/main" val="1024086991"/>
+        <p14:creationId xmlns:p14="http://schemas.microsoft.com/office/powerpoint/2010/main" val="3580186496"/>
       </p:ext>
     </p:extLst>
   </p:cSld>
@@ -4533,7 +4533,7 @@
           <a:p>
             <a:fld id="{F7021451-1387-4CA6-816F-3879F97B5CBC}" type="slidenum">
               <a:rPr lang="en-US"/>
-              <a:t>10</a:t>
+              <a:t>11</a:t>
             </a:fld>
             <a:endParaRPr lang="en-US"/>
           </a:p>
@@ -4961,7 +4961,7 @@
                 <a:ea typeface="Arial" pitchFamily="34" charset="-122"/>
                 <a:cs typeface="Arial" pitchFamily="34" charset="-120"/>
               </a:rPr>
-              <a:t>Your autonomous AI agent — powered by accumulated work context</a:t>
+              <a:t>Autonomous agents that know your work.</a:t>
             </a:r>
             <a:endParaRPr lang="en-US" sz="1800" dirty="0"/>
           </a:p>
@@ -5000,7 +5000,7 @@
                 <a:ea typeface="Arial" pitchFamily="34" charset="-122"/>
                 <a:cs typeface="Arial" pitchFamily="34" charset="-120"/>
               </a:rPr>
-              <a:t>It connects to your tools. It learns your world. It works while you don't.</a:t>
+              <a:t>They connect to your platforms. They accumulate knowledge. They work while you don't.</a:t>
             </a:r>
             <a:endParaRPr lang="en-US" sz="1400" dirty="0"/>
           </a:p>
@@ -5150,537 +5150,6 @@
 </file>
 
 <file path=ppt/slides/slide10.xml><?xml version="1.0" encoding="utf-8"?>
-<p:sld xmlns:a="http://schemas.openxmlformats.org/drawingml/2006/main" xmlns:r="http://schemas.openxmlformats.org/officeDocument/2006/relationships" xmlns:p="http://schemas.openxmlformats.org/presentationml/2006/main">
-  <p:cSld>
-    <p:bg>
-      <p:bgPr>
-        <a:solidFill>
-          <a:srgbClr val="FFFFFF"/>
-        </a:solidFill>
-        <a:effectLst/>
-      </p:bgPr>
-    </p:bg>
-    <p:spTree>
-      <p:nvGrpSpPr>
-        <p:cNvPr id="1" name="Slide 9"/>
-        <p:cNvGrpSpPr/>
-        <p:nvPr/>
-      </p:nvGrpSpPr>
-      <p:grpSpPr>
-        <a:xfrm>
-          <a:off x="0" y="0"/>
-          <a:ext cx="9144000" cy="5143500"/>
-          <a:chOff x="0" y="0"/>
-          <a:chExt cx="9144000" cy="5143500"/>
-        </a:xfrm>
-      </p:grpSpPr>
-      <p:sp>
-        <p:nvSpPr>
-          <p:cNvPr id="2" name="Section Label"/>
-          <p:cNvSpPr/>
-          <p:nvPr/>
-        </p:nvSpPr>
-        <p:spPr>
-          <a:xfrm>
-            <a:off x="685800" y="457200"/>
-            <a:ext cx="2000000" cy="274320"/>
-          </a:xfrm>
-          <a:prstGeom prst="rect">
-            <a:avLst/>
-          </a:prstGeom>
-          <a:noFill/>
-          <a:ln/>
-        </p:spPr>
-        <p:txBody>
-          <a:bodyPr wrap="square" lIns="0" tIns="0" rIns="0" bIns="0" rtlCol="0" anchor="ctr"/>
-          <a:lstStyle/>
-          <a:p>
-            <a:pPr marL="0" indent="0">
-              <a:buNone/>
-            </a:pPr>
-            <a:r>
-              <a:rPr lang="en-US" sz="1100" b="1" dirty="0">
-                <a:solidFill>
-                  <a:srgbClr val="E8985E"/>
-                </a:solidFill>
-                <a:latin typeface="Arial" pitchFamily="34" charset="0"/>
-                <a:ea typeface="Arial" pitchFamily="34" charset="-122"/>
-                <a:cs typeface="Arial" pitchFamily="34" charset="-120"/>
-              </a:rPr>
-              <a:t>Proactive Intelligence</a:t>
-            </a:r>
-          </a:p>
-        </p:txBody>
-      </p:sp>
-      <p:sp>
-        <p:nvSpPr>
-          <p:cNvPr id="3" name="Title"/>
-          <p:cNvSpPr/>
-          <p:nvPr/>
-        </p:nvSpPr>
-        <p:spPr>
-          <a:xfrm>
-            <a:off x="685800" y="777240"/>
-            <a:ext cx="7772400" cy="457200"/>
-          </a:xfrm>
-          <a:prstGeom prst="rect">
-            <a:avLst/>
-          </a:prstGeom>
-          <a:noFill/>
-          <a:ln/>
-        </p:spPr>
-        <p:txBody>
-          <a:bodyPr wrap="square" lIns="0" tIns="0" rIns="0" bIns="0" rtlCol="0" anchor="ctr"/>
-          <a:lstStyle/>
-          <a:p>
-            <a:pPr marL="0" indent="0">
-              <a:buNone/>
-            </a:pPr>
-            <a:r>
-              <a:rPr lang="en-US" sz="2400" b="1" dirty="0">
-                <a:solidFill>
-                  <a:srgbClr val="111111"/>
-                </a:solidFill>
-                <a:latin typeface="Arial" pitchFamily="34" charset="0"/>
-                <a:ea typeface="Arial" pitchFamily="34" charset="-122"/>
-                <a:cs typeface="Arial" pitchFamily="34" charset="-120"/>
-              </a:rPr>
-              <a:t>Your AI works while you don't.</a:t>
-            </a:r>
-          </a:p>
-        </p:txBody>
-      </p:sp>
-      <p:sp>
-        <p:nvSpPr>
-          <p:cNvPr id="4" name="Subtitle"/>
-          <p:cNvSpPr/>
-          <p:nvPr/>
-        </p:nvSpPr>
-        <p:spPr>
-          <a:xfrm>
-            <a:off x="685800" y="1371600"/>
-            <a:ext cx="7772400" cy="274320"/>
-          </a:xfrm>
-          <a:prstGeom prst="rect">
-            <a:avLst/>
-          </a:prstGeom>
-          <a:noFill/>
-          <a:ln/>
-        </p:spPr>
-        <p:txBody>
-          <a:bodyPr wrap="square" lIns="0" tIns="0" rIns="0" bIns="0" rtlCol="0" anchor="ctr"/>
-          <a:lstStyle/>
-          <a:p>
-            <a:pPr marL="0" indent="0">
-              <a:buNone/>
-            </a:pPr>
-            <a:r>
-              <a:rPr lang="en-US" sz="1100" dirty="0">
-                <a:solidFill>
-                  <a:srgbClr val="666666"/>
-                </a:solidFill>
-                <a:latin typeface="Arial" pitchFamily="34" charset="0"/>
-                <a:ea typeface="Arial" pitchFamily="34" charset="-122"/>
-                <a:cs typeface="Arial" pitchFamily="34" charset="-120"/>
-              </a:rPr>
-              <a:t>Two-phase execution: cheap review decides if expensive generation is warranted.</a:t>
-            </a:r>
-          </a:p>
-        </p:txBody>
-      </p:sp>
-      <p:sp>
-        <p:nvSpPr>
-          <p:cNvPr id="5" name="Card1"/>
-          <p:cNvSpPr/>
-          <p:nvPr/>
-        </p:nvSpPr>
-        <p:spPr>
-          <a:xfrm>
-            <a:off x="685800" y="1970843"/>
-            <a:ext cx="2200000" cy="1700000"/>
-          </a:xfrm>
-          <a:prstGeom prst="rect">
-            <a:avLst/>
-          </a:prstGeom>
-          <a:solidFill>
-            <a:srgbClr val="F8F8F8"/>
-          </a:solidFill>
-          <a:ln>
-            <a:solidFill>
-              <a:srgbClr val="DEDEDE"/>
-            </a:solidFill>
-            <a:prstDash val="solid"/>
-            <a:round/>
-          </a:ln>
-        </p:spPr>
-        <p:txBody>
-          <a:bodyPr wrap="square" lIns="91440" tIns="45720" rIns="91440" bIns="45720" rtlCol="0" anchor="t"/>
-          <a:lstStyle/>
-          <a:p>
-            <a:pPr marL="0" indent="0">
-              <a:buNone/>
-            </a:pPr>
-            <a:r>
-              <a:rPr lang="en-US" sz="1100" b="1" dirty="0">
-                <a:solidFill>
-                  <a:srgbClr val="111111"/>
-                </a:solidFill>
-                <a:latin typeface="Arial" pitchFamily="34" charset="0"/>
-                <a:ea typeface="Arial" pitchFamily="34" charset="-122"/>
-                <a:cs typeface="Arial" pitchFamily="34" charset="-120"/>
-              </a:rPr>
-              <a:t>Phase 1: Review</a:t>
-            </a:r>
-          </a:p>
-          <a:p>
-            <a:pPr marL="0" indent="0">
-              <a:buNone/>
-            </a:pPr>
-            <a:r>
-              <a:rPr lang="en-US" sz="900" dirty="0">
-                <a:solidFill>
-                  <a:srgbClr val="666666"/>
-                </a:solidFill>
-                <a:latin typeface="Arial" pitchFamily="34" charset="0"/>
-                <a:ea typeface="Arial" pitchFamily="34" charset="-122"/>
-                <a:cs typeface="Arial" pitchFamily="34" charset="-120"/>
-              </a:rPr>
-              <a:t>Haiku scans accumulated context</a:t>
-            </a:r>
-          </a:p>
-          <a:p>
-            <a:pPr marL="0" indent="0">
-              <a:buNone/>
-            </a:pPr>
-            <a:r>
-              <a:rPr lang="en-US" sz="900" b="1" dirty="0">
-                <a:solidFill>
-                  <a:srgbClr val="E8985E"/>
-                </a:solidFill>
-                <a:latin typeface="Arial" pitchFamily="34" charset="0"/>
-                <a:ea typeface="Arial" pitchFamily="34" charset="-122"/>
-                <a:cs typeface="Arial" pitchFamily="34" charset="-120"/>
-              </a:rPr>
-              <a:t>Cost: ~$0.002 per cycle</a:t>
-            </a:r>
-          </a:p>
-          <a:p>
-            <a:pPr marL="0" indent="0">
-              <a:buNone/>
-            </a:pPr>
-            <a:r>
-              <a:rPr lang="en-US" sz="900" dirty="0">
-                <a:solidFill>
-                  <a:srgbClr val="666666"/>
-                </a:solidFill>
-                <a:latin typeface="Arial" pitchFamily="34" charset="0"/>
-                <a:ea typeface="Arial" pitchFamily="34" charset="-122"/>
-                <a:cs typeface="Arial" pitchFamily="34" charset="-120"/>
-              </a:rPr>
-              <a:t>Runs every scheduled interval</a:t>
-            </a:r>
-          </a:p>
-        </p:txBody>
-      </p:sp>
-      <p:sp>
-        <p:nvSpPr>
-          <p:cNvPr id="6" name="Arrow1"/>
-          <p:cNvSpPr/>
-          <p:nvPr/>
-        </p:nvSpPr>
-        <p:spPr>
-          <a:xfrm>
-            <a:off x="2985800" y="2337043"/>
-            <a:ext cx="350000" cy="200000"/>
-          </a:xfrm>
-          <a:prstGeom prst="rightArrow">
-            <a:avLst/>
-          </a:prstGeom>
-          <a:solidFill>
-            <a:srgbClr val="E8985E"/>
-          </a:solidFill>
-          <a:ln>
-            <a:noFill/>
-          </a:ln>
-        </p:spPr>
-        <p:txBody>
-          <a:bodyPr wrap="square" lIns="0" tIns="0" rIns="0" bIns="0" rtlCol="0" anchor="ctr"/>
-          <a:lstStyle/>
-          <a:p>
-            <a:pPr marL="0" indent="0">
-              <a:buNone/>
-            </a:pPr>
-            <a:endParaRPr/>
-          </a:p>
-        </p:txBody>
-      </p:sp>
-      <p:sp>
-        <p:nvSpPr>
-          <p:cNvPr id="7" name="Card2"/>
-          <p:cNvSpPr/>
-          <p:nvPr/>
-        </p:nvSpPr>
-        <p:spPr>
-          <a:xfrm>
-            <a:off x="3435800" y="1970843"/>
-            <a:ext cx="2200000" cy="1700000"/>
-          </a:xfrm>
-          <a:prstGeom prst="rect">
-            <a:avLst/>
-          </a:prstGeom>
-          <a:solidFill>
-            <a:srgbClr val="E8985E"/>
-          </a:solidFill>
-          <a:ln>
-            <a:solidFill>
-              <a:srgbClr val="E8985E"/>
-            </a:solidFill>
-            <a:prstDash val="solid"/>
-            <a:round/>
-          </a:ln>
-        </p:spPr>
-        <p:txBody>
-          <a:bodyPr wrap="square" lIns="91440" tIns="45720" rIns="91440" bIns="45720" rtlCol="0" anchor="t"/>
-          <a:lstStyle/>
-          <a:p>
-            <a:pPr marL="0" indent="0">
-              <a:buNone/>
-            </a:pPr>
-            <a:r>
-              <a:rPr lang="en-US" sz="1100" b="1" dirty="0">
-                <a:solidFill>
-                  <a:srgbClr val="FFFFFF"/>
-                </a:solidFill>
-                <a:latin typeface="Arial" pitchFamily="34" charset="0"/>
-                <a:ea typeface="Arial" pitchFamily="34" charset="-122"/>
-                <a:cs typeface="Arial" pitchFamily="34" charset="-120"/>
-              </a:rPr>
-              <a:t>Decision Gate</a:t>
-            </a:r>
-          </a:p>
-          <a:p>
-            <a:pPr marL="0" indent="0">
-              <a:buNone/>
-            </a:pPr>
-            <a:r>
-              <a:rPr lang="en-US" sz="900" i="1" dirty="0">
-                <a:solidFill>
-                  <a:srgbClr val="FFFFFF"/>
-                </a:solidFill>
-                <a:latin typeface="Arial" pitchFamily="34" charset="0"/>
-                <a:ea typeface="Arial" pitchFamily="34" charset="-122"/>
-                <a:cs typeface="Arial" pitchFamily="34" charset="-120"/>
-              </a:rPr>
-              <a:t>Is there something worth reporting?</a:t>
-            </a:r>
-          </a:p>
-          <a:p>
-            <a:pPr marL="0" indent="0">
-              <a:buNone/>
-            </a:pPr>
-            <a:r>
-              <a:rPr lang="en-US" sz="900" dirty="0">
-                <a:solidFill>
-                  <a:srgbClr val="FFFFFF"/>
-                </a:solidFill>
-                <a:latin typeface="Arial" pitchFamily="34" charset="0"/>
-                <a:ea typeface="Arial" pitchFamily="34" charset="-122"/>
-                <a:cs typeface="Arial" pitchFamily="34" charset="-120"/>
-              </a:rPr>
-              <a:t>Most cycles: nothing new</a:t>
-            </a:r>
-          </a:p>
-          <a:p>
-            <a:pPr marL="0" indent="0">
-              <a:buNone/>
-            </a:pPr>
-            <a:r>
-              <a:rPr lang="en-US" sz="900" dirty="0">
-                <a:solidFill>
-                  <a:srgbClr val="FFFFFF"/>
-                </a:solidFill>
-                <a:latin typeface="Arial" pitchFamily="34" charset="0"/>
-                <a:ea typeface="Arial" pitchFamily="34" charset="-122"/>
-                <a:cs typeface="Arial" pitchFamily="34" charset="-120"/>
-              </a:rPr>
-              <a:t>Only triggers generation when signal detected</a:t>
-            </a:r>
-          </a:p>
-        </p:txBody>
-      </p:sp>
-      <p:sp>
-        <p:nvSpPr>
-          <p:cNvPr id="8" name="Arrow2"/>
-          <p:cNvSpPr/>
-          <p:nvPr/>
-        </p:nvSpPr>
-        <p:spPr>
-          <a:xfrm>
-            <a:off x="5735800" y="2337043"/>
-            <a:ext cx="350000" cy="200000"/>
-          </a:xfrm>
-          <a:prstGeom prst="rightArrow">
-            <a:avLst/>
-          </a:prstGeom>
-          <a:solidFill>
-            <a:srgbClr val="E8985E"/>
-          </a:solidFill>
-          <a:ln>
-            <a:noFill/>
-          </a:ln>
-        </p:spPr>
-        <p:txBody>
-          <a:bodyPr wrap="square" lIns="0" tIns="0" rIns="0" bIns="0" rtlCol="0" anchor="ctr"/>
-          <a:lstStyle/>
-          <a:p>
-            <a:pPr marL="0" indent="0">
-              <a:buNone/>
-            </a:pPr>
-            <a:endParaRPr/>
-          </a:p>
-        </p:txBody>
-      </p:sp>
-      <p:sp>
-        <p:nvSpPr>
-          <p:cNvPr id="9" name="Card3"/>
-          <p:cNvSpPr/>
-          <p:nvPr/>
-        </p:nvSpPr>
-        <p:spPr>
-          <a:xfrm>
-            <a:off x="6185800" y="1970843"/>
-            <a:ext cx="2200000" cy="1700000"/>
-          </a:xfrm>
-          <a:prstGeom prst="rect">
-            <a:avLst/>
-          </a:prstGeom>
-          <a:solidFill>
-            <a:srgbClr val="F8F8F8"/>
-          </a:solidFill>
-          <a:ln>
-            <a:solidFill>
-              <a:srgbClr val="DEDEDE"/>
-            </a:solidFill>
-            <a:prstDash val="solid"/>
-            <a:round/>
-          </a:ln>
-        </p:spPr>
-        <p:txBody>
-          <a:bodyPr wrap="square" lIns="91440" tIns="45720" rIns="91440" bIns="45720" rtlCol="0" anchor="t"/>
-          <a:lstStyle/>
-          <a:p>
-            <a:pPr marL="0" indent="0">
-              <a:buNone/>
-            </a:pPr>
-            <a:r>
-              <a:rPr lang="en-US" sz="1100" b="1" dirty="0">
-                <a:solidFill>
-                  <a:srgbClr val="111111"/>
-                </a:solidFill>
-                <a:latin typeface="Arial" pitchFamily="34" charset="0"/>
-                <a:ea typeface="Arial" pitchFamily="34" charset="-122"/>
-                <a:cs typeface="Arial" pitchFamily="34" charset="-120"/>
-              </a:rPr>
-              <a:t>Phase 2: Generate</a:t>
-            </a:r>
-          </a:p>
-          <a:p>
-            <a:pPr marL="0" indent="0">
-              <a:buNone/>
-            </a:pPr>
-            <a:r>
-              <a:rPr lang="en-US" sz="900" dirty="0">
-                <a:solidFill>
-                  <a:srgbClr val="666666"/>
-                </a:solidFill>
-                <a:latin typeface="Arial" pitchFamily="34" charset="0"/>
-                <a:ea typeface="Arial" pitchFamily="34" charset="-122"/>
-                <a:cs typeface="Arial" pitchFamily="34" charset="-120"/>
-              </a:rPr>
-              <a:t>Sonnet crafts personalized output</a:t>
-            </a:r>
-          </a:p>
-          <a:p>
-            <a:pPr marL="0" indent="0">
-              <a:buNone/>
-            </a:pPr>
-            <a:r>
-              <a:rPr lang="en-US" sz="900" b="1" dirty="0">
-                <a:solidFill>
-                  <a:srgbClr val="E8985E"/>
-                </a:solidFill>
-                <a:latin typeface="Arial" pitchFamily="34" charset="0"/>
-                <a:ea typeface="Arial" pitchFamily="34" charset="-122"/>
-                <a:cs typeface="Arial" pitchFamily="34" charset="-120"/>
-              </a:rPr>
-              <a:t>Cost: ~$0.05 per generation</a:t>
-            </a:r>
-          </a:p>
-          <a:p>
-            <a:pPr marL="0" indent="0">
-              <a:buNone/>
-            </a:pPr>
-            <a:r>
-              <a:rPr lang="en-US" sz="900" dirty="0">
-                <a:solidFill>
-                  <a:srgbClr val="666666"/>
-                </a:solidFill>
-                <a:latin typeface="Arial" pitchFamily="34" charset="0"/>
-                <a:ea typeface="Arial" pitchFamily="34" charset="-122"/>
-                <a:cs typeface="Arial" pitchFamily="34" charset="-120"/>
-              </a:rPr>
-              <a:t>Only fires when review finds signal</a:t>
-            </a:r>
-          </a:p>
-        </p:txBody>
-      </p:sp>
-      <p:sp>
-        <p:nvSpPr>
-          <p:cNvPr id="10" name="Bottom Insight"/>
-          <p:cNvSpPr/>
-          <p:nvPr/>
-        </p:nvSpPr>
-        <p:spPr>
-          <a:xfrm>
-            <a:off x="685800" y="4572000"/>
-            <a:ext cx="7772400" cy="274320"/>
-          </a:xfrm>
-          <a:prstGeom prst="rect">
-            <a:avLst/>
-          </a:prstGeom>
-          <a:noFill/>
-          <a:ln/>
-        </p:spPr>
-        <p:txBody>
-          <a:bodyPr wrap="square" lIns="0" tIns="0" rIns="0" bIns="0" rtlCol="0" anchor="ctr"/>
-          <a:lstStyle/>
-          <a:p>
-            <a:pPr marL="0" indent="0" algn="ctr">
-              <a:buNone/>
-            </a:pPr>
-            <a:r>
-              <a:rPr lang="en-US" sz="900" i="1" dirty="0">
-                <a:solidFill>
-                  <a:srgbClr val="E8985E"/>
-                </a:solidFill>
-                <a:latin typeface="Arial" pitchFamily="34" charset="0"/>
-                <a:ea typeface="Arial" pitchFamily="34" charset="-122"/>
-                <a:cs typeface="Arial" pitchFamily="34" charset="-120"/>
-              </a:rPr>
-              <a:t>25x cost difference means we can monitor continuously without burning budget.</a:t>
-            </a:r>
-          </a:p>
-        </p:txBody>
-      </p:sp>
-    </p:spTree>
-  </p:cSld>
-  <p:clrMapOvr>
-    <a:masterClrMapping/>
-  </p:clrMapOvr>
-</p:sld>
-</file>
-
-<file path=ppt/slides/slide11.xml><?xml version="1.0" encoding="utf-8"?>
 <p:sld xmlns:a="http://schemas.openxmlformats.org/drawingml/2006/main" xmlns:r="http://schemas.openxmlformats.org/officeDocument/2006/relationships" xmlns:p="http://schemas.openxmlformats.org/presentationml/2006/main">
   <p:cSld>
     <p:bg>
@@ -5802,7 +5271,7 @@
 </p:sld>
 </file>
 
-<file path=ppt/slides/slide12.xml><?xml version="1.0" encoding="utf-8"?>
+<file path=ppt/slides/slide11.xml><?xml version="1.0" encoding="utf-8"?>
 <p:sld xmlns:a="http://schemas.openxmlformats.org/drawingml/2006/main" xmlns:r="http://schemas.openxmlformats.org/officeDocument/2006/relationships" xmlns:p="http://schemas.openxmlformats.org/presentationml/2006/main">
   <p:cSld>
     <p:spTree>
@@ -6213,7 +5682,7 @@
                 <a:ea typeface="Arial" pitchFamily="34" charset="-122"/>
                 <a:cs typeface="Arial" pitchFamily="34" charset="-120"/>
               </a:rPr>
-              <a:t>context accumulation</a:t>
+              <a:t>knowledge accumulation</a:t>
             </a:r>
             <a:endParaRPr lang="en-US" sz="900" dirty="0"/>
           </a:p>
@@ -7238,7 +6707,7 @@
                 <a:ea typeface="Arial" pitchFamily="34" charset="-122"/>
                 <a:cs typeface="Arial" pitchFamily="34" charset="-120"/>
               </a:rPr>
-              <a:t>The only agent that accumulates cross-platform work context and uses it for autonomous output.</a:t>
+              <a:t>The only platform where persistent agents accumulate cross-platform work knowledge for autonomous output.</a:t>
             </a:r>
             <a:endParaRPr lang="en-US" sz="1200" dirty="0"/>
           </a:p>
@@ -7392,7 +6861,7 @@
                 <a:latin typeface="Arial" pitchFamily="34" charset="0"/>
                 <a:cs typeface="Arial" pitchFamily="34" charset="-120"/>
               </a:rPr>
-              <a:t>Cross-Context</a:t>
+              <a:t>Knowledge</a:t>
             </a:r>
           </a:p>
           <a:p>
@@ -7726,7 +7195,7 @@
 </p:sld>
 </file>
 
-<file path=ppt/slides/slide13.xml><?xml version="1.0" encoding="utf-8"?>
+<file path=ppt/slides/slide12.xml><?xml version="1.0" encoding="utf-8"?>
 <p:sld xmlns:a="http://schemas.openxmlformats.org/drawingml/2006/main" xmlns:r="http://schemas.openxmlformats.org/officeDocument/2006/relationships" xmlns:p="http://schemas.openxmlformats.org/presentationml/2006/main">
   <p:cSld name="Slide 11">
     <p:bg>
@@ -8255,7 +7724,7 @@
                 <a:ea typeface="Arial" pitchFamily="34" charset="-122"/>
                 <a:cs typeface="Arial" pitchFamily="34" charset="-120"/>
               </a:rPr>
-              <a:t>$11.4M</a:t>
+              <a:t>$4.6M</a:t>
             </a:r>
             <a:endParaRPr lang="en-US" sz="2200" dirty="0"/>
           </a:p>
@@ -8294,7 +7763,7 @@
                 <a:ea typeface="Arial" pitchFamily="34" charset="-122"/>
                 <a:cs typeface="Arial" pitchFamily="34" charset="-120"/>
               </a:rPr>
-              <a:t>50K consultants (1% SAM) in first 3 years</a:t>
+              <a:t>20K consultants in first 3 years</a:t>
             </a:r>
             <a:endParaRPr lang="en-US" sz="900" dirty="0"/>
           </a:p>
@@ -8896,7 +8365,7 @@
 </p:sld>
 </file>
 
-<file path=ppt/slides/slide14.xml><?xml version="1.0" encoding="utf-8"?>
+<file path=ppt/slides/slide13.xml><?xml version="1.0" encoding="utf-8"?>
 <p:sld xmlns:a="http://schemas.openxmlformats.org/drawingml/2006/main" xmlns:r="http://schemas.openxmlformats.org/officeDocument/2006/relationships" xmlns:p="http://schemas.openxmlformats.org/presentationml/2006/main">
   <p:cSld name="Slide 14">
     <p:bg>
@@ -8993,7 +8462,7 @@
                 <a:ea typeface="Arial" pitchFamily="34" charset="-122"/>
                 <a:cs typeface="Arial" pitchFamily="34" charset="-120"/>
               </a:rPr>
-              <a:t>Three tiers. Sync frequency is the lever.</a:t>
+              <a:t>Two tiers. Knowledge depth is the lever.</a:t>
             </a:r>
             <a:endParaRPr lang="en-US" sz="2600" dirty="0"/>
           </a:p>
@@ -9242,7 +8711,7 @@
                 <a:ea typeface="Arial" pitchFamily="34" charset="-122"/>
                 <a:cs typeface="Arial" pitchFamily="34" charset="-120"/>
               </a:rPr>
-              <a:t>•  1 source per platform</a:t>
+              <a:t>•  5 sources per platform</a:t>
             </a:r>
             <a:endParaRPr lang="en-US" sz="1000" dirty="0"/>
           </a:p>
@@ -9320,7 +8789,7 @@
                 <a:ea typeface="Arial" pitchFamily="34" charset="-122"/>
                 <a:cs typeface="Arial" pitchFamily="34" charset="-120"/>
               </a:rPr>
-              <a:t>•  20 TP conversations/mo</a:t>
+              <a:t>•  50 orchestrator messages/mo</a:t>
             </a:r>
             <a:endParaRPr lang="en-US" sz="1000" dirty="0"/>
           </a:p>
@@ -9359,7 +8828,7 @@
                 <a:ea typeface="Arial" pitchFamily="34" charset="-122"/>
                 <a:cs typeface="Arial" pitchFamily="34" charset="-120"/>
               </a:rPr>
-              <a:t>•  3 active deliverables</a:t>
+              <a:t>•  2 active agents</a:t>
             </a:r>
             <a:endParaRPr lang="en-US" sz="1000" dirty="0"/>
           </a:p>
@@ -9425,7 +8894,7 @@
                 <a:ea typeface="Arial" pitchFamily="34" charset="-122"/>
                 <a:cs typeface="Arial" pitchFamily="34" charset="-120"/>
               </a:rPr>
-              <a:t>Starter</a:t>
+              <a:t>Pro</a:t>
             </a:r>
             <a:endParaRPr lang="en-US" sz="1400" dirty="0"/>
           </a:p>
@@ -9464,7 +8933,7 @@
                 <a:ea typeface="Arial" pitchFamily="34" charset="-122"/>
                 <a:cs typeface="Arial" pitchFamily="34" charset="-120"/>
               </a:rPr>
-              <a:t>$9</a:t>
+              <a:t>$19</a:t>
             </a:r>
             <a:endParaRPr lang="en-US" sz="2000" dirty="0"/>
           </a:p>
@@ -9608,7 +9077,7 @@
                 <a:ea typeface="Arial" pitchFamily="34" charset="-122"/>
                 <a:cs typeface="Arial" pitchFamily="34" charset="-120"/>
               </a:rPr>
-              <a:t>•  5 sources per platform</a:t>
+              <a:t>•  Unlimited sources</a:t>
             </a:r>
             <a:endParaRPr lang="en-US" sz="1000" dirty="0"/>
           </a:p>
@@ -9647,7 +9116,7 @@
                 <a:ea typeface="Arial" pitchFamily="34" charset="-122"/>
                 <a:cs typeface="Arial" pitchFamily="34" charset="-120"/>
               </a:rPr>
-              <a:t>•  Sync every 6 hours</a:t>
+              <a:t>•  Hourly sync</a:t>
             </a:r>
             <a:endParaRPr lang="en-US" sz="1000" dirty="0"/>
           </a:p>
@@ -9686,7 +9155,7 @@
                 <a:ea typeface="Arial" pitchFamily="34" charset="-122"/>
                 <a:cs typeface="Arial" pitchFamily="34" charset="-120"/>
               </a:rPr>
-              <a:t>•  100 TP conversations/mo</a:t>
+              <a:t>•  Unlimited orchestrator messages</a:t>
             </a:r>
             <a:endParaRPr lang="en-US" sz="1000" dirty="0"/>
           </a:p>
@@ -9725,7 +9194,7 @@
                 <a:ea typeface="Arial" pitchFamily="34" charset="-122"/>
                 <a:cs typeface="Arial" pitchFamily="34" charset="-120"/>
               </a:rPr>
-              <a:t>•  10 active deliverables</a:t>
+              <a:t>•  Unlimited agents</a:t>
             </a:r>
             <a:endParaRPr lang="en-US" sz="1000" dirty="0"/>
           </a:p>
@@ -9791,7 +9260,7 @@
                 <a:ea typeface="Arial" pitchFamily="34" charset="-122"/>
                 <a:cs typeface="Arial" pitchFamily="34" charset="-120"/>
               </a:rPr>
-              <a:t>Pro</a:t>
+              <a:t>Enterprise</a:t>
             </a:r>
             <a:endParaRPr lang="en-US" sz="1400" dirty="0"/>
           </a:p>
@@ -9830,7 +9299,7 @@
                 <a:ea typeface="Arial" pitchFamily="34" charset="-122"/>
                 <a:cs typeface="Arial" pitchFamily="34" charset="-120"/>
               </a:rPr>
-              <a:t>$19</a:t>
+              <a:t>TBD</a:t>
             </a:r>
             <a:endParaRPr lang="en-US" sz="2000" dirty="0"/>
           </a:p>
@@ -9935,7 +9404,7 @@
                 <a:ea typeface="Arial" pitchFamily="34" charset="-122"/>
                 <a:cs typeface="Arial" pitchFamily="34" charset="-120"/>
               </a:rPr>
-              <a:t>•  4 platforms connected</a:t>
+              <a:t>•  Everything in Pro</a:t>
             </a:r>
             <a:endParaRPr lang="en-US" sz="1000" dirty="0"/>
           </a:p>
@@ -9974,7 +9443,7 @@
                 <a:ea typeface="Arial" pitchFamily="34" charset="-122"/>
                 <a:cs typeface="Arial" pitchFamily="34" charset="-120"/>
               </a:rPr>
-              <a:t>•  20+ sources per platform</a:t>
+              <a:t>•  Team workspaces</a:t>
             </a:r>
             <a:endParaRPr lang="en-US" sz="1000" dirty="0"/>
           </a:p>
@@ -10013,7 +9482,7 @@
                 <a:ea typeface="Arial" pitchFamily="34" charset="-122"/>
                 <a:cs typeface="Arial" pitchFamily="34" charset="-120"/>
               </a:rPr>
-              <a:t>•  Hourly sync</a:t>
+              <a:t>•  Priority support</a:t>
             </a:r>
             <a:endParaRPr lang="en-US" sz="1000" dirty="0"/>
           </a:p>
@@ -10052,7 +9521,7 @@
                 <a:ea typeface="Arial" pitchFamily="34" charset="-122"/>
                 <a:cs typeface="Arial" pitchFamily="34" charset="-120"/>
               </a:rPr>
-              <a:t>•  Unlimited TP conversations</a:t>
+              <a:t>•  Custom integrations</a:t>
             </a:r>
             <a:endParaRPr lang="en-US" sz="1000" dirty="0"/>
           </a:p>
@@ -10091,7 +9560,7 @@
                 <a:ea typeface="Arial" pitchFamily="34" charset="-122"/>
                 <a:cs typeface="Arial" pitchFamily="34" charset="-120"/>
               </a:rPr>
-              <a:t>•  Unlimited deliverables</a:t>
+              <a:t>•  Agent-to-agent protocol</a:t>
             </a:r>
             <a:endParaRPr lang="en-US" sz="1000" dirty="0"/>
           </a:p>
@@ -10130,7 +9599,7 @@
                 <a:ea typeface="Arial" pitchFamily="34" charset="-122"/>
                 <a:cs typeface="Arial" pitchFamily="34" charset="-120"/>
               </a:rPr>
-              <a:t>Unit economics: Target 70%+ gross margin at scale. Batched sync and cached context reduce per-user API cost as context accumulates.</a:t>
+              <a:t>Unit economics: Target 70%+ gross margin at scale. Batched sync and cached knowledge reduce per-user API cost as context accumulates.</a:t>
             </a:r>
             <a:endParaRPr lang="en-US" sz="900" dirty="0"/>
           </a:p>
@@ -10169,7 +9638,7 @@
                 <a:ea typeface="Arial" pitchFamily="34" charset="-122"/>
                 <a:cs typeface="Arial" pitchFamily="34" charset="-120"/>
               </a:rPr>
-              <a:t>Yearly plans: 2 months free (17% off). Starter $90/yr, Pro $190/yr.</a:t>
+              <a:t>Yearly plan: 2 months free (17% off). Pro $190/yr.</a:t>
             </a:r>
             <a:endParaRPr lang="en-US" sz="900" dirty="0"/>
           </a:p>
@@ -10183,7 +9652,7 @@
 </p:sld>
 </file>
 
-<file path=ppt/slides/slide15.xml><?xml version="1.0" encoding="utf-8"?>
+<file path=ppt/slides/slide14.xml><?xml version="1.0" encoding="utf-8"?>
 <p:sld xmlns:a="http://schemas.openxmlformats.org/drawingml/2006/main" xmlns:r="http://schemas.openxmlformats.org/officeDocument/2006/relationships" xmlns:p="http://schemas.openxmlformats.org/presentationml/2006/main">
   <p:cSld>
     <p:bg>
@@ -10544,7 +10013,7 @@
                 </a:solidFill>
                 <a:latin typeface="Arial" pitchFamily="34" charset="0"/>
               </a:rPr>
-              <a:t>Cross-platform context is what makes deliverables intelligent</a:t>
+              <a:t>Cross-platform knowledge is what makes agents intelligent</a:t>
             </a:r>
           </a:p>
         </p:txBody>
@@ -10887,7 +10356,7 @@
 </p:sld>
 </file>
 
-<file path=ppt/slides/slide16.xml><?xml version="1.0" encoding="utf-8"?>
+<file path=ppt/slides/slide15.xml><?xml version="1.0" encoding="utf-8"?>
 <p:sld xmlns:a="http://schemas.openxmlformats.org/drawingml/2006/main" xmlns:r="http://schemas.openxmlformats.org/officeDocument/2006/relationships" xmlns:p="http://schemas.openxmlformats.org/presentationml/2006/main">
   <p:cSld name="Slide 17">
     <p:bg>
@@ -10984,7 +10453,7 @@
                 <a:ea typeface="Arial" pitchFamily="34" charset="-122"/>
                 <a:cs typeface="Arial" pitchFamily="34" charset="-120"/>
               </a:rPr>
-              <a:t>$500K–$1M seed round at $5–10M valuation.</a:t>
+              <a:t>$500K at $5M post-money valuation.</a:t>
             </a:r>
             <a:endParaRPr lang="en-US" sz="2600" dirty="0"/>
           </a:p>
@@ -11140,7 +10609,7 @@
                 <a:ea typeface="Arial" pitchFamily="34" charset="-122"/>
                 <a:cs typeface="Arial" pitchFamily="34" charset="-120"/>
               </a:rPr>
-              <a:t>→  12–18 months runway</a:t>
+              <a:t>→  12 months runway</a:t>
             </a:r>
             <a:endParaRPr lang="en-US" sz="1000" dirty="0"/>
           </a:p>
@@ -11895,7 +11364,7 @@
 </p:sld>
 </file>
 
-<file path=ppt/slides/slide17.xml><?xml version="1.0" encoding="utf-8"?>
+<file path=ppt/slides/slide16.xml><?xml version="1.0" encoding="utf-8"?>
 <p:sld xmlns:a="http://schemas.openxmlformats.org/drawingml/2006/main" xmlns:r="http://schemas.openxmlformats.org/officeDocument/2006/relationships" xmlns:p="http://schemas.openxmlformats.org/presentationml/2006/main">
   <p:cSld>
     <p:spTree>
@@ -12034,7 +11503,7 @@
 </p:sld>
 </file>
 
-<file path=ppt/slides/slide18.xml><?xml version="1.0" encoding="utf-8"?>
+<file path=ppt/slides/slide17.xml><?xml version="1.0" encoding="utf-8"?>
 <p:sld xmlns:a="http://schemas.openxmlformats.org/drawingml/2006/main" xmlns:r="http://schemas.openxmlformats.org/officeDocument/2006/relationships" xmlns:p="http://schemas.openxmlformats.org/presentationml/2006/main">
   <p:cSld>
     <p:spTree>
@@ -12346,7 +11815,7 @@
                 </a:solidFill>
                 <a:latin typeface="Arial" pitchFamily="34" charset="0"/>
               </a:rPr>
-              <a:t>), four platform integrations, unified agent architecture documented across 90+ Architecture Decision Records.</a:t>
+              <a:t>), four platform integrations, unified agent architecture documented across 115+ Architecture Decision Records.</a:t>
             </a:r>
           </a:p>
           <a:p>
@@ -12452,6 +11921,651 @@
         </p:txBody>
       </p:sp>
     </p:spTree>
+  </p:cSld>
+  <p:clrMapOvr>
+    <a:masterClrMapping/>
+  </p:clrMapOvr>
+</p:sld>
+</file>
+
+<file path=ppt/slides/slide18.xml><?xml version="1.0" encoding="utf-8"?>
+<p:sld xmlns:a="http://schemas.openxmlformats.org/drawingml/2006/main" xmlns:r="http://schemas.openxmlformats.org/officeDocument/2006/relationships" xmlns:p="http://schemas.openxmlformats.org/presentationml/2006/main">
+  <p:cSld>
+    <p:spTree>
+      <p:nvGrpSpPr>
+        <p:cNvPr id="1" name="Slide 9"/>
+        <p:cNvGrpSpPr/>
+        <p:nvPr/>
+      </p:nvGrpSpPr>
+      <p:grpSpPr>
+        <a:xfrm>
+          <a:off x="0" y="0"/>
+          <a:ext cx="9144000" cy="5143500"/>
+          <a:chOff x="0" y="0"/>
+          <a:chExt cx="9144000" cy="5143500"/>
+        </a:xfrm>
+      </p:grpSpPr>
+      <p:sp>
+        <p:nvSpPr>
+          <p:cNvPr id="2" name="Section Label"/>
+          <p:cNvSpPr/>
+          <p:nvPr/>
+        </p:nvSpPr>
+        <p:spPr>
+          <a:xfrm>
+            <a:off x="685800" y="457200"/>
+            <a:ext cx="2000000" cy="274320"/>
+          </a:xfrm>
+          <a:prstGeom prst="rect">
+            <a:avLst/>
+          </a:prstGeom>
+          <a:noFill/>
+          <a:ln/>
+        </p:spPr>
+        <p:txBody>
+          <a:bodyPr wrap="square" lIns="0" tIns="0" rIns="0" bIns="0" rtlCol="0" anchor="ctr"/>
+          <a:lstStyle/>
+          <a:p>
+            <a:pPr marL="0" indent="0">
+              <a:buNone/>
+            </a:pPr>
+            <a:r>
+              <a:rPr lang="en-US" sz="1100" b="1" dirty="0">
+                <a:solidFill>
+                  <a:srgbClr val="E8985E"/>
+                </a:solidFill>
+                <a:latin typeface="Arial" pitchFamily="34" charset="0"/>
+                <a:ea typeface="Arial" pitchFamily="34" charset="-122"/>
+                <a:cs typeface="Arial" pitchFamily="34" charset="-120"/>
+              </a:rPr>
+              <a:t>Product</a:t>
+            </a:r>
+          </a:p>
+        </p:txBody>
+      </p:sp>
+      <p:sp>
+        <p:nvSpPr>
+          <p:cNvPr id="3" name="Title"/>
+          <p:cNvSpPr/>
+          <p:nvPr/>
+        </p:nvSpPr>
+        <p:spPr>
+          <a:xfrm>
+            <a:off x="685800" y="777240"/>
+            <a:ext cx="7772400" cy="457200"/>
+          </a:xfrm>
+          <a:prstGeom prst="rect">
+            <a:avLst/>
+          </a:prstGeom>
+          <a:noFill/>
+          <a:ln/>
+        </p:spPr>
+        <p:txBody>
+          <a:bodyPr wrap="square" lIns="0" tIns="0" rIns="0" bIns="0" rtlCol="0" anchor="ctr"/>
+          <a:lstStyle/>
+          <a:p>
+            <a:pPr marL="0" indent="0">
+              <a:buNone/>
+            </a:pPr>
+            <a:r>
+              <a:rPr lang="en-US" sz="2400" b="1" dirty="0">
+                <a:solidFill>
+                  <a:srgbClr val="111111"/>
+                </a:solidFill>
+                <a:latin typeface="Arial" pitchFamily="34" charset="0"/>
+                <a:ea typeface="Arial" pitchFamily="34" charset="-122"/>
+                <a:cs typeface="Arial" pitchFamily="34" charset="-120"/>
+              </a:rPr>
+              <a:t>What YARNNN Replaces</a:t>
+            </a:r>
+          </a:p>
+        </p:txBody>
+      </p:sp>
+      <p:sp>
+        <p:nvSpPr>
+          <p:cNvPr id="4" name="Subtitle"/>
+          <p:cNvSpPr/>
+          <p:nvPr/>
+        </p:nvSpPr>
+        <p:spPr>
+          <a:xfrm>
+            <a:off x="685800" y="1371600"/>
+            <a:ext cx="7772400" cy="274320"/>
+          </a:xfrm>
+          <a:prstGeom prst="rect">
+            <a:avLst/>
+          </a:prstGeom>
+          <a:noFill/>
+          <a:ln/>
+        </p:spPr>
+        <p:txBody>
+          <a:bodyPr wrap="square" lIns="0" tIns="0" rIns="0" bIns="0" rtlCol="0" anchor="ctr"/>
+          <a:lstStyle/>
+          <a:p>
+            <a:pPr marL="0" indent="0">
+              <a:buNone/>
+            </a:pPr>
+            <a:r>
+              <a:rPr lang="en-US" sz="1100" dirty="0">
+                <a:solidFill>
+                  <a:srgbClr val="666666"/>
+                </a:solidFill>
+                <a:latin typeface="Arial" pitchFamily="34" charset="0"/>
+                <a:ea typeface="Arial" pitchFamily="34" charset="-122"/>
+                <a:cs typeface="Arial" pitchFamily="34" charset="-120"/>
+              </a:rPr>
+              <a:t>Three real workflows. Before: manual, fragmented, time-consuming. After: autonomous, cross-platform, improving.</a:t>
+            </a:r>
+          </a:p>
+        </p:txBody>
+      </p:sp>
+      <p:sp>
+        <p:nvSpPr>
+          <p:cNvPr id="5" name="Card1"/>
+          <p:cNvSpPr/>
+          <p:nvPr/>
+        </p:nvSpPr>
+        <p:spPr>
+          <a:xfrm>
+            <a:off x="685800" y="1970843"/>
+            <a:ext cx="2200000" cy="2263806"/>
+          </a:xfrm>
+          <a:prstGeom prst="rect">
+            <a:avLst/>
+          </a:prstGeom>
+          <a:solidFill>
+            <a:srgbClr val="F8F8F8"/>
+          </a:solidFill>
+          <a:ln>
+            <a:solidFill>
+              <a:srgbClr val="DEDEDE"/>
+            </a:solidFill>
+            <a:prstDash val="solid"/>
+            <a:round/>
+          </a:ln>
+        </p:spPr>
+        <p:txBody>
+          <a:bodyPr wrap="square" lIns="91440" tIns="45720" rIns="91440" bIns="45720" rtlCol="0" anchor="t"/>
+          <a:lstStyle/>
+          <a:p>
+            <a:pPr marL="0" indent="0">
+              <a:buNone/>
+            </a:pPr>
+            <a:r>
+              <a:rPr lang="en-US" sz="1100" b="1" dirty="0">
+                <a:solidFill>
+                  <a:srgbClr val="111111"/>
+                </a:solidFill>
+                <a:latin typeface="Arial" pitchFamily="34" charset="0"/>
+                <a:ea typeface="Arial" pitchFamily="34" charset="-122"/>
+                <a:cs typeface="Arial" pitchFamily="34" charset="-120"/>
+              </a:rPr>
+              <a:t>Before: Monday Catchup</a:t>
+            </a:r>
+          </a:p>
+          <a:p>
+            <a:pPr marL="0" indent="0">
+              <a:buNone/>
+            </a:pPr>
+            <a:endParaRPr lang="en-US" sz="900" dirty="0">
+              <a:solidFill>
+                <a:srgbClr val="666666"/>
+              </a:solidFill>
+              <a:latin typeface="Arial" pitchFamily="34" charset="0"/>
+              <a:ea typeface="Arial" pitchFamily="34" charset="-122"/>
+              <a:cs typeface="Arial" pitchFamily="34" charset="-120"/>
+            </a:endParaRPr>
+          </a:p>
+          <a:p>
+            <a:pPr marL="0" indent="0">
+              <a:buNone/>
+            </a:pPr>
+            <a:r>
+              <a:rPr lang="en-US" sz="900" dirty="0">
+                <a:solidFill>
+                  <a:srgbClr val="666666"/>
+                </a:solidFill>
+                <a:latin typeface="Arial" pitchFamily="34" charset="0"/>
+                <a:ea typeface="Arial" pitchFamily="34" charset="-122"/>
+                <a:cs typeface="Arial" pitchFamily="34" charset="-120"/>
+              </a:rPr>
+              <a:t>Open Slack. Scroll 14 channels. Open Gmail. Scan 40 emails. 45 minutes gone.</a:t>
+            </a:r>
+          </a:p>
+          <a:p>
+            <a:pPr marL="0" indent="0">
+              <a:buNone/>
+            </a:pPr>
+            <a:endParaRPr lang="en-US" sz="900" b="1" dirty="0">
+              <a:solidFill>
+                <a:srgbClr val="E8985E"/>
+              </a:solidFill>
+              <a:latin typeface="Arial" pitchFamily="34" charset="0"/>
+              <a:ea typeface="Arial" pitchFamily="34" charset="-122"/>
+              <a:cs typeface="Arial" pitchFamily="34" charset="-120"/>
+            </a:endParaRPr>
+          </a:p>
+          <a:p>
+            <a:pPr marL="0" indent="0">
+              <a:buNone/>
+            </a:pPr>
+            <a:endParaRPr lang="en-US" sz="900" b="1" dirty="0">
+              <a:solidFill>
+                <a:srgbClr val="E8985E"/>
+              </a:solidFill>
+              <a:latin typeface="Arial" pitchFamily="34" charset="0"/>
+              <a:ea typeface="Arial" pitchFamily="34" charset="-122"/>
+              <a:cs typeface="Arial" pitchFamily="34" charset="-120"/>
+            </a:endParaRPr>
+          </a:p>
+          <a:p>
+            <a:pPr marL="0" indent="0">
+              <a:buNone/>
+            </a:pPr>
+            <a:r>
+              <a:rPr lang="en-US" sz="900" b="1" dirty="0">
+                <a:solidFill>
+                  <a:srgbClr val="E8985E"/>
+                </a:solidFill>
+                <a:latin typeface="Arial" pitchFamily="34" charset="0"/>
+                <a:ea typeface="Arial" pitchFamily="34" charset="-122"/>
+                <a:cs typeface="Arial" pitchFamily="34" charset="-120"/>
+              </a:rPr>
+              <a:t>AFTER: Recap Agent</a:t>
+            </a:r>
+          </a:p>
+          <a:p>
+            <a:pPr marL="0" indent="0">
+              <a:buNone/>
+            </a:pPr>
+            <a:r>
+              <a:rPr lang="en-US" sz="900" dirty="0">
+                <a:solidFill>
+                  <a:srgbClr val="666666"/>
+                </a:solidFill>
+                <a:latin typeface="Arial" pitchFamily="34" charset="0"/>
+                <a:ea typeface="Arial" pitchFamily="34" charset="-122"/>
+                <a:cs typeface="Arial" pitchFamily="34" charset="-120"/>
+              </a:rPr>
+              <a:t>One brief. All platforms. Waiting at 8am. 0 minutes of your time.</a:t>
+            </a:r>
+          </a:p>
+        </p:txBody>
+      </p:sp>
+      <p:sp>
+        <p:nvSpPr>
+          <p:cNvPr id="6" name="Arrow1"/>
+          <p:cNvSpPr/>
+          <p:nvPr/>
+        </p:nvSpPr>
+        <p:spPr>
+          <a:xfrm>
+            <a:off x="2985800" y="2337043"/>
+            <a:ext cx="350000" cy="200000"/>
+          </a:xfrm>
+          <a:prstGeom prst="rightArrow">
+            <a:avLst/>
+          </a:prstGeom>
+          <a:solidFill>
+            <a:srgbClr val="E8985E"/>
+          </a:solidFill>
+          <a:ln>
+            <a:noFill/>
+          </a:ln>
+        </p:spPr>
+        <p:txBody>
+          <a:bodyPr wrap="square" lIns="0" tIns="0" rIns="0" bIns="0" rtlCol="0" anchor="ctr"/>
+          <a:lstStyle/>
+          <a:p>
+            <a:pPr marL="0" indent="0">
+              <a:buNone/>
+            </a:pPr>
+            <a:endParaRPr/>
+          </a:p>
+        </p:txBody>
+      </p:sp>
+      <p:sp>
+        <p:nvSpPr>
+          <p:cNvPr id="7" name="Card2"/>
+          <p:cNvSpPr/>
+          <p:nvPr/>
+        </p:nvSpPr>
+        <p:spPr>
+          <a:xfrm>
+            <a:off x="3435800" y="1970843"/>
+            <a:ext cx="2200000" cy="2263806"/>
+          </a:xfrm>
+          <a:prstGeom prst="rect">
+            <a:avLst/>
+          </a:prstGeom>
+          <a:solidFill>
+            <a:srgbClr val="E8985E"/>
+          </a:solidFill>
+          <a:ln>
+            <a:solidFill>
+              <a:srgbClr val="E8985E"/>
+            </a:solidFill>
+            <a:prstDash val="solid"/>
+            <a:round/>
+          </a:ln>
+        </p:spPr>
+        <p:txBody>
+          <a:bodyPr wrap="square" lIns="91440" tIns="45720" rIns="91440" bIns="45720" rtlCol="0" anchor="t"/>
+          <a:lstStyle/>
+          <a:p>
+            <a:pPr marL="0" indent="0">
+              <a:buNone/>
+            </a:pPr>
+            <a:r>
+              <a:rPr lang="en-US" sz="1100" b="1" dirty="0">
+                <a:solidFill>
+                  <a:srgbClr val="FFFFFF"/>
+                </a:solidFill>
+                <a:latin typeface="Arial" pitchFamily="34" charset="0"/>
+                <a:ea typeface="Arial" pitchFamily="34" charset="-122"/>
+                <a:cs typeface="Arial" pitchFamily="34" charset="-120"/>
+              </a:rPr>
+              <a:t>Before: Client Status Update</a:t>
+            </a:r>
+          </a:p>
+          <a:p>
+            <a:pPr marL="0" indent="0">
+              <a:buNone/>
+            </a:pPr>
+            <a:endParaRPr lang="en-US" sz="900" i="1" dirty="0">
+              <a:solidFill>
+                <a:srgbClr val="FFFFFF"/>
+              </a:solidFill>
+              <a:latin typeface="Arial" pitchFamily="34" charset="0"/>
+              <a:ea typeface="Arial" pitchFamily="34" charset="-122"/>
+              <a:cs typeface="Arial" pitchFamily="34" charset="-120"/>
+            </a:endParaRPr>
+          </a:p>
+          <a:p>
+            <a:pPr marL="0" indent="0">
+              <a:buNone/>
+            </a:pPr>
+            <a:r>
+              <a:rPr lang="en-US" sz="900" i="1" dirty="0">
+                <a:solidFill>
+                  <a:srgbClr val="FFFFFF"/>
+                </a:solidFill>
+                <a:latin typeface="Arial" pitchFamily="34" charset="0"/>
+                <a:ea typeface="Arial" pitchFamily="34" charset="-122"/>
+                <a:cs typeface="Arial" pitchFamily="34" charset="-120"/>
+              </a:rPr>
+              <a:t>Copy from Slack. Paste into doc. Check Gmail. Rewrite for client tone. 2 hours, every week.</a:t>
+            </a:r>
+          </a:p>
+          <a:p>
+            <a:pPr marL="0" indent="0">
+              <a:buNone/>
+            </a:pPr>
+            <a:endParaRPr lang="en-US" sz="900" dirty="0">
+              <a:solidFill>
+                <a:srgbClr val="FFFFFF"/>
+              </a:solidFill>
+              <a:latin typeface="Arial" pitchFamily="34" charset="0"/>
+              <a:ea typeface="Arial" pitchFamily="34" charset="-122"/>
+              <a:cs typeface="Arial" pitchFamily="34" charset="-120"/>
+            </a:endParaRPr>
+          </a:p>
+          <a:p>
+            <a:pPr marL="0" indent="0">
+              <a:buNone/>
+            </a:pPr>
+            <a:endParaRPr lang="en-US" sz="900" b="1" dirty="0">
+              <a:solidFill>
+                <a:srgbClr val="FFFFFF"/>
+              </a:solidFill>
+              <a:latin typeface="Arial" pitchFamily="34" charset="0"/>
+              <a:ea typeface="Arial" pitchFamily="34" charset="-122"/>
+              <a:cs typeface="Arial" pitchFamily="34" charset="-120"/>
+            </a:endParaRPr>
+          </a:p>
+          <a:p>
+            <a:pPr marL="0" indent="0">
+              <a:buNone/>
+            </a:pPr>
+            <a:r>
+              <a:rPr lang="en-US" sz="900" b="1" dirty="0">
+                <a:solidFill>
+                  <a:srgbClr val="FFFFFF"/>
+                </a:solidFill>
+                <a:latin typeface="Arial" pitchFamily="34" charset="0"/>
+                <a:ea typeface="Arial" pitchFamily="34" charset="-122"/>
+                <a:cs typeface="Arial" pitchFamily="34" charset="-120"/>
+              </a:rPr>
+              <a:t>AFTER: Status Agent</a:t>
+            </a:r>
+          </a:p>
+          <a:p>
+            <a:pPr marL="0" indent="0">
+              <a:buNone/>
+            </a:pPr>
+            <a:r>
+              <a:rPr lang="en-US" sz="900" dirty="0">
+                <a:solidFill>
+                  <a:srgbClr val="FFFFFF"/>
+                </a:solidFill>
+                <a:latin typeface="Arial" pitchFamily="34" charset="0"/>
+                <a:ea typeface="Arial" pitchFamily="34" charset="-122"/>
+                <a:cs typeface="Arial" pitchFamily="34" charset="-120"/>
+              </a:rPr>
+              <a:t>Pulls from all platforms. 12 weeks of accumulated context. Draft arrives Friday 5pm.</a:t>
+            </a:r>
+          </a:p>
+        </p:txBody>
+      </p:sp>
+      <p:sp>
+        <p:nvSpPr>
+          <p:cNvPr id="8" name="Arrow2"/>
+          <p:cNvSpPr/>
+          <p:nvPr/>
+        </p:nvSpPr>
+        <p:spPr>
+          <a:xfrm>
+            <a:off x="5735800" y="2337043"/>
+            <a:ext cx="350000" cy="200000"/>
+          </a:xfrm>
+          <a:prstGeom prst="rightArrow">
+            <a:avLst/>
+          </a:prstGeom>
+          <a:solidFill>
+            <a:srgbClr val="E8985E"/>
+          </a:solidFill>
+          <a:ln>
+            <a:noFill/>
+          </a:ln>
+        </p:spPr>
+        <p:txBody>
+          <a:bodyPr wrap="square" lIns="0" tIns="0" rIns="0" bIns="0" rtlCol="0" anchor="ctr"/>
+          <a:lstStyle/>
+          <a:p>
+            <a:pPr marL="0" indent="0">
+              <a:buNone/>
+            </a:pPr>
+            <a:endParaRPr/>
+          </a:p>
+        </p:txBody>
+      </p:sp>
+      <p:sp>
+        <p:nvSpPr>
+          <p:cNvPr id="9" name="Card3"/>
+          <p:cNvSpPr/>
+          <p:nvPr/>
+        </p:nvSpPr>
+        <p:spPr>
+          <a:xfrm>
+            <a:off x="6185800" y="1970843"/>
+            <a:ext cx="2200000" cy="2263806"/>
+          </a:xfrm>
+          <a:prstGeom prst="rect">
+            <a:avLst/>
+          </a:prstGeom>
+          <a:solidFill>
+            <a:srgbClr val="F8F8F8"/>
+          </a:solidFill>
+          <a:ln>
+            <a:solidFill>
+              <a:srgbClr val="DEDEDE"/>
+            </a:solidFill>
+            <a:prstDash val="solid"/>
+            <a:round/>
+          </a:ln>
+        </p:spPr>
+        <p:txBody>
+          <a:bodyPr wrap="square" lIns="91440" tIns="45720" rIns="91440" bIns="45720" rtlCol="0" anchor="t"/>
+          <a:lstStyle/>
+          <a:p>
+            <a:pPr marL="0" indent="0">
+              <a:buNone/>
+            </a:pPr>
+            <a:r>
+              <a:rPr lang="en-US" sz="1100" b="1" dirty="0">
+                <a:solidFill>
+                  <a:srgbClr val="111111"/>
+                </a:solidFill>
+                <a:latin typeface="Arial" pitchFamily="34" charset="0"/>
+                <a:ea typeface="Arial" pitchFamily="34" charset="-122"/>
+                <a:cs typeface="Arial" pitchFamily="34" charset="-120"/>
+              </a:rPr>
+              <a:t>Before: Meeting Prep</a:t>
+            </a:r>
+          </a:p>
+          <a:p>
+            <a:pPr marL="0" indent="0">
+              <a:buNone/>
+            </a:pPr>
+            <a:endParaRPr lang="en-US" sz="900" dirty="0">
+              <a:solidFill>
+                <a:srgbClr val="666666"/>
+              </a:solidFill>
+              <a:latin typeface="Arial" pitchFamily="34" charset="0"/>
+              <a:ea typeface="Arial" pitchFamily="34" charset="-122"/>
+              <a:cs typeface="Arial" pitchFamily="34" charset="-120"/>
+            </a:endParaRPr>
+          </a:p>
+          <a:p>
+            <a:pPr marL="0" indent="0">
+              <a:buNone/>
+            </a:pPr>
+            <a:r>
+              <a:rPr lang="en-US" sz="900" dirty="0">
+                <a:solidFill>
+                  <a:srgbClr val="666666"/>
+                </a:solidFill>
+                <a:latin typeface="Arial" pitchFamily="34" charset="0"/>
+                <a:ea typeface="Arial" pitchFamily="34" charset="-122"/>
+                <a:cs typeface="Arial" pitchFamily="34" charset="-120"/>
+              </a:rPr>
+              <a:t>Search Slack. Search Gmail. Check LinkedIn. Skim Notion. Scramble 10 minutes before the call.</a:t>
+            </a:r>
+          </a:p>
+          <a:p>
+            <a:pPr marL="0" indent="0">
+              <a:buNone/>
+            </a:pPr>
+            <a:endParaRPr lang="en-US" sz="900" dirty="0">
+              <a:solidFill>
+                <a:srgbClr val="666666"/>
+              </a:solidFill>
+              <a:latin typeface="Arial" pitchFamily="34" charset="0"/>
+              <a:ea typeface="Arial" pitchFamily="34" charset="-122"/>
+              <a:cs typeface="Arial" pitchFamily="34" charset="-120"/>
+            </a:endParaRPr>
+          </a:p>
+          <a:p>
+            <a:pPr marL="0" indent="0">
+              <a:buNone/>
+            </a:pPr>
+            <a:endParaRPr lang="en-US" sz="900" b="1" dirty="0">
+              <a:solidFill>
+                <a:srgbClr val="E8985E"/>
+              </a:solidFill>
+              <a:latin typeface="Arial" pitchFamily="34" charset="0"/>
+              <a:ea typeface="Arial" pitchFamily="34" charset="-122"/>
+              <a:cs typeface="Arial" pitchFamily="34" charset="-120"/>
+            </a:endParaRPr>
+          </a:p>
+          <a:p>
+            <a:pPr marL="0" indent="0">
+              <a:buNone/>
+            </a:pPr>
+            <a:r>
+              <a:rPr lang="en-US" sz="900" b="1" dirty="0">
+                <a:solidFill>
+                  <a:srgbClr val="E8985E"/>
+                </a:solidFill>
+                <a:latin typeface="Arial" pitchFamily="34" charset="0"/>
+                <a:ea typeface="Arial" pitchFamily="34" charset="-122"/>
+                <a:cs typeface="Arial" pitchFamily="34" charset="-120"/>
+              </a:rPr>
+              <a:t>AFTER: Meeting Prep Agent</a:t>
+            </a:r>
+          </a:p>
+          <a:p>
+            <a:pPr marL="0" indent="0">
+              <a:buNone/>
+            </a:pPr>
+            <a:r>
+              <a:rPr lang="en-US" sz="900" dirty="0">
+                <a:solidFill>
+                  <a:srgbClr val="666666"/>
+                </a:solidFill>
+                <a:latin typeface="Arial" pitchFamily="34" charset="0"/>
+                <a:ea typeface="Arial" pitchFamily="34" charset="-122"/>
+                <a:cs typeface="Arial" pitchFamily="34" charset="-120"/>
+              </a:rPr>
+              <a:t>Brief auto-generated from calendar. Full context. Delivered 30 min before. Every time.</a:t>
+            </a:r>
+          </a:p>
+        </p:txBody>
+      </p:sp>
+      <p:sp>
+        <p:nvSpPr>
+          <p:cNvPr id="10" name="Bottom Insight"/>
+          <p:cNvSpPr/>
+          <p:nvPr/>
+        </p:nvSpPr>
+        <p:spPr>
+          <a:xfrm>
+            <a:off x="685800" y="4572000"/>
+            <a:ext cx="7772400" cy="274320"/>
+          </a:xfrm>
+          <a:prstGeom prst="rect">
+            <a:avLst/>
+          </a:prstGeom>
+          <a:noFill/>
+          <a:ln/>
+        </p:spPr>
+        <p:txBody>
+          <a:bodyPr wrap="square" lIns="0" tIns="0" rIns="0" bIns="0" rtlCol="0" anchor="ctr"/>
+          <a:lstStyle/>
+          <a:p>
+            <a:pPr marL="0" indent="0" algn="ctr">
+              <a:buNone/>
+            </a:pPr>
+            <a:r>
+              <a:rPr lang="en-US" sz="900" i="1" dirty="0">
+                <a:solidFill>
+                  <a:srgbClr val="E8985E"/>
+                </a:solidFill>
+                <a:latin typeface="Arial" pitchFamily="34" charset="0"/>
+                <a:ea typeface="Arial" pitchFamily="34" charset="-122"/>
+                <a:cs typeface="Arial" pitchFamily="34" charset="-120"/>
+              </a:rPr>
+              <a:t>Every agent gets better with tenure. The 12th weekly update needs zero corrections.</a:t>
+            </a:r>
+          </a:p>
+        </p:txBody>
+      </p:sp>
+    </p:spTree>
+    <p:extLst>
+      <p:ext uri="{BB962C8B-B14F-4D97-AF65-F5344CB8AC3E}">
+        <p14:creationId xmlns:p14="http://schemas.microsoft.com/office/powerpoint/2010/main" val="4186313045"/>
+      </p:ext>
+    </p:extLst>
   </p:cSld>
   <p:clrMapOvr>
     <a:masterClrMapping/>
@@ -12646,7 +12760,7 @@
                 <a:ea typeface="Arial" pitchFamily="34" charset="-122"/>
                 <a:cs typeface="Arial" pitchFamily="34" charset="-120"/>
               </a:rPr>
-              <a:t>But every platform cycle looks that way — until it doesn’t.</a:t>
+              <a:t>Every platform cycle looks that way — until it doesn’t.</a:t>
             </a:r>
             <a:endParaRPr lang="en-US" sz="2000" b="1" dirty="0"/>
           </a:p>
@@ -14062,6 +14176,36 @@
           <a:xfrm>
             <a:off x="1569715" y="1819923"/>
             <a:ext cx="946261" cy="946261"/>
+          </a:xfrm>
+          <a:prstGeom prst="rect">
+            <a:avLst/>
+          </a:prstGeom>
+        </p:spPr>
+      </p:pic>
+      <p:pic>
+        <p:nvPicPr>
+          <p:cNvPr id="3" name="Picture 2">
+            <a:extLst>
+              <a:ext uri="{FF2B5EF4-FFF2-40B4-BE49-F238E27FC236}">
+                <a16:creationId xmlns:a16="http://schemas.microsoft.com/office/drawing/2014/main" id="{59DB195E-D9C0-8AD5-534F-AA0A0C933D31}"/>
+              </a:ext>
+            </a:extLst>
+          </p:cNvPr>
+          <p:cNvPicPr>
+            <a:picLocks noChangeAspect="1"/>
+          </p:cNvPicPr>
+          <p:nvPr/>
+        </p:nvPicPr>
+        <p:blipFill>
+          <a:blip r:embed="rId3"/>
+          <a:stretch>
+            <a:fillRect/>
+          </a:stretch>
+        </p:blipFill>
+        <p:spPr>
+          <a:xfrm>
+            <a:off x="1423428" y="2613802"/>
+            <a:ext cx="1117600" cy="419100"/>
           </a:xfrm>
           <a:prstGeom prst="rect">
             <a:avLst/>
@@ -14139,7 +14283,7 @@
                 <a:ea typeface="Arial" pitchFamily="34" charset="-122"/>
                 <a:cs typeface="Arial" pitchFamily="34" charset="-120"/>
               </a:rPr>
-              <a:t>Product: meet yarnnn’s agent: Thinking Partner TP</a:t>
+              <a:t>Product: Meet yarnnn's Orchestrator</a:t>
             </a:r>
             <a:endParaRPr lang="en-US" sz="1100" dirty="0"/>
           </a:p>
@@ -14178,7 +14322,7 @@
                 <a:ea typeface="Arial" pitchFamily="34" charset="-122"/>
                 <a:cs typeface="Arial" pitchFamily="34" charset="-120"/>
               </a:rPr>
-              <a:t>Your autonomous AI agent. Live at yarnnn.com.</a:t>
+              <a:t>Your autonomous agent network. Live at yarnnn.com.</a:t>
             </a:r>
             <a:endParaRPr lang="en-US" sz="2400" dirty="0"/>
           </a:p>
@@ -14186,7 +14330,7 @@
       </p:sp>
       <p:pic>
         <p:nvPicPr>
-          <p:cNvPr id="4" name="Screenshot Chat" descr="TP Chat Mode"/>
+          <p:cNvPr id="4" name="Screenshot Chat" descr="Orchestrator - Chat"/>
           <p:cNvPicPr>
             <a:picLocks noChangeAspect="1"/>
           </p:cNvPicPr>
@@ -14212,7 +14356,7 @@
       </p:pic>
       <p:pic>
         <p:nvPicPr>
-          <p:cNvPr id="21" name="Screenshot Deliverables" descr="Deliverables - Headless Mode"/>
+          <p:cNvPr id="21" name="Screenshot Deliverables" descr="Agents - Headless Mode"/>
           <p:cNvPicPr>
             <a:picLocks noChangeAspect="1"/>
           </p:cNvPicPr>
@@ -14264,7 +14408,7 @@
       </p:pic>
       <p:pic>
         <p:nvPicPr>
-          <p:cNvPr id="23" name="Screenshot Context" descr="Context Engine"/>
+          <p:cNvPr id="23" name="Screenshot Context" descr="Knowledge Engine"/>
           <p:cNvPicPr>
             <a:picLocks noChangeAspect="1"/>
           </p:cNvPicPr>
@@ -14426,7 +14570,7 @@
                 <a:ea typeface="Arial" pitchFamily="34" charset="-122"/>
                 <a:cs typeface="Arial" pitchFamily="34" charset="-120"/>
               </a:rPr>
-              <a:t>Ask anything. TP already has the context. Built like Claude Code with primitive tools, webSearch</a:t>
+              <a:t>Ask anything. It already knows your work. Built like Claude Code with capabilities and webSearch</a:t>
             </a:r>
             <a:endParaRPr lang="en-US" sz="800" dirty="0"/>
           </a:p>
@@ -14570,7 +14714,7 @@
                 <a:ea typeface="Arial" pitchFamily="34" charset="-122"/>
                 <a:cs typeface="Arial" pitchFamily="34" charset="-120"/>
               </a:rPr>
-              <a:t>Autonomous deliverables on schedule. Backend Processors, Cron jobs to make autonomy native</a:t>
+              <a:t>Autonomous agents on schedule. Persistent agents with inspectable workspaces</a:t>
             </a:r>
             <a:endParaRPr lang="en-US" sz="800" dirty="0"/>
           </a:p>
@@ -14888,7 +15032,7 @@
                 <a:latin typeface="Arial" pitchFamily="34" charset="0"/>
                 <a:cs typeface="Arial" pitchFamily="34" charset="-120"/>
               </a:rPr>
-              <a:t>Recursive context management, memory handling</a:t>
+              <a:t>Knowledge accumulation, workspace memory</a:t>
             </a:r>
             <a:endParaRPr lang="en-US" sz="800" dirty="0"/>
           </a:p>
@@ -14971,7 +15115,7 @@
         </p:nvSpPr>
         <p:spPr>
           <a:xfrm>
-            <a:off x="685800" y="594360"/>
+            <a:off x="685800" y="685800"/>
             <a:ext cx="7772400" cy="457200"/>
           </a:xfrm>
           <a:prstGeom prst="rect">
@@ -15007,8 +15151,8 @@
         </p:nvSpPr>
         <p:spPr>
           <a:xfrm>
-            <a:off x="685800" y="1051560"/>
-            <a:ext cx="7772400" cy="228600"/>
+            <a:off x="685800" y="1211579"/>
+            <a:ext cx="7772400" cy="336974"/>
           </a:xfrm>
           <a:prstGeom prst="rect">
             <a:avLst/>
@@ -15030,7 +15174,7 @@
                 </a:solidFill>
                 <a:latin typeface="Arial" pitchFamily="34" charset="0"/>
               </a:rPr>
-              <a:t>Designed so context compounds over time, creating recursive feedback between outputs and agent architecture</a:t>
+              <a:t>Every layer purpose-built so knowledge compounds — creating recursive feedback between agent output and accumulated intelligence</a:t>
             </a:r>
           </a:p>
         </p:txBody>
@@ -15043,8 +15187,8 @@
         </p:nvSpPr>
         <p:spPr>
           <a:xfrm>
-            <a:off x="643287" y="1783080"/>
-            <a:ext cx="1296609" cy="731520"/>
+            <a:off x="643287" y="1862982"/>
+            <a:ext cx="1296609" cy="1234972"/>
           </a:xfrm>
           <a:prstGeom prst="roundRect">
             <a:avLst>
@@ -15059,7 +15203,7 @@
           </a:ln>
         </p:spPr>
         <p:txBody>
-          <a:bodyPr wrap="square" lIns="54000" tIns="36000" rIns="54000" bIns="36000" rtlCol="0" anchor="ctr"/>
+          <a:bodyPr wrap="square" lIns="54000" tIns="36000" rIns="54000" bIns="36000" rtlCol="0" anchor="t"/>
           <a:lstStyle/>
           <a:p>
             <a:pPr marL="0" indent="0" algn="ctr">
@@ -15072,8 +15216,19 @@
                 </a:solidFill>
                 <a:latin typeface="Arial" pitchFamily="34" charset="0"/>
               </a:rPr>
-              <a:t>Platform Sync</a:t>
-            </a:r>
+              <a:t>Perception Pipeline</a:t>
+            </a:r>
+          </a:p>
+          <a:p>
+            <a:pPr marL="0" indent="0" algn="ctr">
+              <a:buNone/>
+            </a:pPr>
+            <a:endParaRPr lang="en-US" sz="800" dirty="0">
+              <a:solidFill>
+                <a:srgbClr val="FFFFFF"/>
+              </a:solidFill>
+              <a:latin typeface="Arial" pitchFamily="34" charset="0"/>
+            </a:endParaRPr>
           </a:p>
           <a:p>
             <a:pPr marL="0" indent="0" algn="ctr">
@@ -15100,7 +15255,7 @@
         </p:nvSpPr>
         <p:spPr>
           <a:xfrm>
-            <a:off x="2043968" y="2057400"/>
+            <a:off x="2043968" y="2137302"/>
             <a:ext cx="202595" cy="182880"/>
           </a:xfrm>
           <a:prstGeom prst="rect">
@@ -15136,8 +15291,8 @@
         </p:nvSpPr>
         <p:spPr>
           <a:xfrm>
-            <a:off x="2350635" y="1783080"/>
-            <a:ext cx="1296609" cy="731520"/>
+            <a:off x="2350635" y="1862982"/>
+            <a:ext cx="1296609" cy="1234972"/>
           </a:xfrm>
           <a:prstGeom prst="roundRect">
             <a:avLst>
@@ -15152,7 +15307,7 @@
           </a:ln>
         </p:spPr>
         <p:txBody>
-          <a:bodyPr wrap="square" lIns="54000" tIns="36000" rIns="54000" bIns="36000" rtlCol="0" anchor="ctr"/>
+          <a:bodyPr wrap="square" lIns="54000" tIns="36000" rIns="54000" bIns="36000" rtlCol="0" anchor="t"/>
           <a:lstStyle/>
           <a:p>
             <a:pPr marL="0" indent="0" algn="ctr">
@@ -15165,13 +15320,35 @@
                 </a:solidFill>
                 <a:latin typeface="Arial" pitchFamily="34" charset="0"/>
               </a:rPr>
-              <a:t>Content Layer</a:t>
+              <a:t>Context Mgmt.</a:t>
             </a:r>
           </a:p>
           <a:p>
             <a:pPr marL="0" indent="0" algn="ctr">
               <a:buNone/>
             </a:pPr>
+            <a:endParaRPr lang="en-US" sz="800" dirty="0">
+              <a:solidFill>
+                <a:srgbClr val="BBBBBB"/>
+              </a:solidFill>
+              <a:latin typeface="Arial" pitchFamily="34" charset="0"/>
+            </a:endParaRPr>
+          </a:p>
+          <a:p>
+            <a:pPr marL="0" indent="0" algn="ctr">
+              <a:buNone/>
+            </a:pPr>
+            <a:endParaRPr lang="en-US" sz="800" dirty="0">
+              <a:solidFill>
+                <a:srgbClr val="BBBBBB"/>
+              </a:solidFill>
+              <a:latin typeface="Arial" pitchFamily="34" charset="0"/>
+            </a:endParaRPr>
+          </a:p>
+          <a:p>
+            <a:pPr marL="0" indent="0" algn="ctr">
+              <a:buNone/>
+            </a:pPr>
             <a:r>
               <a:rPr lang="en-US" sz="800" dirty="0">
                 <a:solidFill>
@@ -15179,8 +15356,39 @@
                 </a:solidFill>
                 <a:latin typeface="Arial" pitchFamily="34" charset="0"/>
               </a:rPr>
-              <a:t>Unified store
-Retention + provenance</a:t>
+              <a:t>Shared content
+management for </a:t>
+            </a:r>
+            <a:br>
+              <a:rPr lang="en-US" sz="800" dirty="0">
+                <a:solidFill>
+                  <a:srgbClr val="BBBBBB"/>
+                </a:solidFill>
+                <a:latin typeface="Arial" pitchFamily="34" charset="0"/>
+              </a:rPr>
+            </a:br>
+            <a:r>
+              <a:rPr lang="en-US" sz="800" dirty="0">
+                <a:solidFill>
+                  <a:srgbClr val="BBBBBB"/>
+                </a:solidFill>
+                <a:latin typeface="Arial" pitchFamily="34" charset="0"/>
+              </a:rPr>
+              <a:t>multi agents</a:t>
+            </a:r>
+          </a:p>
+          <a:p>
+            <a:pPr marL="0" indent="0" algn="ctr">
+              <a:buNone/>
+            </a:pPr>
+            <a:r>
+              <a:rPr lang="en-US" sz="800" dirty="0">
+                <a:solidFill>
+                  <a:srgbClr val="BBBBBB"/>
+                </a:solidFill>
+                <a:latin typeface="Arial" pitchFamily="34" charset="0"/>
+              </a:rPr>
+              <a:t>Retention + provenance</a:t>
             </a:r>
           </a:p>
         </p:txBody>
@@ -15193,7 +15401,7 @@
         </p:nvSpPr>
         <p:spPr>
           <a:xfrm>
-            <a:off x="3751316" y="2057400"/>
+            <a:off x="3751316" y="2137302"/>
             <a:ext cx="202595" cy="182880"/>
           </a:xfrm>
           <a:prstGeom prst="rect">
@@ -15229,8 +15437,8 @@
         </p:nvSpPr>
         <p:spPr>
           <a:xfrm>
-            <a:off x="4057983" y="1783080"/>
-            <a:ext cx="1296609" cy="731520"/>
+            <a:off x="4057983" y="1862982"/>
+            <a:ext cx="1296609" cy="1234972"/>
           </a:xfrm>
           <a:prstGeom prst="roundRect">
             <a:avLst>
@@ -15245,7 +15453,7 @@
           </a:ln>
         </p:spPr>
         <p:txBody>
-          <a:bodyPr wrap="square" lIns="54000" tIns="36000" rIns="54000" bIns="36000" rtlCol="0" anchor="ctr"/>
+          <a:bodyPr wrap="square" lIns="54000" tIns="36000" rIns="54000" bIns="36000" rtlCol="0" anchor="t"/>
           <a:lstStyle/>
           <a:p>
             <a:pPr marL="0" indent="0" algn="ctr">
@@ -15260,6 +15468,28 @@
               </a:rPr>
               <a:t>Memory</a:t>
             </a:r>
+          </a:p>
+          <a:p>
+            <a:pPr marL="0" indent="0" algn="ctr">
+              <a:buNone/>
+            </a:pPr>
+            <a:endParaRPr lang="en-US" sz="800" dirty="0">
+              <a:solidFill>
+                <a:srgbClr val="BBBBBB"/>
+              </a:solidFill>
+              <a:latin typeface="Arial" pitchFamily="34" charset="0"/>
+            </a:endParaRPr>
+          </a:p>
+          <a:p>
+            <a:pPr marL="0" indent="0" algn="ctr">
+              <a:buNone/>
+            </a:pPr>
+            <a:endParaRPr lang="en-US" sz="800" dirty="0">
+              <a:solidFill>
+                <a:srgbClr val="BBBBBB"/>
+              </a:solidFill>
+              <a:latin typeface="Arial" pitchFamily="34" charset="0"/>
+            </a:endParaRPr>
           </a:p>
           <a:p>
             <a:pPr marL="0" indent="0" algn="ctr">
@@ -15286,7 +15516,7 @@
         </p:nvSpPr>
         <p:spPr>
           <a:xfrm>
-            <a:off x="5458664" y="2057400"/>
+            <a:off x="5458664" y="2137302"/>
             <a:ext cx="202595" cy="182880"/>
           </a:xfrm>
           <a:prstGeom prst="rect">
@@ -15322,8 +15552,8 @@
         </p:nvSpPr>
         <p:spPr>
           <a:xfrm>
-            <a:off x="5765331" y="1783080"/>
-            <a:ext cx="1296609" cy="731520"/>
+            <a:off x="5765331" y="1862982"/>
+            <a:ext cx="1296609" cy="1234972"/>
           </a:xfrm>
           <a:prstGeom prst="roundRect">
             <a:avLst>
@@ -15338,7 +15568,7 @@
           </a:ln>
         </p:spPr>
         <p:txBody>
-          <a:bodyPr wrap="square" lIns="54000" tIns="36000" rIns="54000" bIns="36000" rtlCol="0" anchor="ctr"/>
+          <a:bodyPr wrap="square" lIns="54000" tIns="36000" rIns="54000" bIns="36000" rtlCol="0" anchor="t"/>
           <a:lstStyle/>
           <a:p>
             <a:pPr marL="0" indent="0" algn="ctr">
@@ -15351,8 +15581,25 @@
                 </a:solidFill>
                 <a:latin typeface="Arial" pitchFamily="34" charset="0"/>
               </a:rPr>
-              <a:t>Agent Engine</a:t>
-            </a:r>
+              <a:t>Agent Orchestration</a:t>
+            </a:r>
+            <a:endParaRPr lang="en-US" sz="800" dirty="0">
+              <a:solidFill>
+                <a:srgbClr val="BBBBBB"/>
+              </a:solidFill>
+              <a:latin typeface="Arial" pitchFamily="34" charset="0"/>
+            </a:endParaRPr>
+          </a:p>
+          <a:p>
+            <a:pPr marL="0" indent="0" algn="ctr">
+              <a:buNone/>
+            </a:pPr>
+            <a:endParaRPr lang="en-US" sz="800" dirty="0">
+              <a:solidFill>
+                <a:srgbClr val="BBBBBB"/>
+              </a:solidFill>
+              <a:latin typeface="Arial" pitchFamily="34" charset="0"/>
+            </a:endParaRPr>
           </a:p>
           <a:p>
             <a:pPr marL="0" indent="0" algn="ctr">
@@ -15369,6 +15616,38 @@
 Chat + headless</a:t>
             </a:r>
           </a:p>
+          <a:p>
+            <a:pPr marL="0" indent="0" algn="ctr">
+              <a:buNone/>
+            </a:pPr>
+            <a:r>
+              <a:rPr lang="en-US" sz="800" dirty="0">
+                <a:solidFill>
+                  <a:srgbClr val="BBBBBB"/>
+                </a:solidFill>
+                <a:latin typeface="Arial" pitchFamily="34" charset="0"/>
+              </a:rPr>
+              <a:t>(</a:t>
+            </a:r>
+            <a:r>
+              <a:rPr lang="en-US" sz="800" dirty="0" err="1">
+                <a:solidFill>
+                  <a:srgbClr val="BBBBBB"/>
+                </a:solidFill>
+                <a:latin typeface="Arial" pitchFamily="34" charset="0"/>
+              </a:rPr>
+              <a:t>cron</a:t>
+            </a:r>
+            <a:r>
+              <a:rPr lang="en-US" sz="800" dirty="0">
+                <a:solidFill>
+                  <a:srgbClr val="BBBBBB"/>
+                </a:solidFill>
+                <a:latin typeface="Arial" pitchFamily="34" charset="0"/>
+              </a:rPr>
+              <a:t>-jobs, sync processors, etc.)</a:t>
+            </a:r>
+          </a:p>
         </p:txBody>
       </p:sp>
       <p:sp>
@@ -15379,7 +15658,7 @@
         </p:nvSpPr>
         <p:spPr>
           <a:xfrm>
-            <a:off x="7166012" y="2057400"/>
+            <a:off x="7166012" y="2137302"/>
             <a:ext cx="202595" cy="182880"/>
           </a:xfrm>
           <a:prstGeom prst="rect">
@@ -15415,8 +15694,8 @@
         </p:nvSpPr>
         <p:spPr>
           <a:xfrm>
-            <a:off x="7472680" y="1777153"/>
-            <a:ext cx="1134533" cy="731520"/>
+            <a:off x="7472680" y="1857055"/>
+            <a:ext cx="1134533" cy="1234972"/>
           </a:xfrm>
           <a:prstGeom prst="roundRect">
             <a:avLst>
@@ -15431,7 +15710,7 @@
           </a:ln>
         </p:spPr>
         <p:txBody>
-          <a:bodyPr wrap="square" lIns="54000" tIns="36000" rIns="54000" bIns="36000" rtlCol="0" anchor="ctr"/>
+          <a:bodyPr wrap="square" lIns="54000" tIns="36000" rIns="54000" bIns="36000" rtlCol="0" anchor="t"/>
           <a:lstStyle/>
           <a:p>
             <a:pPr marL="0" indent="0" algn="ctr">
@@ -15444,13 +15723,35 @@
                 </a:solidFill>
                 <a:latin typeface="Arial" pitchFamily="34" charset="0"/>
               </a:rPr>
-              <a:t>Deliverables</a:t>
+              <a:t>Agents</a:t>
             </a:r>
           </a:p>
           <a:p>
             <a:pPr marL="0" indent="0" algn="ctr">
               <a:buNone/>
             </a:pPr>
+            <a:endParaRPr lang="en-US" sz="800" dirty="0">
+              <a:solidFill>
+                <a:srgbClr val="FFFFFF"/>
+              </a:solidFill>
+              <a:latin typeface="Arial" pitchFamily="34" charset="0"/>
+            </a:endParaRPr>
+          </a:p>
+          <a:p>
+            <a:pPr marL="0" indent="0" algn="ctr">
+              <a:buNone/>
+            </a:pPr>
+            <a:endParaRPr lang="en-US" sz="800" dirty="0">
+              <a:solidFill>
+                <a:srgbClr val="FFFFFF"/>
+              </a:solidFill>
+              <a:latin typeface="Arial" pitchFamily="34" charset="0"/>
+            </a:endParaRPr>
+          </a:p>
+          <a:p>
+            <a:pPr marL="0" indent="0" algn="ctr">
+              <a:buNone/>
+            </a:pPr>
             <a:r>
               <a:rPr lang="en-US" sz="800" dirty="0">
                 <a:solidFill>
@@ -15458,8 +15759,8 @@
                 </a:solidFill>
                 <a:latin typeface="Arial" pitchFamily="34" charset="0"/>
               </a:rPr>
-              <a:t>Autonomous
-scheduled output</a:t>
+              <a:t>Persistent
+autonomous output</a:t>
             </a:r>
           </a:p>
         </p:txBody>
@@ -15472,7 +15773,7 @@
         </p:nvSpPr>
         <p:spPr>
           <a:xfrm>
-            <a:off x="685800" y="3017520"/>
+            <a:off x="706120" y="3497580"/>
             <a:ext cx="7315200" cy="228600"/>
           </a:xfrm>
           <a:prstGeom prst="rect">
@@ -15508,7 +15809,7 @@
         </p:nvSpPr>
         <p:spPr>
           <a:xfrm>
-            <a:off x="685800" y="3337560"/>
+            <a:off x="706120" y="3817620"/>
             <a:ext cx="2560320" cy="182880"/>
           </a:xfrm>
           <a:prstGeom prst="rect">
@@ -15544,7 +15845,7 @@
         </p:nvSpPr>
         <p:spPr>
           <a:xfrm>
-            <a:off x="685800" y="3520440"/>
+            <a:off x="706120" y="4000500"/>
             <a:ext cx="2560320" cy="457200"/>
           </a:xfrm>
           <a:prstGeom prst="rect">
@@ -15564,7 +15865,7 @@
                 </a:solidFill>
                 <a:latin typeface="Arial" pitchFamily="34" charset="0"/>
               </a:rPr>
-              <a:t>No persistent cross-platform context.</a:t>
+              <a:t>Cross-platform knowledge not possible.</a:t>
             </a:r>
           </a:p>
           <a:p>
@@ -15578,7 +15879,7 @@
                 </a:solidFill>
                 <a:latin typeface="Arial" pitchFamily="34" charset="0"/>
               </a:rPr>
-              <a:t>Optimized for breadth, not individual depth. </a:t>
+              <a:t>Optimized for horizontal, not individual depth. </a:t>
             </a:r>
           </a:p>
         </p:txBody>
@@ -15591,7 +15892,7 @@
         </p:nvSpPr>
         <p:spPr>
           <a:xfrm>
-            <a:off x="3429000" y="3337560"/>
+            <a:off x="3449320" y="3817620"/>
             <a:ext cx="2560320" cy="182880"/>
           </a:xfrm>
           <a:prstGeom prst="rect">
@@ -15614,7 +15915,43 @@
                 </a:solidFill>
                 <a:latin typeface="Arial" pitchFamily="34" charset="0"/>
               </a:rPr>
-              <a:t>Agent Startups</a:t>
+              <a:t>Agent Startups (</a:t>
+            </a:r>
+            <a:r>
+              <a:rPr lang="en-US" sz="1000" b="1" dirty="0" err="1">
+                <a:solidFill>
+                  <a:srgbClr val="111111"/>
+                </a:solidFill>
+                <a:latin typeface="Arial" pitchFamily="34" charset="0"/>
+              </a:rPr>
+              <a:t>mem.ai</a:t>
+            </a:r>
+            <a:r>
+              <a:rPr lang="en-US" sz="1000" b="1" dirty="0">
+                <a:solidFill>
+                  <a:srgbClr val="111111"/>
+                </a:solidFill>
+                <a:latin typeface="Arial" pitchFamily="34" charset="0"/>
+              </a:rPr>
+              <a:t>, </a:t>
+            </a:r>
+            <a:r>
+              <a:rPr lang="en-US" sz="1000" b="1" dirty="0" err="1">
+                <a:solidFill>
+                  <a:srgbClr val="111111"/>
+                </a:solidFill>
+                <a:latin typeface="Arial" pitchFamily="34" charset="0"/>
+              </a:rPr>
+              <a:t>openclaw</a:t>
+            </a:r>
+            <a:r>
+              <a:rPr lang="en-US" sz="1000" b="1" dirty="0">
+                <a:solidFill>
+                  <a:srgbClr val="111111"/>
+                </a:solidFill>
+                <a:latin typeface="Arial" pitchFamily="34" charset="0"/>
+              </a:rPr>
+              <a:t>)</a:t>
             </a:r>
           </a:p>
         </p:txBody>
@@ -15627,7 +15964,7 @@
         </p:nvSpPr>
         <p:spPr>
           <a:xfrm>
-            <a:off x="3429000" y="3520440"/>
+            <a:off x="3449320" y="4000500"/>
             <a:ext cx="2560320" cy="457200"/>
           </a:xfrm>
           <a:prstGeom prst="rect">
@@ -15650,7 +15987,7 @@
                 </a:solidFill>
                 <a:latin typeface="Arial" pitchFamily="34" charset="0"/>
               </a:rPr>
-              <a:t>Architectural gap.</a:t>
+              <a:t>Architectural gap. (hardware or agent framework)</a:t>
             </a:r>
           </a:p>
           <a:p>
@@ -15664,9 +16001,67 @@
                 </a:solidFill>
                 <a:latin typeface="Arial" pitchFamily="34" charset="0"/>
               </a:rPr>
-              <a:t>Task execution focused. </a:t>
-            </a:r>
-          </a:p>
+              <a:t>No accumulated knowledge layer with feedback loop</a:t>
+            </a:r>
+          </a:p>
+        </p:txBody>
+      </p:sp>
+      <p:sp>
+        <p:nvSpPr>
+          <p:cNvPr id="24" name="Text 18"/>
+          <p:cNvSpPr/>
+          <p:nvPr/>
+        </p:nvSpPr>
+        <p:spPr>
+          <a:xfrm>
+            <a:off x="6192520" y="3817620"/>
+            <a:ext cx="2560320" cy="182880"/>
+          </a:xfrm>
+          <a:prstGeom prst="rect">
+            <a:avLst/>
+          </a:prstGeom>
+          <a:noFill/>
+          <a:ln/>
+        </p:spPr>
+        <p:txBody>
+          <a:bodyPr wrap="square" lIns="0" tIns="0" rIns="0" bIns="0" rtlCol="0" anchor="ctr"/>
+          <a:lstStyle/>
+          <a:p>
+            <a:pPr marL="0" indent="0">
+              <a:buNone/>
+            </a:pPr>
+            <a:r>
+              <a:rPr lang="en-US" sz="1000" b="1" dirty="0">
+                <a:solidFill>
+                  <a:srgbClr val="111111"/>
+                </a:solidFill>
+                <a:latin typeface="Arial" pitchFamily="34" charset="0"/>
+              </a:rPr>
+              <a:t>Workspace AI (Notion AI, Slack)</a:t>
+            </a:r>
+          </a:p>
+        </p:txBody>
+      </p:sp>
+      <p:sp>
+        <p:nvSpPr>
+          <p:cNvPr id="25" name="Text 19"/>
+          <p:cNvSpPr/>
+          <p:nvPr/>
+        </p:nvSpPr>
+        <p:spPr>
+          <a:xfrm>
+            <a:off x="6192520" y="4000500"/>
+            <a:ext cx="2560320" cy="457200"/>
+          </a:xfrm>
+          <a:prstGeom prst="rect">
+            <a:avLst/>
+          </a:prstGeom>
+          <a:noFill/>
+          <a:ln/>
+        </p:spPr>
+        <p:txBody>
+          <a:bodyPr wrap="square" lIns="0" tIns="0" rIns="0" bIns="0" rtlCol="0" anchor="t"/>
+          <a:lstStyle/>
           <a:p>
             <a:pPr marL="0" indent="0">
               <a:buNone/>
@@ -15678,67 +16073,9 @@
                 </a:solidFill>
                 <a:latin typeface="Arial" pitchFamily="34" charset="0"/>
               </a:rPr>
-              <a:t>No accumulated context layer with feedback loop</a:t>
-            </a:r>
-          </a:p>
-        </p:txBody>
-      </p:sp>
-      <p:sp>
-        <p:nvSpPr>
-          <p:cNvPr id="24" name="Text 18"/>
-          <p:cNvSpPr/>
-          <p:nvPr/>
-        </p:nvSpPr>
-        <p:spPr>
-          <a:xfrm>
-            <a:off x="6172200" y="3337560"/>
-            <a:ext cx="2560320" cy="182880"/>
-          </a:xfrm>
-          <a:prstGeom prst="rect">
-            <a:avLst/>
-          </a:prstGeom>
-          <a:noFill/>
-          <a:ln/>
-        </p:spPr>
-        <p:txBody>
-          <a:bodyPr wrap="square" lIns="0" tIns="0" rIns="0" bIns="0" rtlCol="0" anchor="ctr"/>
-          <a:lstStyle/>
-          <a:p>
-            <a:pPr marL="0" indent="0">
-              <a:buNone/>
-            </a:pPr>
-            <a:r>
-              <a:rPr lang="en-US" sz="1000" b="1" dirty="0">
-                <a:solidFill>
-                  <a:srgbClr val="111111"/>
-                </a:solidFill>
-                <a:latin typeface="Arial" pitchFamily="34" charset="0"/>
-              </a:rPr>
-              <a:t>Workspace AI</a:t>
-            </a:r>
-          </a:p>
-        </p:txBody>
-      </p:sp>
-      <p:sp>
-        <p:nvSpPr>
-          <p:cNvPr id="25" name="Text 19"/>
-          <p:cNvSpPr/>
-          <p:nvPr/>
-        </p:nvSpPr>
-        <p:spPr>
-          <a:xfrm>
-            <a:off x="6172200" y="3520440"/>
-            <a:ext cx="2560320" cy="457200"/>
-          </a:xfrm>
-          <a:prstGeom prst="rect">
-            <a:avLst/>
-          </a:prstGeom>
-          <a:noFill/>
-          <a:ln/>
-        </p:spPr>
-        <p:txBody>
-          <a:bodyPr wrap="square" lIns="0" tIns="0" rIns="0" bIns="0" rtlCol="0" anchor="t"/>
-          <a:lstStyle/>
+              <a:t>Single-platform. Can’t synthesize across tools. </a:t>
+            </a:r>
+          </a:p>
           <a:p>
             <a:pPr marL="0" indent="0">
               <a:buNone/>
@@ -15750,54 +16087,7 @@
                 </a:solidFill>
                 <a:latin typeface="Arial" pitchFamily="34" charset="0"/>
               </a:rPr>
-              <a:t>Single-platform. Can’t synthesize across tools. </a:t>
-            </a:r>
-          </a:p>
-          <a:p>
-            <a:pPr marL="0" indent="0">
-              <a:buNone/>
-            </a:pPr>
-            <a:r>
-              <a:rPr lang="en-US" sz="900" dirty="0">
-                <a:solidFill>
-                  <a:srgbClr val="666666"/>
-                </a:solidFill>
-                <a:latin typeface="Arial" pitchFamily="34" charset="0"/>
-              </a:rPr>
-              <a:t>No autonomous deliverables.</a:t>
-            </a:r>
-          </a:p>
-        </p:txBody>
-      </p:sp>
-      <p:sp>
-        <p:nvSpPr>
-          <p:cNvPr id="26" name="Text 20"/>
-          <p:cNvSpPr/>
-          <p:nvPr/>
-        </p:nvSpPr>
-        <p:spPr>
-          <a:xfrm>
-            <a:off x="685800" y="4206240"/>
-            <a:ext cx="7772400" cy="274320"/>
-          </a:xfrm>
-          <a:prstGeom prst="rect">
-            <a:avLst/>
-          </a:prstGeom>
-          <a:noFill/>
-          <a:ln/>
-        </p:spPr>
-        <p:txBody>
-          <a:bodyPr wrap="square" lIns="0" tIns="0" rIns="0" bIns="0" rtlCol="0" anchor="ctr"/>
-          <a:lstStyle/>
-          <a:p>
-            <a:r>
-              <a:rPr lang="en-US" sz="1000" b="1" dirty="0">
-                <a:solidFill>
-                  <a:srgbClr val="E8985E"/>
-                </a:solidFill>
-                <a:latin typeface="Arial" pitchFamily="34" charset="0"/>
-              </a:rPr>
-              <a:t>Every layer purpose-built for context accumulation, true autonomy + intelligence</a:t>
+              <a:t>No persistent agents.</a:t>
             </a:r>
           </a:p>
         </p:txBody>
@@ -15868,7 +16158,7 @@
                 <a:ea typeface="Arial" pitchFamily="34" charset="-122"/>
                 <a:cs typeface="Arial" pitchFamily="34" charset="-120"/>
               </a:rPr>
-              <a:t>Solution: Compounding Stickiness</a:t>
+              <a:t>Product</a:t>
             </a:r>
             <a:endParaRPr lang="en-US" sz="1100" dirty="0"/>
           </a:p>
@@ -15907,7 +16197,7 @@
                 <a:ea typeface="Arial" pitchFamily="34" charset="-122"/>
                 <a:cs typeface="Arial" pitchFamily="34" charset="-120"/>
               </a:rPr>
-              <a:t>Value Compounds with Every Execution Cycle.</a:t>
+              <a:t>Your Agent Network</a:t>
             </a:r>
             <a:endParaRPr lang="en-US" sz="2400" dirty="0"/>
           </a:p>
@@ -15946,7 +16236,7 @@
                 <a:ea typeface="Arial" pitchFamily="34" charset="-122"/>
                 <a:cs typeface="Arial" pitchFamily="34" charset="-120"/>
               </a:rPr>
-              <a:t>Connect your platforms. TP learns your world. Deliverables run on their own.</a:t>
+              <a:t>Platform specialists accumulate knowledge. Synthesis agents produce work you’d never get from a single tool.</a:t>
             </a:r>
             <a:endParaRPr lang="en-US" sz="1100" dirty="0"/>
           </a:p>
@@ -16010,7 +16300,7 @@
                 </a:solidFill>
                 <a:latin typeface="Arial" pitchFamily="34" charset="0"/>
               </a:rPr>
-              <a:t>DAY 1</a:t>
+              <a:t>RECAP AGENT</a:t>
             </a:r>
           </a:p>
         </p:txBody>
@@ -16046,7 +16336,7 @@
                 </a:solidFill>
                 <a:latin typeface="Arial" pitchFamily="34" charset="0"/>
               </a:rPr>
-              <a:t>Connect + Context</a:t>
+              <a:t>Platform Digest</a:t>
             </a:r>
           </a:p>
         </p:txBody>
@@ -16082,7 +16372,7 @@
                 </a:solidFill>
                 <a:latin typeface="Arial" pitchFamily="34" charset="0"/>
               </a:rPr>
-              <a:t>Link Slack, Gmail, Notion, Calendar. First sync in minutes. TP already knows your work.</a:t>
+              <a:t>What happened while you weren’t looking. All platforms synthesized into one brief.</a:t>
             </a:r>
           </a:p>
         </p:txBody>
@@ -16147,7 +16437,7 @@
                 </a:solidFill>
                 <a:latin typeface="Arial" pitchFamily="34" charset="0"/>
               </a:rPr>
-              <a:t>WHAT YOU GET:</a:t>
+              <a:t>EXAMPLE:</a:t>
             </a:r>
           </a:p>
         </p:txBody>
@@ -16183,22 +16473,7 @@
                 </a:solidFill>
                 <a:latin typeface="Arial" pitchFamily="34" charset="0"/>
               </a:rPr>
-              <a:t>• Ask TP anything — shared context is key</a:t>
-            </a:r>
-          </a:p>
-          <a:p>
-            <a:pPr marL="0" indent="0">
-              <a:buNone/>
-            </a:pPr>
-            <a:r>
-              <a:rPr lang="en-US" sz="900" dirty="0">
-                <a:solidFill>
-                  <a:srgbClr val="FFFFFF"/>
-                </a:solidFill>
-                <a:latin typeface="Arial" pitchFamily="34" charset="0"/>
-              </a:rPr>
-              <a:t>• Pre-meeting brief from Slack + Gmail
-• Project status from channel activity</a:t>
+              <a:t>Monday morning: here’s everything from #engineering, your inbox, and 3 Notion updates. Gets better every week.</a:t>
             </a:r>
           </a:p>
         </p:txBody>
@@ -16261,7 +16536,7 @@
                 </a:solidFill>
                 <a:latin typeface="Arial" pitchFamily="34" charset="0"/>
               </a:rPr>
-              <a:t>DAY 30</a:t>
+              <a:t>MEETING PREP AGENT</a:t>
             </a:r>
           </a:p>
         </p:txBody>
@@ -16297,7 +16572,7 @@
                 </a:solidFill>
                 <a:latin typeface="Arial" pitchFamily="34" charset="0"/>
               </a:rPr>
-              <a:t>Autonomous Output</a:t>
+              <a:t>Calendar-Driven Briefs</a:t>
             </a:r>
           </a:p>
         </p:txBody>
@@ -16333,7 +16608,7 @@
                 </a:solidFill>
                 <a:latin typeface="Arial" pitchFamily="34" charset="0"/>
               </a:rPr>
-              <a:t>Scheduled deliverables run without prompting. Each one learns from your edits and feedback.</a:t>
+              <a:t>Full attendee context from Slack + Gmail + Notion. Delivered before every meeting.</a:t>
             </a:r>
           </a:p>
         </p:txBody>
@@ -16398,7 +16673,7 @@
                 </a:solidFill>
                 <a:latin typeface="Arial" pitchFamily="34" charset="0"/>
               </a:rPr>
-              <a:t>WHAT RUNS ON ITS OWN:</a:t>
+              <a:t>EXAMPLE:</a:t>
             </a:r>
           </a:p>
         </p:txBody>
@@ -16434,9 +16709,7 @@
                 </a:solidFill>
                 <a:latin typeface="Arial" pitchFamily="34" charset="0"/>
               </a:rPr>
-              <a:t>• Weekly client updates from project channels
-• Monday meeting prep with attendee context
-• Monthly board report from all platforms</a:t>
+              <a:t>You meet Sarah at 2pm. Here’s her last 5 Slack threads, 2 emails, and the Notion doc she edited yesterday.</a:t>
             </a:r>
           </a:p>
         </p:txBody>
@@ -16499,7 +16772,7 @@
                 </a:solidFill>
                 <a:latin typeface="Arial" pitchFamily="34" charset="0"/>
               </a:rPr>
-              <a:t>DAY 90</a:t>
+              <a:t>STATUS + WATCH AGENTS</a:t>
             </a:r>
           </a:p>
         </p:txBody>
@@ -16535,7 +16808,7 @@
                 </a:solidFill>
                 <a:latin typeface="Arial" pitchFamily="34" charset="0"/>
               </a:rPr>
-              <a:t>Irreplaceable Intelligence</a:t>
+              <a:t>Synthesis + Proactive Intel</a:t>
             </a:r>
           </a:p>
         </p:txBody>
@@ -16571,7 +16844,7 @@
                 </a:solidFill>
                 <a:latin typeface="Arial" pitchFamily="34" charset="0"/>
               </a:rPr>
-              <a:t>90 days of accumulated context. TP knows your clients, your projects, your style. No generic tool can replicate this.</a:t>
+              <a:t>Cross-platform status updates for any audience. Proactive alerts when pricing or competitors surface across channels.</a:t>
             </a:r>
           </a:p>
         </p:txBody>
@@ -16636,7 +16909,7 @@
                 </a:solidFill>
                 <a:latin typeface="Arial" pitchFamily="34" charset="0"/>
               </a:rPr>
-              <a:t>WHAT ONLY YOU HAVE:</a:t>
+              <a:t>EXAMPLES:</a:t>
             </a:r>
           </a:p>
         </p:txBody>
@@ -16672,13 +16945,246 @@
                 </a:solidFill>
                 <a:latin typeface="Arial" pitchFamily="34" charset="0"/>
               </a:rPr>
-              <a:t>• Deal alerts when pricing surfaces in Slack
-• Cross-platform research digests
-• Switching cost: context is irreplaceable</a:t>
-            </a:r>
-          </a:p>
-        </p:txBody>
-      </p:sp>
+              <a:t>Weekly client update from Slack + Gmail + Notion. No copy-paste. Competitor mention detected across 3 channels. Brief generated.</a:t>
+            </a:r>
+          </a:p>
+        </p:txBody>
+      </p:sp>
+      <p:pic>
+        <p:nvPicPr>
+          <p:cNvPr id="1026" name="Picture 2" descr="Slack logo - free Icon PNG, SVG">
+            <a:extLst>
+              <a:ext uri="{FF2B5EF4-FFF2-40B4-BE49-F238E27FC236}">
+                <a16:creationId xmlns:a16="http://schemas.microsoft.com/office/drawing/2014/main" id="{41B8F80D-AC21-0546-BB33-708657AAAAF4}"/>
+              </a:ext>
+            </a:extLst>
+          </p:cNvPr>
+          <p:cNvPicPr>
+            <a:picLocks noChangeAspect="1" noChangeArrowheads="1"/>
+          </p:cNvPicPr>
+          <p:nvPr/>
+        </p:nvPicPr>
+        <p:blipFill>
+          <a:blip r:embed="rId3">
+            <a:extLst>
+              <a:ext uri="{28A0092B-C50C-407E-A947-70E740481C1C}">
+                <a14:useLocalDpi xmlns:a14="http://schemas.microsoft.com/office/drawing/2010/main" val="0"/>
+              </a:ext>
+            </a:extLst>
+          </a:blip>
+          <a:srcRect/>
+          <a:stretch>
+            <a:fillRect/>
+          </a:stretch>
+        </p:blipFill>
+        <p:spPr bwMode="auto">
+          <a:xfrm>
+            <a:off x="1026468" y="3615163"/>
+            <a:ext cx="327232" cy="327232"/>
+          </a:xfrm>
+          <a:prstGeom prst="rect">
+            <a:avLst/>
+          </a:prstGeom>
+          <a:noFill/>
+          <a:extLst>
+            <a:ext uri="{909E8E84-426E-40DD-AFC4-6F175D3DCCD1}">
+              <a14:hiddenFill xmlns:a14="http://schemas.microsoft.com/office/drawing/2010/main">
+                <a:solidFill>
+                  <a:srgbClr val="FFFFFF"/>
+                </a:solidFill>
+              </a14:hiddenFill>
+            </a:ext>
+          </a:extLst>
+        </p:spPr>
+      </p:pic>
+      <p:pic>
+        <p:nvPicPr>
+          <p:cNvPr id="1028" name="Picture 4" descr="Gmail new logo - free Icon PNG, SVG">
+            <a:extLst>
+              <a:ext uri="{FF2B5EF4-FFF2-40B4-BE49-F238E27FC236}">
+                <a16:creationId xmlns:a16="http://schemas.microsoft.com/office/drawing/2014/main" id="{977D2602-1FC1-B338-DD80-43810A7406BC}"/>
+              </a:ext>
+            </a:extLst>
+          </p:cNvPr>
+          <p:cNvPicPr>
+            <a:picLocks noChangeAspect="1" noChangeArrowheads="1"/>
+          </p:cNvPicPr>
+          <p:nvPr/>
+        </p:nvPicPr>
+        <p:blipFill>
+          <a:blip r:embed="rId4">
+            <a:extLst>
+              <a:ext uri="{28A0092B-C50C-407E-A947-70E740481C1C}">
+                <a14:useLocalDpi xmlns:a14="http://schemas.microsoft.com/office/drawing/2010/main" val="0"/>
+              </a:ext>
+            </a:extLst>
+          </a:blip>
+          <a:srcRect/>
+          <a:stretch>
+            <a:fillRect/>
+          </a:stretch>
+        </p:blipFill>
+        <p:spPr bwMode="auto">
+          <a:xfrm>
+            <a:off x="1713657" y="3565760"/>
+            <a:ext cx="426038" cy="426038"/>
+          </a:xfrm>
+          <a:prstGeom prst="rect">
+            <a:avLst/>
+          </a:prstGeom>
+          <a:noFill/>
+          <a:extLst>
+            <a:ext uri="{909E8E84-426E-40DD-AFC4-6F175D3DCCD1}">
+              <a14:hiddenFill xmlns:a14="http://schemas.microsoft.com/office/drawing/2010/main">
+                <a:solidFill>
+                  <a:srgbClr val="FFFFFF"/>
+                </a:solidFill>
+              </a14:hiddenFill>
+            </a:ext>
+          </a:extLst>
+        </p:spPr>
+      </p:pic>
+      <p:pic>
+        <p:nvPicPr>
+          <p:cNvPr id="1032" name="Picture 8" descr="Notion-style Icons">
+            <a:extLst>
+              <a:ext uri="{FF2B5EF4-FFF2-40B4-BE49-F238E27FC236}">
+                <a16:creationId xmlns:a16="http://schemas.microsoft.com/office/drawing/2014/main" id="{152A952D-5370-40F6-A8C2-803C8A1B7EE3}"/>
+              </a:ext>
+            </a:extLst>
+          </p:cNvPr>
+          <p:cNvPicPr>
+            <a:picLocks noChangeAspect="1" noChangeArrowheads="1"/>
+          </p:cNvPicPr>
+          <p:nvPr/>
+        </p:nvPicPr>
+        <p:blipFill>
+          <a:blip r:embed="rId5">
+            <a:extLst>
+              <a:ext uri="{28A0092B-C50C-407E-A947-70E740481C1C}">
+                <a14:useLocalDpi xmlns:a14="http://schemas.microsoft.com/office/drawing/2010/main" val="0"/>
+              </a:ext>
+            </a:extLst>
+          </a:blip>
+          <a:srcRect/>
+          <a:stretch>
+            <a:fillRect/>
+          </a:stretch>
+        </p:blipFill>
+        <p:spPr bwMode="auto">
+          <a:xfrm>
+            <a:off x="2499652" y="3571132"/>
+            <a:ext cx="426038" cy="426038"/>
+          </a:xfrm>
+          <a:prstGeom prst="rect">
+            <a:avLst/>
+          </a:prstGeom>
+          <a:noFill/>
+          <a:extLst>
+            <a:ext uri="{909E8E84-426E-40DD-AFC4-6F175D3DCCD1}">
+              <a14:hiddenFill xmlns:a14="http://schemas.microsoft.com/office/drawing/2010/main">
+                <a:solidFill>
+                  <a:srgbClr val="FFFFFF"/>
+                </a:solidFill>
+              </a14:hiddenFill>
+            </a:ext>
+          </a:extLst>
+        </p:spPr>
+      </p:pic>
+      <p:pic>
+        <p:nvPicPr>
+          <p:cNvPr id="1034" name="Picture 10" descr="calendar icon vector 24150216 Vector Art at Vecteezy">
+            <a:extLst>
+              <a:ext uri="{FF2B5EF4-FFF2-40B4-BE49-F238E27FC236}">
+                <a16:creationId xmlns:a16="http://schemas.microsoft.com/office/drawing/2014/main" id="{ED7105D5-D07A-D7C8-CA39-05077DA0FFC6}"/>
+              </a:ext>
+            </a:extLst>
+          </p:cNvPr>
+          <p:cNvPicPr>
+            <a:picLocks noChangeAspect="1" noChangeArrowheads="1"/>
+          </p:cNvPicPr>
+          <p:nvPr/>
+        </p:nvPicPr>
+        <p:blipFill>
+          <a:blip r:embed="rId6">
+            <a:extLst>
+              <a:ext uri="{28A0092B-C50C-407E-A947-70E740481C1C}">
+                <a14:useLocalDpi xmlns:a14="http://schemas.microsoft.com/office/drawing/2010/main" val="0"/>
+              </a:ext>
+            </a:extLst>
+          </a:blip>
+          <a:srcRect/>
+          <a:stretch>
+            <a:fillRect/>
+          </a:stretch>
+        </p:blipFill>
+        <p:spPr bwMode="auto">
+          <a:xfrm>
+            <a:off x="4469130" y="3557721"/>
+            <a:ext cx="499402" cy="499402"/>
+          </a:xfrm>
+          <a:prstGeom prst="rect">
+            <a:avLst/>
+          </a:prstGeom>
+          <a:noFill/>
+          <a:extLst>
+            <a:ext uri="{909E8E84-426E-40DD-AFC4-6F175D3DCCD1}">
+              <a14:hiddenFill xmlns:a14="http://schemas.microsoft.com/office/drawing/2010/main">
+                <a:solidFill>
+                  <a:srgbClr val="FFFFFF"/>
+                </a:solidFill>
+              </a14:hiddenFill>
+            </a:ext>
+          </a:extLst>
+        </p:spPr>
+      </p:pic>
+      <p:pic>
+        <p:nvPicPr>
+          <p:cNvPr id="1036" name="Picture 12" descr="55,636 Crossroad Icon Stock Vectors and Vector Art | Shutterstock">
+            <a:extLst>
+              <a:ext uri="{FF2B5EF4-FFF2-40B4-BE49-F238E27FC236}">
+                <a16:creationId xmlns:a16="http://schemas.microsoft.com/office/drawing/2014/main" id="{42C2C16F-9F74-9824-4912-86950CD98020}"/>
+              </a:ext>
+            </a:extLst>
+          </p:cNvPr>
+          <p:cNvPicPr>
+            <a:picLocks noChangeAspect="1" noChangeArrowheads="1"/>
+          </p:cNvPicPr>
+          <p:nvPr/>
+        </p:nvPicPr>
+        <p:blipFill rotWithShape="1">
+          <a:blip r:embed="rId7">
+            <a:extLst>
+              <a:ext uri="{28A0092B-C50C-407E-A947-70E740481C1C}">
+                <a14:useLocalDpi xmlns:a14="http://schemas.microsoft.com/office/drawing/2010/main" val="0"/>
+              </a:ext>
+            </a:extLst>
+          </a:blip>
+          <a:srcRect l="53403" t="13395" r="7919" b="14233"/>
+          <a:stretch>
+            <a:fillRect/>
+          </a:stretch>
+        </p:blipFill>
+        <p:spPr bwMode="auto">
+          <a:xfrm>
+            <a:off x="7408399" y="3542913"/>
+            <a:ext cx="499402" cy="509274"/>
+          </a:xfrm>
+          <a:prstGeom prst="rect">
+            <a:avLst/>
+          </a:prstGeom>
+          <a:noFill/>
+          <a:extLst>
+            <a:ext uri="{909E8E84-426E-40DD-AFC4-6F175D3DCCD1}">
+              <a14:hiddenFill xmlns:a14="http://schemas.microsoft.com/office/drawing/2010/main">
+                <a:solidFill>
+                  <a:srgbClr val="FFFFFF"/>
+                </a:solidFill>
+              </a14:hiddenFill>
+            </a:ext>
+          </a:extLst>
+        </p:spPr>
+      </p:pic>
     </p:spTree>
   </p:cSld>
   <p:clrMapOvr>
@@ -16784,7 +17290,7 @@
                 <a:ea typeface="Arial" pitchFamily="34" charset="-122"/>
                 <a:cs typeface="Arial" pitchFamily="34" charset="-120"/>
               </a:rPr>
-              <a:t>Switching Costs compound as Context Accumulates</a:t>
+              <a:t>Knowledge Compounds. Switching Costs Follow.</a:t>
             </a:r>
             <a:endParaRPr lang="en-US" sz="2400" dirty="0"/>
           </a:p>
@@ -16798,34 +17304,57 @@
         </p:nvSpPr>
         <p:spPr>
           <a:xfrm>
-            <a:off x="685800" y="1356116"/>
-            <a:ext cx="7772400" cy="274320"/>
-          </a:xfrm>
-          <a:prstGeom prst="rect">
-            <a:avLst/>
-          </a:prstGeom>
-          <a:noFill/>
-          <a:ln/>
-        </p:spPr>
-        <p:txBody>
-          <a:bodyPr wrap="square" lIns="0" tIns="0" rIns="0" bIns="0" rtlCol="0" anchor="ctr"/>
-          <a:lstStyle/>
-          <a:p>
-            <a:pPr marL="0" indent="0">
-              <a:buNone/>
-            </a:pPr>
-            <a:r>
-              <a:rPr lang="en-US" sz="1100" dirty="0">
-                <a:solidFill>
-                  <a:srgbClr val="999999"/>
-                </a:solidFill>
-                <a:latin typeface="Arial" pitchFamily="34" charset="0"/>
-                <a:ea typeface="Arial" pitchFamily="34" charset="-122"/>
-                <a:cs typeface="Arial" pitchFamily="34" charset="-120"/>
-              </a:rPr>
-              <a:t>Every interaction makes yarnnn harder to replace and more valuable to keep.</a:t>
-            </a:r>
-            <a:endParaRPr lang="en-US" sz="1100" dirty="0"/>
+            <a:off x="685800" y="1486028"/>
+            <a:ext cx="4274507" cy="610259"/>
+          </a:xfrm>
+          <a:prstGeom prst="rect">
+            <a:avLst/>
+          </a:prstGeom>
+          <a:noFill/>
+          <a:ln/>
+        </p:spPr>
+        <p:txBody>
+          <a:bodyPr wrap="square" lIns="0" tIns="0" rIns="0" bIns="0" rtlCol="0" anchor="ctr"/>
+          <a:lstStyle/>
+          <a:p>
+            <a:pPr marL="0" indent="0">
+              <a:buNone/>
+            </a:pPr>
+            <a:r>
+              <a:rPr lang="en-US" sz="1200" b="1" dirty="0">
+                <a:latin typeface="Arial" pitchFamily="34" charset="0"/>
+                <a:ea typeface="Arial" pitchFamily="34" charset="-122"/>
+                <a:cs typeface="Arial" pitchFamily="34" charset="-120"/>
+              </a:rPr>
+              <a:t>Every agent run makes the next one better. </a:t>
+            </a:r>
+          </a:p>
+          <a:p>
+            <a:pPr marL="0" indent="0">
+              <a:buNone/>
+            </a:pPr>
+            <a:r>
+              <a:rPr lang="en-US" sz="1200" b="1" dirty="0">
+                <a:latin typeface="Arial" pitchFamily="34" charset="0"/>
+                <a:ea typeface="Arial" pitchFamily="34" charset="-122"/>
+                <a:cs typeface="Arial" pitchFamily="34" charset="-120"/>
+              </a:rPr>
+              <a:t>Every edit teaches the system. </a:t>
+            </a:r>
+          </a:p>
+          <a:p>
+            <a:pPr marL="0" indent="0">
+              <a:buNone/>
+            </a:pPr>
+            <a:r>
+              <a:rPr lang="en-US" sz="1200" b="1" dirty="0">
+                <a:latin typeface="Arial" pitchFamily="34" charset="0"/>
+                <a:ea typeface="Arial" pitchFamily="34" charset="-122"/>
+                <a:cs typeface="Arial" pitchFamily="34" charset="-120"/>
+              </a:rPr>
+              <a:t>Every sync deepens the knowledge base.</a:t>
+            </a:r>
+            <a:endParaRPr lang="en-US" sz="1200" b="1" dirty="0"/>
           </a:p>
         </p:txBody>
       </p:sp>
@@ -16837,7 +17366,7 @@
         </p:nvSpPr>
         <p:spPr>
           <a:xfrm>
-            <a:off x="926600" y="1930583"/>
+            <a:off x="713658" y="2261094"/>
             <a:ext cx="3657600" cy="274320"/>
           </a:xfrm>
           <a:prstGeom prst="rect">
@@ -16862,7 +17391,7 @@
                 <a:ea typeface="Arial" pitchFamily="34" charset="-122"/>
                 <a:cs typeface="Arial" pitchFamily="34" charset="-120"/>
               </a:rPr>
-              <a:t>Why This Creates a Moat:</a:t>
+              <a:t>Three moat mechanics:</a:t>
             </a:r>
             <a:endParaRPr lang="en-US" sz="1400" dirty="0"/>
           </a:p>
@@ -16876,7 +17405,7 @@
         </p:nvSpPr>
         <p:spPr>
           <a:xfrm>
-            <a:off x="1155200" y="2342063"/>
+            <a:off x="729316" y="2672574"/>
             <a:ext cx="274320" cy="274320"/>
           </a:xfrm>
           <a:prstGeom prst="line">
@@ -16903,7 +17432,7 @@
         </p:nvSpPr>
         <p:spPr>
           <a:xfrm>
-            <a:off x="1155200" y="2342063"/>
+            <a:off x="729316" y="2672574"/>
             <a:ext cx="274320" cy="274320"/>
           </a:xfrm>
           <a:prstGeom prst="rect">
@@ -16939,8 +17468,8 @@
         </p:nvSpPr>
         <p:spPr>
           <a:xfrm>
-            <a:off x="1612400" y="2342063"/>
-            <a:ext cx="3200400" cy="274320"/>
+            <a:off x="1186516" y="2697626"/>
+            <a:ext cx="3960000" cy="274320"/>
           </a:xfrm>
           <a:prstGeom prst="rect">
             <a:avLst/>
@@ -16964,7 +17493,7 @@
                 <a:ea typeface="Arial" pitchFamily="34" charset="-122"/>
                 <a:cs typeface="Arial" pitchFamily="34" charset="-120"/>
               </a:rPr>
-              <a:t>Accumulation: Every sync cycle deepens cross-platform understanding</a:t>
+              <a:t>Accumulation: Every sync cycle deepens cross-platform understanding. Agents don’t start from zero.</a:t>
             </a:r>
             <a:endParaRPr lang="en-US" sz="1100" dirty="0"/>
           </a:p>
@@ -16978,7 +17507,7 @@
         </p:nvSpPr>
         <p:spPr>
           <a:xfrm>
-            <a:off x="1155200" y="2799263"/>
+            <a:off x="729316" y="3129774"/>
             <a:ext cx="274320" cy="274320"/>
           </a:xfrm>
           <a:prstGeom prst="line">
@@ -17005,7 +17534,7 @@
         </p:nvSpPr>
         <p:spPr>
           <a:xfrm>
-            <a:off x="1155200" y="2799263"/>
+            <a:off x="729316" y="3129774"/>
             <a:ext cx="274320" cy="274320"/>
           </a:xfrm>
           <a:prstGeom prst="rect">
@@ -17041,8 +17570,8 @@
         </p:nvSpPr>
         <p:spPr>
           <a:xfrm>
-            <a:off x="1612400" y="2799263"/>
-            <a:ext cx="3200400" cy="274320"/>
+            <a:off x="1186516" y="3179878"/>
+            <a:ext cx="3960000" cy="274320"/>
           </a:xfrm>
           <a:prstGeom prst="rect">
             <a:avLst/>
@@ -17066,7 +17595,7 @@
                 <a:ea typeface="Arial" pitchFamily="34" charset="-122"/>
                 <a:cs typeface="Arial" pitchFamily="34" charset="-120"/>
               </a:rPr>
-              <a:t>Recursion: Your edits teach the system — output quality compounds</a:t>
+              <a:t>Recursion: Your edits and feedback train agent output quality. The 5th run needs fewer corrections than the 1st.</a:t>
             </a:r>
             <a:endParaRPr lang="en-US" sz="1100" dirty="0"/>
           </a:p>
@@ -17080,7 +17609,7 @@
         </p:nvSpPr>
         <p:spPr>
           <a:xfrm>
-            <a:off x="1155200" y="3256463"/>
+            <a:off x="729316" y="3586974"/>
             <a:ext cx="274320" cy="274320"/>
           </a:xfrm>
           <a:prstGeom prst="line">
@@ -17107,7 +17636,7 @@
         </p:nvSpPr>
         <p:spPr>
           <a:xfrm>
-            <a:off x="1155200" y="3256463"/>
+            <a:off x="729316" y="3586974"/>
             <a:ext cx="274320" cy="274320"/>
           </a:xfrm>
           <a:prstGeom prst="rect">
@@ -17143,8 +17672,8 @@
         </p:nvSpPr>
         <p:spPr>
           <a:xfrm>
-            <a:off x="1612400" y="3256463"/>
-            <a:ext cx="3200400" cy="274320"/>
+            <a:off x="1186516" y="3649604"/>
+            <a:ext cx="3960000" cy="274320"/>
           </a:xfrm>
           <a:prstGeom prst="rect">
             <a:avLst/>
@@ -17168,7 +17697,7 @@
                 <a:ea typeface="Arial" pitchFamily="34" charset="-122"/>
                 <a:cs typeface="Arial" pitchFamily="34" charset="-120"/>
               </a:rPr>
-              <a:t>Switching costs: 90 days of context is irreplaceable by any competitor</a:t>
+              <a:t>Irreversibility: 90 days of accumulated knowledge can’t be exported or replicated. Switching means starting over.</a:t>
             </a:r>
             <a:endParaRPr lang="en-US" sz="1100" dirty="0"/>
           </a:p>
@@ -17182,7 +17711,7 @@
         </p:nvSpPr>
         <p:spPr>
           <a:xfrm>
-            <a:off x="1155200" y="3713663"/>
+            <a:off x="729316" y="4044174"/>
             <a:ext cx="274320" cy="274320"/>
           </a:xfrm>
           <a:prstGeom prst="line">
@@ -17209,7 +17738,7 @@
         </p:nvSpPr>
         <p:spPr>
           <a:xfrm>
-            <a:off x="1155200" y="3713663"/>
+            <a:off x="729316" y="4044174"/>
             <a:ext cx="274320" cy="274320"/>
           </a:xfrm>
           <a:prstGeom prst="rect">
@@ -17231,7 +17760,7 @@
                 <a:ea typeface="Arial" pitchFamily="34" charset="-122"/>
                 <a:cs typeface="Arial" pitchFamily="34" charset="-120"/>
               </a:rPr>
-              <a:t>4</a:t>
+              <a:t> </a:t>
             </a:r>
             <a:endParaRPr lang="en-US" sz="1100" dirty="0"/>
           </a:p>
@@ -17245,7 +17774,7 @@
         </p:nvSpPr>
         <p:spPr>
           <a:xfrm>
-            <a:off x="1612400" y="3713663"/>
+            <a:off x="1186516" y="4044174"/>
             <a:ext cx="3200400" cy="274320"/>
           </a:xfrm>
           <a:prstGeom prst="rect">
@@ -17270,7 +17799,7 @@
                 <a:ea typeface="Arial" pitchFamily="34" charset="-122"/>
                 <a:cs typeface="Arial" pitchFamily="34" charset="-120"/>
               </a:rPr>
-              <a:t>Lock-in: Deliverables depend on accumulated context — not transferable</a:t>
+              <a:t> </a:t>
             </a:r>
             <a:endParaRPr lang="en-US" sz="1100" dirty="0"/>
           </a:p>
@@ -17395,7 +17924,7 @@
                 <a:ea typeface="Arial" pitchFamily="34" charset="-122"/>
                 <a:cs typeface="Arial" pitchFamily="34" charset="-120"/>
               </a:rPr>
-              <a:t>Context syncs</a:t>
+              <a:t>Knowledge syncs</a:t>
             </a:r>
             <a:endParaRPr lang="en-KR" sz="700" dirty="0"/>
           </a:p>

</xml_diff>

<commit_message>
content: add agent protocol stack post + update IR deck (March 2026 v2)
Co-Authored-By: Claude Opus 4.6 <noreply@anthropic.com>
</commit_message>
<xml_diff>
--- a/docs/working_docs/investors/IR Deck - yarnnn - March 2026.pptx
+++ b/docs/working_docs/investors/IR Deck - yarnnn - March 2026.pptx
@@ -17,15 +17,15 @@
     <p:sldId id="263" r:id="rId8"/>
     <p:sldId id="260" r:id="rId9"/>
     <p:sldId id="262" r:id="rId10"/>
-    <p:sldId id="273" r:id="rId11"/>
-    <p:sldId id="277" r:id="rId12"/>
-    <p:sldId id="266" r:id="rId13"/>
-    <p:sldId id="269" r:id="rId14"/>
-    <p:sldId id="270" r:id="rId15"/>
-    <p:sldId id="272" r:id="rId16"/>
-    <p:sldId id="278" r:id="rId17"/>
-    <p:sldId id="279" r:id="rId18"/>
-    <p:sldId id="261" r:id="rId19"/>
+    <p:sldId id="261" r:id="rId11"/>
+    <p:sldId id="273" r:id="rId12"/>
+    <p:sldId id="277" r:id="rId13"/>
+    <p:sldId id="266" r:id="rId14"/>
+    <p:sldId id="269" r:id="rId15"/>
+    <p:sldId id="270" r:id="rId16"/>
+    <p:sldId id="272" r:id="rId17"/>
+    <p:sldId id="278" r:id="rId18"/>
+    <p:sldId id="279" r:id="rId19"/>
   </p:sldIdLst>
   <p:sldSz cx="9144000" cy="5143500" type="screen16x9"/>
   <p:notesSz cx="5143500" cy="9144000"/>
@@ -942,7 +942,7 @@
     <dgm:pt modelId="{3475EFB5-6545-5444-B3CA-6FCE5209FEC5}" type="doc">
       <dgm:prSet loTypeId="urn:microsoft.com/office/officeart/2005/8/layout/cycle2" loCatId="" qsTypeId="urn:microsoft.com/office/officeart/2005/8/quickstyle/simple1" qsCatId="simple" csTypeId="urn:microsoft.com/office/officeart/2005/8/colors/accent0_1" csCatId="mainScheme" phldr="1"/>
       <dgm:spPr/>
-      <dgm:t>
+      <dgm:t xml:space="preserve">
         <a:bodyPr/>
         <a:lstStyle/>
         <a:p>
@@ -953,7 +953,7 @@
     <dgm:pt modelId="{94D0CE6A-B567-424E-ADD1-914866CB5499}">
       <dgm:prSet phldrT="[Text]"/>
       <dgm:spPr/>
-      <dgm:t>
+      <dgm:t xml:space="preserve">
         <a:bodyPr/>
         <a:lstStyle/>
         <a:p>
@@ -967,7 +967,7 @@
     <dgm:pt modelId="{13793F0F-94FA-F443-BA21-6B58B9BFA631}" type="parTrans" cxnId="{9B9FED14-CA6A-3C4B-9E35-B5C478BC5B5A}">
       <dgm:prSet/>
       <dgm:spPr/>
-      <dgm:t>
+      <dgm:t xml:space="preserve">
         <a:bodyPr/>
         <a:lstStyle/>
         <a:p>
@@ -978,7 +978,7 @@
     <dgm:pt modelId="{D76EC4C4-D4DC-EB44-B0A9-DBDBC65462FC}" type="sibTrans" cxnId="{9B9FED14-CA6A-3C4B-9E35-B5C478BC5B5A}">
       <dgm:prSet/>
       <dgm:spPr/>
-      <dgm:t>
+      <dgm:t xml:space="preserve">
         <a:bodyPr/>
         <a:lstStyle/>
         <a:p>
@@ -989,7 +989,7 @@
     <dgm:pt modelId="{96B892F0-DB33-A241-AE5E-C18BC679580A}">
       <dgm:prSet phldrT="[Text]"/>
       <dgm:spPr/>
-      <dgm:t>
+      <dgm:t xml:space="preserve">
         <a:bodyPr/>
         <a:lstStyle/>
         <a:p>
@@ -1003,7 +1003,7 @@
     <dgm:pt modelId="{069FFB75-0FE1-7143-A922-FE565E1EC6EB}" type="parTrans" cxnId="{23C26AD3-2DED-1544-9BE0-EF11D0437E70}">
       <dgm:prSet/>
       <dgm:spPr/>
-      <dgm:t>
+      <dgm:t xml:space="preserve">
         <a:bodyPr/>
         <a:lstStyle/>
         <a:p>
@@ -1014,7 +1014,7 @@
     <dgm:pt modelId="{8D10FAA7-DADF-ED42-927B-A8C34D42C0E9}" type="sibTrans" cxnId="{23C26AD3-2DED-1544-9BE0-EF11D0437E70}">
       <dgm:prSet/>
       <dgm:spPr/>
-      <dgm:t>
+      <dgm:t xml:space="preserve">
         <a:bodyPr/>
         <a:lstStyle/>
         <a:p>
@@ -1025,7 +1025,7 @@
     <dgm:pt modelId="{A7B3F113-682D-7E46-BBD5-013F0B177322}">
       <dgm:prSet phldrT="[Text]"/>
       <dgm:spPr/>
-      <dgm:t>
+      <dgm:t xml:space="preserve">
         <a:bodyPr/>
         <a:lstStyle/>
         <a:p>
@@ -1039,7 +1039,7 @@
     <dgm:pt modelId="{A7AF438A-2AF8-8D43-A712-F82685C02488}" type="parTrans" cxnId="{FA1E47CF-8216-FC4D-B89C-A47D10451EF0}">
       <dgm:prSet/>
       <dgm:spPr/>
-      <dgm:t>
+      <dgm:t xml:space="preserve">
         <a:bodyPr/>
         <a:lstStyle/>
         <a:p>
@@ -1050,7 +1050,7 @@
     <dgm:pt modelId="{A1B0231E-AAB7-2948-A805-41F69AA79600}" type="sibTrans" cxnId="{FA1E47CF-8216-FC4D-B89C-A47D10451EF0}">
       <dgm:prSet/>
       <dgm:spPr/>
-      <dgm:t>
+      <dgm:t xml:space="preserve">
         <a:bodyPr/>
         <a:lstStyle/>
         <a:p>
@@ -1061,7 +1061,7 @@
     <dgm:pt modelId="{005126F7-5330-5C43-AD97-2D8EC3A3A550}">
       <dgm:prSet phldrT="[Text]"/>
       <dgm:spPr/>
-      <dgm:t>
+      <dgm:t xml:space="preserve">
         <a:bodyPr/>
         <a:lstStyle/>
         <a:p>
@@ -1075,7 +1075,7 @@
     <dgm:pt modelId="{0D8280E4-C59B-F241-AC3E-904DA2B48F33}" type="parTrans" cxnId="{9281CDA1-274A-384A-A131-1F091B50BAF6}">
       <dgm:prSet/>
       <dgm:spPr/>
-      <dgm:t>
+      <dgm:t xml:space="preserve">
         <a:bodyPr/>
         <a:lstStyle/>
         <a:p>
@@ -1086,7 +1086,7 @@
     <dgm:pt modelId="{83AFFC27-0BB1-A047-BC04-733FBB9A13BA}" type="sibTrans" cxnId="{9281CDA1-274A-384A-A131-1F091B50BAF6}">
       <dgm:prSet/>
       <dgm:spPr/>
-      <dgm:t>
+      <dgm:t xml:space="preserve">
         <a:bodyPr/>
         <a:lstStyle/>
         <a:p>
@@ -3541,7 +3541,7 @@
     </p:spTree>
     <p:extLst>
       <p:ext uri="{BB962C8B-B14F-4D97-AF65-F5344CB8AC3E}">
-        <p14:creationId xmlns:p14="http://schemas.microsoft.com/office/powerpoint/2010/main" val="3439085272"/>
+        <p14:creationId xmlns:p14="http://schemas.microsoft.com/office/powerpoint/2010/main" val="1024086991"/>
       </p:ext>
     </p:extLst>
   </p:cSld>
@@ -3632,7 +3632,7 @@
     </p:spTree>
     <p:extLst>
       <p:ext uri="{BB962C8B-B14F-4D97-AF65-F5344CB8AC3E}">
-        <p14:creationId xmlns:p14="http://schemas.microsoft.com/office/powerpoint/2010/main" val="1024086991"/>
+        <p14:creationId xmlns:p14="http://schemas.microsoft.com/office/powerpoint/2010/main" val="3439085272"/>
       </p:ext>
     </p:extLst>
   </p:cSld>
@@ -3714,7 +3714,7 @@
           <a:p>
             <a:fld id="{F7021451-1387-4CA6-816F-3879F97B5CBC}" type="slidenum">
               <a:rPr lang="en-US"/>
-              <a:t>17</a:t>
+              <a:t>16</a:t>
             </a:fld>
             <a:endParaRPr lang="en-US"/>
           </a:p>
@@ -3814,7 +3814,7 @@
     </p:spTree>
     <p:extLst>
       <p:ext uri="{BB962C8B-B14F-4D97-AF65-F5344CB8AC3E}">
-        <p14:creationId xmlns:p14="http://schemas.microsoft.com/office/powerpoint/2010/main" val="3580186496"/>
+        <p14:creationId xmlns:p14="http://schemas.microsoft.com/office/powerpoint/2010/main" val="1024086991"/>
       </p:ext>
     </p:extLst>
   </p:cSld>
@@ -4533,7 +4533,7 @@
           <a:p>
             <a:fld id="{F7021451-1387-4CA6-816F-3879F97B5CBC}" type="slidenum">
               <a:rPr lang="en-US"/>
-              <a:t>11</a:t>
+              <a:t>10</a:t>
             </a:fld>
             <a:endParaRPr lang="en-US"/>
           </a:p>
@@ -5155,6 +5155,537 @@
     <p:bg>
       <p:bgPr>
         <a:solidFill>
+          <a:srgbClr val="FFFFFF"/>
+        </a:solidFill>
+        <a:effectLst/>
+      </p:bgPr>
+    </p:bg>
+    <p:spTree>
+      <p:nvGrpSpPr>
+        <p:cNvPr id="1" name="Slide 9"/>
+        <p:cNvGrpSpPr/>
+        <p:nvPr/>
+      </p:nvGrpSpPr>
+      <p:grpSpPr>
+        <a:xfrm>
+          <a:off x="0" y="0"/>
+          <a:ext cx="9144000" cy="5143500"/>
+          <a:chOff x="0" y="0"/>
+          <a:chExt cx="9144000" cy="5143500"/>
+        </a:xfrm>
+      </p:grpSpPr>
+      <p:sp>
+        <p:nvSpPr>
+          <p:cNvPr id="2" name="Section Label"/>
+          <p:cNvSpPr/>
+          <p:nvPr/>
+        </p:nvSpPr>
+        <p:spPr>
+          <a:xfrm>
+            <a:off x="685800" y="457200"/>
+            <a:ext cx="2000000" cy="274320"/>
+          </a:xfrm>
+          <a:prstGeom prst="rect">
+            <a:avLst/>
+          </a:prstGeom>
+          <a:noFill/>
+          <a:ln/>
+        </p:spPr>
+        <p:txBody>
+          <a:bodyPr wrap="square" lIns="0" tIns="0" rIns="0" bIns="0" rtlCol="0" anchor="ctr"/>
+          <a:lstStyle/>
+          <a:p>
+            <a:pPr marL="0" indent="0">
+              <a:buNone/>
+            </a:pPr>
+            <a:r>
+              <a:rPr lang="en-US" sz="1100" b="1" dirty="0">
+                <a:solidFill>
+                  <a:srgbClr val="E8985E"/>
+                </a:solidFill>
+                <a:latin typeface="Arial" pitchFamily="34" charset="0"/>
+                <a:ea typeface="Arial" pitchFamily="34" charset="-122"/>
+                <a:cs typeface="Arial" pitchFamily="34" charset="-120"/>
+              </a:rPr>
+              <a:t>Product</a:t>
+            </a:r>
+          </a:p>
+        </p:txBody>
+      </p:sp>
+      <p:sp>
+        <p:nvSpPr>
+          <p:cNvPr id="3" name="Title"/>
+          <p:cNvSpPr/>
+          <p:nvPr/>
+        </p:nvSpPr>
+        <p:spPr>
+          <a:xfrm>
+            <a:off x="685800" y="777240"/>
+            <a:ext cx="7772400" cy="457200"/>
+          </a:xfrm>
+          <a:prstGeom prst="rect">
+            <a:avLst/>
+          </a:prstGeom>
+          <a:noFill/>
+          <a:ln/>
+        </p:spPr>
+        <p:txBody>
+          <a:bodyPr wrap="square" lIns="0" tIns="0" rIns="0" bIns="0" rtlCol="0" anchor="ctr"/>
+          <a:lstStyle/>
+          <a:p>
+            <a:pPr marL="0" indent="0">
+              <a:buNone/>
+            </a:pPr>
+            <a:r>
+              <a:rPr lang="en-US" sz="2400" b="1" dirty="0">
+                <a:solidFill>
+                  <a:srgbClr val="111111"/>
+                </a:solidFill>
+                <a:latin typeface="Arial" pitchFamily="34" charset="0"/>
+                <a:ea typeface="Arial" pitchFamily="34" charset="-122"/>
+                <a:cs typeface="Arial" pitchFamily="34" charset="-120"/>
+              </a:rPr>
+              <a:t>What YARNNN Replaces</a:t>
+            </a:r>
+          </a:p>
+        </p:txBody>
+      </p:sp>
+      <p:sp>
+        <p:nvSpPr>
+          <p:cNvPr id="4" name="Subtitle"/>
+          <p:cNvSpPr/>
+          <p:nvPr/>
+        </p:nvSpPr>
+        <p:spPr>
+          <a:xfrm>
+            <a:off x="685800" y="1371600"/>
+            <a:ext cx="7772400" cy="274320"/>
+          </a:xfrm>
+          <a:prstGeom prst="rect">
+            <a:avLst/>
+          </a:prstGeom>
+          <a:noFill/>
+          <a:ln/>
+        </p:spPr>
+        <p:txBody>
+          <a:bodyPr wrap="square" lIns="0" tIns="0" rIns="0" bIns="0" rtlCol="0" anchor="ctr"/>
+          <a:lstStyle/>
+          <a:p>
+            <a:pPr marL="0" indent="0">
+              <a:buNone/>
+            </a:pPr>
+            <a:r>
+              <a:rPr lang="en-US" sz="1100" dirty="0">
+                <a:solidFill>
+                  <a:srgbClr val="666666"/>
+                </a:solidFill>
+                <a:latin typeface="Arial" pitchFamily="34" charset="0"/>
+                <a:ea typeface="Arial" pitchFamily="34" charset="-122"/>
+                <a:cs typeface="Arial" pitchFamily="34" charset="-120"/>
+              </a:rPr>
+              <a:t>Three real workflows. Before: manual, fragmented, time-consuming. After: autonomous, cross-platform, improving.</a:t>
+            </a:r>
+          </a:p>
+        </p:txBody>
+      </p:sp>
+      <p:sp>
+        <p:nvSpPr>
+          <p:cNvPr id="5" name="Card1"/>
+          <p:cNvSpPr/>
+          <p:nvPr/>
+        </p:nvSpPr>
+        <p:spPr>
+          <a:xfrm>
+            <a:off x="685800" y="1970843"/>
+            <a:ext cx="2200000" cy="1700000"/>
+          </a:xfrm>
+          <a:prstGeom prst="rect">
+            <a:avLst/>
+          </a:prstGeom>
+          <a:solidFill>
+            <a:srgbClr val="F8F8F8"/>
+          </a:solidFill>
+          <a:ln>
+            <a:solidFill>
+              <a:srgbClr val="DEDEDE"/>
+            </a:solidFill>
+            <a:prstDash val="solid"/>
+            <a:round/>
+          </a:ln>
+        </p:spPr>
+        <p:txBody>
+          <a:bodyPr wrap="square" lIns="91440" tIns="45720" rIns="91440" bIns="45720" rtlCol="0" anchor="t"/>
+          <a:lstStyle/>
+          <a:p>
+            <a:pPr marL="0" indent="0">
+              <a:buNone/>
+            </a:pPr>
+            <a:r>
+              <a:rPr lang="en-US" sz="1100" b="1" dirty="0">
+                <a:solidFill>
+                  <a:srgbClr val="111111"/>
+                </a:solidFill>
+                <a:latin typeface="Arial" pitchFamily="34" charset="0"/>
+                <a:ea typeface="Arial" pitchFamily="34" charset="-122"/>
+                <a:cs typeface="Arial" pitchFamily="34" charset="-120"/>
+              </a:rPr>
+              <a:t>BEFORE: Monday Catchup</a:t>
+            </a:r>
+          </a:p>
+          <a:p>
+            <a:pPr marL="0" indent="0">
+              <a:buNone/>
+            </a:pPr>
+            <a:r>
+              <a:rPr lang="en-US" sz="900" dirty="0">
+                <a:solidFill>
+                  <a:srgbClr val="666666"/>
+                </a:solidFill>
+                <a:latin typeface="Arial" pitchFamily="34" charset="0"/>
+                <a:ea typeface="Arial" pitchFamily="34" charset="-122"/>
+                <a:cs typeface="Arial" pitchFamily="34" charset="-120"/>
+              </a:rPr>
+              <a:t>Open Slack. Scroll 14 channels. Open Gmail. Scan 40 emails. 45 minutes gone.</a:t>
+            </a:r>
+          </a:p>
+          <a:p>
+            <a:pPr marL="0" indent="0">
+              <a:buNone/>
+            </a:pPr>
+            <a:r>
+              <a:rPr lang="en-US" sz="900" b="1" dirty="0">
+                <a:solidFill>
+                  <a:srgbClr val="E8985E"/>
+                </a:solidFill>
+                <a:latin typeface="Arial" pitchFamily="34" charset="0"/>
+                <a:ea typeface="Arial" pitchFamily="34" charset="-122"/>
+                <a:cs typeface="Arial" pitchFamily="34" charset="-120"/>
+              </a:rPr>
+              <a:t>AFTER: Recap Agent</a:t>
+            </a:r>
+          </a:p>
+          <a:p>
+            <a:pPr marL="0" indent="0">
+              <a:buNone/>
+            </a:pPr>
+            <a:r>
+              <a:rPr lang="en-US" sz="900" dirty="0">
+                <a:solidFill>
+                  <a:srgbClr val="666666"/>
+                </a:solidFill>
+                <a:latin typeface="Arial" pitchFamily="34" charset="0"/>
+                <a:ea typeface="Arial" pitchFamily="34" charset="-122"/>
+                <a:cs typeface="Arial" pitchFamily="34" charset="-120"/>
+              </a:rPr>
+              <a:t>One brief. All platforms. Waiting at 8am. 0 minutes of your time.</a:t>
+            </a:r>
+          </a:p>
+        </p:txBody>
+      </p:sp>
+      <p:sp>
+        <p:nvSpPr>
+          <p:cNvPr id="6" name="Arrow1"/>
+          <p:cNvSpPr/>
+          <p:nvPr/>
+        </p:nvSpPr>
+        <p:spPr>
+          <a:xfrm>
+            <a:off x="2985800" y="2337043"/>
+            <a:ext cx="350000" cy="200000"/>
+          </a:xfrm>
+          <a:prstGeom prst="rightArrow">
+            <a:avLst/>
+          </a:prstGeom>
+          <a:solidFill>
+            <a:srgbClr val="E8985E"/>
+          </a:solidFill>
+          <a:ln>
+            <a:noFill/>
+          </a:ln>
+        </p:spPr>
+        <p:txBody>
+          <a:bodyPr wrap="square" lIns="0" tIns="0" rIns="0" bIns="0" rtlCol="0" anchor="ctr"/>
+          <a:lstStyle/>
+          <a:p>
+            <a:pPr marL="0" indent="0">
+              <a:buNone/>
+            </a:pPr>
+            <a:endParaRPr/>
+          </a:p>
+        </p:txBody>
+      </p:sp>
+      <p:sp>
+        <p:nvSpPr>
+          <p:cNvPr id="7" name="Card2"/>
+          <p:cNvSpPr/>
+          <p:nvPr/>
+        </p:nvSpPr>
+        <p:spPr>
+          <a:xfrm>
+            <a:off x="3435800" y="1970843"/>
+            <a:ext cx="2200000" cy="1700000"/>
+          </a:xfrm>
+          <a:prstGeom prst="rect">
+            <a:avLst/>
+          </a:prstGeom>
+          <a:solidFill>
+            <a:srgbClr val="E8985E"/>
+          </a:solidFill>
+          <a:ln>
+            <a:solidFill>
+              <a:srgbClr val="E8985E"/>
+            </a:solidFill>
+            <a:prstDash val="solid"/>
+            <a:round/>
+          </a:ln>
+        </p:spPr>
+        <p:txBody>
+          <a:bodyPr wrap="square" lIns="91440" tIns="45720" rIns="91440" bIns="45720" rtlCol="0" anchor="t"/>
+          <a:lstStyle/>
+          <a:p>
+            <a:pPr marL="0" indent="0">
+              <a:buNone/>
+            </a:pPr>
+            <a:r>
+              <a:rPr lang="en-US" sz="1100" b="1" dirty="0">
+                <a:solidFill>
+                  <a:srgbClr val="FFFFFF"/>
+                </a:solidFill>
+                <a:latin typeface="Arial" pitchFamily="34" charset="0"/>
+                <a:ea typeface="Arial" pitchFamily="34" charset="-122"/>
+                <a:cs typeface="Arial" pitchFamily="34" charset="-120"/>
+              </a:rPr>
+              <a:t>BEFORE: Client Status Update</a:t>
+            </a:r>
+          </a:p>
+          <a:p>
+            <a:pPr marL="0" indent="0">
+              <a:buNone/>
+            </a:pPr>
+            <a:r>
+              <a:rPr lang="en-US" sz="900" i="1" dirty="0">
+                <a:solidFill>
+                  <a:srgbClr val="FFFFFF"/>
+                </a:solidFill>
+                <a:latin typeface="Arial" pitchFamily="34" charset="0"/>
+                <a:ea typeface="Arial" pitchFamily="34" charset="-122"/>
+                <a:cs typeface="Arial" pitchFamily="34" charset="-120"/>
+              </a:rPr>
+              <a:t>Copy from Slack. Paste into doc. Check Gmail. Rewrite for client tone. 2 hours, every week.</a:t>
+            </a:r>
+          </a:p>
+          <a:p>
+            <a:pPr marL="0" indent="0">
+              <a:buNone/>
+            </a:pPr>
+            <a:r>
+              <a:rPr lang="en-US" sz="900" dirty="0">
+                <a:solidFill>
+                  <a:srgbClr val="FFFFFF"/>
+                </a:solidFill>
+                <a:latin typeface="Arial" pitchFamily="34" charset="0"/>
+                <a:ea typeface="Arial" pitchFamily="34" charset="-122"/>
+                <a:cs typeface="Arial" pitchFamily="34" charset="-120"/>
+              </a:rPr>
+              <a:t>AFTER: Status Agent</a:t>
+            </a:r>
+          </a:p>
+          <a:p>
+            <a:pPr marL="0" indent="0">
+              <a:buNone/>
+            </a:pPr>
+            <a:r>
+              <a:rPr lang="en-US" sz="900" dirty="0">
+                <a:solidFill>
+                  <a:srgbClr val="FFFFFF"/>
+                </a:solidFill>
+                <a:latin typeface="Arial" pitchFamily="34" charset="0"/>
+                <a:ea typeface="Arial" pitchFamily="34" charset="-122"/>
+                <a:cs typeface="Arial" pitchFamily="34" charset="-120"/>
+              </a:rPr>
+              <a:t>Pulls from all platforms. 12 weeks of accumulated context. Draft arrives Friday 5pm.</a:t>
+            </a:r>
+          </a:p>
+        </p:txBody>
+      </p:sp>
+      <p:sp>
+        <p:nvSpPr>
+          <p:cNvPr id="8" name="Arrow2"/>
+          <p:cNvSpPr/>
+          <p:nvPr/>
+        </p:nvSpPr>
+        <p:spPr>
+          <a:xfrm>
+            <a:off x="5735800" y="2337043"/>
+            <a:ext cx="350000" cy="200000"/>
+          </a:xfrm>
+          <a:prstGeom prst="rightArrow">
+            <a:avLst/>
+          </a:prstGeom>
+          <a:solidFill>
+            <a:srgbClr val="E8985E"/>
+          </a:solidFill>
+          <a:ln>
+            <a:noFill/>
+          </a:ln>
+        </p:spPr>
+        <p:txBody>
+          <a:bodyPr wrap="square" lIns="0" tIns="0" rIns="0" bIns="0" rtlCol="0" anchor="ctr"/>
+          <a:lstStyle/>
+          <a:p>
+            <a:pPr marL="0" indent="0">
+              <a:buNone/>
+            </a:pPr>
+            <a:endParaRPr/>
+          </a:p>
+        </p:txBody>
+      </p:sp>
+      <p:sp>
+        <p:nvSpPr>
+          <p:cNvPr id="9" name="Card3"/>
+          <p:cNvSpPr/>
+          <p:nvPr/>
+        </p:nvSpPr>
+        <p:spPr>
+          <a:xfrm>
+            <a:off x="6185800" y="1970843"/>
+            <a:ext cx="2200000" cy="1700000"/>
+          </a:xfrm>
+          <a:prstGeom prst="rect">
+            <a:avLst/>
+          </a:prstGeom>
+          <a:solidFill>
+            <a:srgbClr val="F8F8F8"/>
+          </a:solidFill>
+          <a:ln>
+            <a:solidFill>
+              <a:srgbClr val="DEDEDE"/>
+            </a:solidFill>
+            <a:prstDash val="solid"/>
+            <a:round/>
+          </a:ln>
+        </p:spPr>
+        <p:txBody>
+          <a:bodyPr wrap="square" lIns="91440" tIns="45720" rIns="91440" bIns="45720" rtlCol="0" anchor="t"/>
+          <a:lstStyle/>
+          <a:p>
+            <a:pPr marL="0" indent="0">
+              <a:buNone/>
+            </a:pPr>
+            <a:r>
+              <a:rPr lang="en-US" sz="1100" b="1" dirty="0">
+                <a:solidFill>
+                  <a:srgbClr val="111111"/>
+                </a:solidFill>
+                <a:latin typeface="Arial" pitchFamily="34" charset="0"/>
+                <a:ea typeface="Arial" pitchFamily="34" charset="-122"/>
+                <a:cs typeface="Arial" pitchFamily="34" charset="-120"/>
+              </a:rPr>
+              <a:t>BEFORE: Meeting Prep</a:t>
+            </a:r>
+          </a:p>
+          <a:p>
+            <a:pPr marL="0" indent="0">
+              <a:buNone/>
+            </a:pPr>
+            <a:r>
+              <a:rPr lang="en-US" sz="900" dirty="0">
+                <a:solidFill>
+                  <a:srgbClr val="666666"/>
+                </a:solidFill>
+                <a:latin typeface="Arial" pitchFamily="34" charset="0"/>
+                <a:ea typeface="Arial" pitchFamily="34" charset="-122"/>
+                <a:cs typeface="Arial" pitchFamily="34" charset="-120"/>
+              </a:rPr>
+              <a:t>Search Slack. Search Gmail. Check LinkedIn. Skim Notion. Scramble 10 minutes before the call.</a:t>
+            </a:r>
+          </a:p>
+          <a:p>
+            <a:pPr marL="0" indent="0">
+              <a:buNone/>
+            </a:pPr>
+            <a:r>
+              <a:rPr lang="en-US" sz="900" b="1" dirty="0">
+                <a:solidFill>
+                  <a:srgbClr val="E8985E"/>
+                </a:solidFill>
+                <a:latin typeface="Arial" pitchFamily="34" charset="0"/>
+                <a:ea typeface="Arial" pitchFamily="34" charset="-122"/>
+                <a:cs typeface="Arial" pitchFamily="34" charset="-120"/>
+              </a:rPr>
+              <a:t>AFTER: Meeting Prep Agent</a:t>
+            </a:r>
+          </a:p>
+          <a:p>
+            <a:pPr marL="0" indent="0">
+              <a:buNone/>
+            </a:pPr>
+            <a:r>
+              <a:rPr lang="en-US" sz="900" dirty="0">
+                <a:solidFill>
+                  <a:srgbClr val="666666"/>
+                </a:solidFill>
+                <a:latin typeface="Arial" pitchFamily="34" charset="0"/>
+                <a:ea typeface="Arial" pitchFamily="34" charset="-122"/>
+                <a:cs typeface="Arial" pitchFamily="34" charset="-120"/>
+              </a:rPr>
+              <a:t>Brief auto-generated from calendar. Full context. Delivered 30 min before. Every time.</a:t>
+            </a:r>
+          </a:p>
+        </p:txBody>
+      </p:sp>
+      <p:sp>
+        <p:nvSpPr>
+          <p:cNvPr id="10" name="Bottom Insight"/>
+          <p:cNvSpPr/>
+          <p:nvPr/>
+        </p:nvSpPr>
+        <p:spPr>
+          <a:xfrm>
+            <a:off x="685800" y="4572000"/>
+            <a:ext cx="7772400" cy="274320"/>
+          </a:xfrm>
+          <a:prstGeom prst="rect">
+            <a:avLst/>
+          </a:prstGeom>
+          <a:noFill/>
+          <a:ln/>
+        </p:spPr>
+        <p:txBody>
+          <a:bodyPr wrap="square" lIns="0" tIns="0" rIns="0" bIns="0" rtlCol="0" anchor="ctr"/>
+          <a:lstStyle/>
+          <a:p>
+            <a:pPr marL="0" indent="0" algn="ctr">
+              <a:buNone/>
+            </a:pPr>
+            <a:r>
+              <a:rPr lang="en-US" sz="900" i="1" dirty="0">
+                <a:solidFill>
+                  <a:srgbClr val="E8985E"/>
+                </a:solidFill>
+                <a:latin typeface="Arial" pitchFamily="34" charset="0"/>
+                <a:ea typeface="Arial" pitchFamily="34" charset="-122"/>
+                <a:cs typeface="Arial" pitchFamily="34" charset="-120"/>
+              </a:rPr>
+              <a:t>Every agent gets better with tenure. The 12th weekly update needs zero corrections.</a:t>
+            </a:r>
+          </a:p>
+        </p:txBody>
+      </p:sp>
+    </p:spTree>
+  </p:cSld>
+  <p:clrMapOvr>
+    <a:masterClrMapping/>
+  </p:clrMapOvr>
+</p:sld>
+</file>
+
+<file path=ppt/slides/slide11.xml><?xml version="1.0" encoding="utf-8"?>
+<p:sld xmlns:a="http://schemas.openxmlformats.org/drawingml/2006/main" xmlns:r="http://schemas.openxmlformats.org/officeDocument/2006/relationships" xmlns:p="http://schemas.openxmlformats.org/presentationml/2006/main">
+  <p:cSld>
+    <p:bg>
+      <p:bgPr>
+        <a:solidFill>
           <a:srgbClr val="111111"/>
         </a:solidFill>
         <a:effectLst/>
@@ -5207,7 +5738,7 @@
                 <a:ea typeface="Arial" pitchFamily="34" charset="-122"/>
                 <a:cs typeface="Arial" pitchFamily="34" charset="-120"/>
               </a:rPr>
-              <a:t>Positioning  •  Market  •  </a:t>
+              <a:t xml:space="preserve">Positioning  •  Market  •  </a:t>
             </a:r>
           </a:p>
           <a:p>
@@ -5271,7 +5802,7 @@
 </p:sld>
 </file>
 
-<file path=ppt/slides/slide11.xml><?xml version="1.0" encoding="utf-8"?>
+<file path=ppt/slides/slide12.xml><?xml version="1.0" encoding="utf-8"?>
 <p:sld xmlns:a="http://schemas.openxmlformats.org/drawingml/2006/main" xmlns:r="http://schemas.openxmlformats.org/officeDocument/2006/relationships" xmlns:p="http://schemas.openxmlformats.org/presentationml/2006/main">
   <p:cSld>
     <p:spTree>
@@ -5479,7 +6010,7 @@
                 <a:latin typeface="Arial" pitchFamily="34" charset="0"/>
                 <a:cs typeface="Arial" pitchFamily="34" charset="-120"/>
               </a:rPr>
-              <a:t>, </a:t>
+              <a:t xml:space="preserve">, </a:t>
             </a:r>
             <a:r>
               <a:rPr lang="en-US" sz="800" dirty="0" err="1">
@@ -5661,7 +6192,7 @@
                 <a:ea typeface="Arial" pitchFamily="34" charset="-122"/>
                 <a:cs typeface="Arial" pitchFamily="34" charset="-120"/>
               </a:rPr>
-              <a:t>Cross-platform </a:t>
+              <a:t xml:space="preserve">Cross-platform </a:t>
             </a:r>
             <a:br>
               <a:rPr lang="en-US" sz="900" dirty="0">
@@ -7141,7 +7672,7 @@
                 <a:ea typeface="Arial" pitchFamily="34" charset="-122"/>
                 <a:cs typeface="Arial" pitchFamily="34" charset="-120"/>
               </a:rPr>
-              <a:t> </a:t>
+              <a:t xml:space="preserve"> </a:t>
             </a:r>
             <a:r>
               <a:rPr lang="en-US" altLang="ko-KR" sz="800" b="1" dirty="0" err="1">
@@ -7163,7 +7694,7 @@
                 <a:ea typeface="Arial" pitchFamily="34" charset="-122"/>
                 <a:cs typeface="Arial" pitchFamily="34" charset="-120"/>
               </a:rPr>
-              <a:t> / </a:t>
+              <a:t xml:space="preserve"> / </a:t>
             </a:r>
             <a:r>
               <a:rPr lang="en-US" sz="800" b="1" dirty="0" err="1">
@@ -7195,7 +7726,7 @@
 </p:sld>
 </file>
 
-<file path=ppt/slides/slide12.xml><?xml version="1.0" encoding="utf-8"?>
+<file path=ppt/slides/slide13.xml><?xml version="1.0" encoding="utf-8"?>
 <p:sld xmlns:a="http://schemas.openxmlformats.org/drawingml/2006/main" xmlns:r="http://schemas.openxmlformats.org/officeDocument/2006/relationships" xmlns:p="http://schemas.openxmlformats.org/presentationml/2006/main">
   <p:cSld name="Slide 11">
     <p:bg>
@@ -8365,7 +8896,7 @@
 </p:sld>
 </file>
 
-<file path=ppt/slides/slide13.xml><?xml version="1.0" encoding="utf-8"?>
+<file path=ppt/slides/slide14.xml><?xml version="1.0" encoding="utf-8"?>
 <p:sld xmlns:a="http://schemas.openxmlformats.org/drawingml/2006/main" xmlns:r="http://schemas.openxmlformats.org/officeDocument/2006/relationships" xmlns:p="http://schemas.openxmlformats.org/presentationml/2006/main">
   <p:cSld name="Slide 14">
     <p:bg>
@@ -9652,7 +10183,7 @@
 </p:sld>
 </file>
 
-<file path=ppt/slides/slide14.xml><?xml version="1.0" encoding="utf-8"?>
+<file path=ppt/slides/slide15.xml><?xml version="1.0" encoding="utf-8"?>
 <p:sld xmlns:a="http://schemas.openxmlformats.org/drawingml/2006/main" xmlns:r="http://schemas.openxmlformats.org/officeDocument/2006/relationships" xmlns:p="http://schemas.openxmlformats.org/presentationml/2006/main">
   <p:cSld>
     <p:bg>
@@ -10356,7 +10887,7 @@
 </p:sld>
 </file>
 
-<file path=ppt/slides/slide15.xml><?xml version="1.0" encoding="utf-8"?>
+<file path=ppt/slides/slide16.xml><?xml version="1.0" encoding="utf-8"?>
 <p:sld xmlns:a="http://schemas.openxmlformats.org/drawingml/2006/main" xmlns:r="http://schemas.openxmlformats.org/officeDocument/2006/relationships" xmlns:p="http://schemas.openxmlformats.org/presentationml/2006/main">
   <p:cSld name="Slide 17">
     <p:bg>
@@ -11364,7 +11895,7 @@
 </p:sld>
 </file>
 
-<file path=ppt/slides/slide16.xml><?xml version="1.0" encoding="utf-8"?>
+<file path=ppt/slides/slide17.xml><?xml version="1.0" encoding="utf-8"?>
 <p:sld xmlns:a="http://schemas.openxmlformats.org/drawingml/2006/main" xmlns:r="http://schemas.openxmlformats.org/officeDocument/2006/relationships" xmlns:p="http://schemas.openxmlformats.org/presentationml/2006/main">
   <p:cSld>
     <p:spTree>
@@ -11503,7 +12034,7 @@
 </p:sld>
 </file>
 
-<file path=ppt/slides/slide17.xml><?xml version="1.0" encoding="utf-8"?>
+<file path=ppt/slides/slide18.xml><?xml version="1.0" encoding="utf-8"?>
 <p:sld xmlns:a="http://schemas.openxmlformats.org/drawingml/2006/main" xmlns:r="http://schemas.openxmlformats.org/officeDocument/2006/relationships" xmlns:p="http://schemas.openxmlformats.org/presentationml/2006/main">
   <p:cSld>
     <p:spTree>
@@ -11717,7 +12248,7 @@
                 </a:solidFill>
                 <a:latin typeface="Arial" pitchFamily="34" charset="0"/>
               </a:rPr>
-              <a:t>+10 years designing CRM and GTM systems in FMCG. </a:t>
+              <a:t xml:space="preserve">+10 years designing CRM and GTM systems in FMCG. </a:t>
             </a:r>
           </a:p>
           <a:p>
@@ -11739,7 +12270,7 @@
                 </a:solidFill>
                 <a:latin typeface="Arial" pitchFamily="34" charset="0"/>
               </a:rPr>
-              <a:t>CMO, CPO positions in Korea based startups, Ran e-commerce fashion brand for 5 years, </a:t>
+              <a:t xml:space="preserve">CMO, CPO positions in Korea based startups, Ran e-commerce fashion brand for 5 years, </a:t>
             </a:r>
           </a:p>
           <a:p>
@@ -11779,7 +12310,7 @@
                 </a:solidFill>
                 <a:latin typeface="Arial" pitchFamily="34" charset="0"/>
               </a:rPr>
-              <a:t> + </a:t>
+              <a:t xml:space="preserve"> + </a:t>
             </a:r>
             <a:r>
               <a:rPr lang="en-US" sz="1100" dirty="0" err="1">
@@ -11797,7 +12328,7 @@
                 </a:solidFill>
                 <a:latin typeface="Arial" pitchFamily="34" charset="0"/>
               </a:rPr>
-              <a:t> + </a:t>
+              <a:t xml:space="preserve"> + </a:t>
             </a:r>
             <a:r>
               <a:rPr lang="en-US" sz="1100" dirty="0" err="1">
@@ -11921,651 +12452,6 @@
         </p:txBody>
       </p:sp>
     </p:spTree>
-  </p:cSld>
-  <p:clrMapOvr>
-    <a:masterClrMapping/>
-  </p:clrMapOvr>
-</p:sld>
-</file>
-
-<file path=ppt/slides/slide18.xml><?xml version="1.0" encoding="utf-8"?>
-<p:sld xmlns:a="http://schemas.openxmlformats.org/drawingml/2006/main" xmlns:r="http://schemas.openxmlformats.org/officeDocument/2006/relationships" xmlns:p="http://schemas.openxmlformats.org/presentationml/2006/main">
-  <p:cSld>
-    <p:spTree>
-      <p:nvGrpSpPr>
-        <p:cNvPr id="1" name="Slide 9"/>
-        <p:cNvGrpSpPr/>
-        <p:nvPr/>
-      </p:nvGrpSpPr>
-      <p:grpSpPr>
-        <a:xfrm>
-          <a:off x="0" y="0"/>
-          <a:ext cx="9144000" cy="5143500"/>
-          <a:chOff x="0" y="0"/>
-          <a:chExt cx="9144000" cy="5143500"/>
-        </a:xfrm>
-      </p:grpSpPr>
-      <p:sp>
-        <p:nvSpPr>
-          <p:cNvPr id="2" name="Section Label"/>
-          <p:cNvSpPr/>
-          <p:nvPr/>
-        </p:nvSpPr>
-        <p:spPr>
-          <a:xfrm>
-            <a:off x="685800" y="457200"/>
-            <a:ext cx="2000000" cy="274320"/>
-          </a:xfrm>
-          <a:prstGeom prst="rect">
-            <a:avLst/>
-          </a:prstGeom>
-          <a:noFill/>
-          <a:ln/>
-        </p:spPr>
-        <p:txBody>
-          <a:bodyPr wrap="square" lIns="0" tIns="0" rIns="0" bIns="0" rtlCol="0" anchor="ctr"/>
-          <a:lstStyle/>
-          <a:p>
-            <a:pPr marL="0" indent="0">
-              <a:buNone/>
-            </a:pPr>
-            <a:r>
-              <a:rPr lang="en-US" sz="1100" b="1" dirty="0">
-                <a:solidFill>
-                  <a:srgbClr val="E8985E"/>
-                </a:solidFill>
-                <a:latin typeface="Arial" pitchFamily="34" charset="0"/>
-                <a:ea typeface="Arial" pitchFamily="34" charset="-122"/>
-                <a:cs typeface="Arial" pitchFamily="34" charset="-120"/>
-              </a:rPr>
-              <a:t>Product</a:t>
-            </a:r>
-          </a:p>
-        </p:txBody>
-      </p:sp>
-      <p:sp>
-        <p:nvSpPr>
-          <p:cNvPr id="3" name="Title"/>
-          <p:cNvSpPr/>
-          <p:nvPr/>
-        </p:nvSpPr>
-        <p:spPr>
-          <a:xfrm>
-            <a:off x="685800" y="777240"/>
-            <a:ext cx="7772400" cy="457200"/>
-          </a:xfrm>
-          <a:prstGeom prst="rect">
-            <a:avLst/>
-          </a:prstGeom>
-          <a:noFill/>
-          <a:ln/>
-        </p:spPr>
-        <p:txBody>
-          <a:bodyPr wrap="square" lIns="0" tIns="0" rIns="0" bIns="0" rtlCol="0" anchor="ctr"/>
-          <a:lstStyle/>
-          <a:p>
-            <a:pPr marL="0" indent="0">
-              <a:buNone/>
-            </a:pPr>
-            <a:r>
-              <a:rPr lang="en-US" sz="2400" b="1" dirty="0">
-                <a:solidFill>
-                  <a:srgbClr val="111111"/>
-                </a:solidFill>
-                <a:latin typeface="Arial" pitchFamily="34" charset="0"/>
-                <a:ea typeface="Arial" pitchFamily="34" charset="-122"/>
-                <a:cs typeface="Arial" pitchFamily="34" charset="-120"/>
-              </a:rPr>
-              <a:t>What YARNNN Replaces</a:t>
-            </a:r>
-          </a:p>
-        </p:txBody>
-      </p:sp>
-      <p:sp>
-        <p:nvSpPr>
-          <p:cNvPr id="4" name="Subtitle"/>
-          <p:cNvSpPr/>
-          <p:nvPr/>
-        </p:nvSpPr>
-        <p:spPr>
-          <a:xfrm>
-            <a:off x="685800" y="1371600"/>
-            <a:ext cx="7772400" cy="274320"/>
-          </a:xfrm>
-          <a:prstGeom prst="rect">
-            <a:avLst/>
-          </a:prstGeom>
-          <a:noFill/>
-          <a:ln/>
-        </p:spPr>
-        <p:txBody>
-          <a:bodyPr wrap="square" lIns="0" tIns="0" rIns="0" bIns="0" rtlCol="0" anchor="ctr"/>
-          <a:lstStyle/>
-          <a:p>
-            <a:pPr marL="0" indent="0">
-              <a:buNone/>
-            </a:pPr>
-            <a:r>
-              <a:rPr lang="en-US" sz="1100" dirty="0">
-                <a:solidFill>
-                  <a:srgbClr val="666666"/>
-                </a:solidFill>
-                <a:latin typeface="Arial" pitchFamily="34" charset="0"/>
-                <a:ea typeface="Arial" pitchFamily="34" charset="-122"/>
-                <a:cs typeface="Arial" pitchFamily="34" charset="-120"/>
-              </a:rPr>
-              <a:t>Three real workflows. Before: manual, fragmented, time-consuming. After: autonomous, cross-platform, improving.</a:t>
-            </a:r>
-          </a:p>
-        </p:txBody>
-      </p:sp>
-      <p:sp>
-        <p:nvSpPr>
-          <p:cNvPr id="5" name="Card1"/>
-          <p:cNvSpPr/>
-          <p:nvPr/>
-        </p:nvSpPr>
-        <p:spPr>
-          <a:xfrm>
-            <a:off x="685800" y="1970843"/>
-            <a:ext cx="2200000" cy="2263806"/>
-          </a:xfrm>
-          <a:prstGeom prst="rect">
-            <a:avLst/>
-          </a:prstGeom>
-          <a:solidFill>
-            <a:srgbClr val="F8F8F8"/>
-          </a:solidFill>
-          <a:ln>
-            <a:solidFill>
-              <a:srgbClr val="DEDEDE"/>
-            </a:solidFill>
-            <a:prstDash val="solid"/>
-            <a:round/>
-          </a:ln>
-        </p:spPr>
-        <p:txBody>
-          <a:bodyPr wrap="square" lIns="91440" tIns="45720" rIns="91440" bIns="45720" rtlCol="0" anchor="t"/>
-          <a:lstStyle/>
-          <a:p>
-            <a:pPr marL="0" indent="0">
-              <a:buNone/>
-            </a:pPr>
-            <a:r>
-              <a:rPr lang="en-US" sz="1100" b="1" dirty="0">
-                <a:solidFill>
-                  <a:srgbClr val="111111"/>
-                </a:solidFill>
-                <a:latin typeface="Arial" pitchFamily="34" charset="0"/>
-                <a:ea typeface="Arial" pitchFamily="34" charset="-122"/>
-                <a:cs typeface="Arial" pitchFamily="34" charset="-120"/>
-              </a:rPr>
-              <a:t>Before: Monday Catchup</a:t>
-            </a:r>
-          </a:p>
-          <a:p>
-            <a:pPr marL="0" indent="0">
-              <a:buNone/>
-            </a:pPr>
-            <a:endParaRPr lang="en-US" sz="900" dirty="0">
-              <a:solidFill>
-                <a:srgbClr val="666666"/>
-              </a:solidFill>
-              <a:latin typeface="Arial" pitchFamily="34" charset="0"/>
-              <a:ea typeface="Arial" pitchFamily="34" charset="-122"/>
-              <a:cs typeface="Arial" pitchFamily="34" charset="-120"/>
-            </a:endParaRPr>
-          </a:p>
-          <a:p>
-            <a:pPr marL="0" indent="0">
-              <a:buNone/>
-            </a:pPr>
-            <a:r>
-              <a:rPr lang="en-US" sz="900" dirty="0">
-                <a:solidFill>
-                  <a:srgbClr val="666666"/>
-                </a:solidFill>
-                <a:latin typeface="Arial" pitchFamily="34" charset="0"/>
-                <a:ea typeface="Arial" pitchFamily="34" charset="-122"/>
-                <a:cs typeface="Arial" pitchFamily="34" charset="-120"/>
-              </a:rPr>
-              <a:t>Open Slack. Scroll 14 channels. Open Gmail. Scan 40 emails. 45 minutes gone.</a:t>
-            </a:r>
-          </a:p>
-          <a:p>
-            <a:pPr marL="0" indent="0">
-              <a:buNone/>
-            </a:pPr>
-            <a:endParaRPr lang="en-US" sz="900" b="1" dirty="0">
-              <a:solidFill>
-                <a:srgbClr val="E8985E"/>
-              </a:solidFill>
-              <a:latin typeface="Arial" pitchFamily="34" charset="0"/>
-              <a:ea typeface="Arial" pitchFamily="34" charset="-122"/>
-              <a:cs typeface="Arial" pitchFamily="34" charset="-120"/>
-            </a:endParaRPr>
-          </a:p>
-          <a:p>
-            <a:pPr marL="0" indent="0">
-              <a:buNone/>
-            </a:pPr>
-            <a:endParaRPr lang="en-US" sz="900" b="1" dirty="0">
-              <a:solidFill>
-                <a:srgbClr val="E8985E"/>
-              </a:solidFill>
-              <a:latin typeface="Arial" pitchFamily="34" charset="0"/>
-              <a:ea typeface="Arial" pitchFamily="34" charset="-122"/>
-              <a:cs typeface="Arial" pitchFamily="34" charset="-120"/>
-            </a:endParaRPr>
-          </a:p>
-          <a:p>
-            <a:pPr marL="0" indent="0">
-              <a:buNone/>
-            </a:pPr>
-            <a:r>
-              <a:rPr lang="en-US" sz="900" b="1" dirty="0">
-                <a:solidFill>
-                  <a:srgbClr val="E8985E"/>
-                </a:solidFill>
-                <a:latin typeface="Arial" pitchFamily="34" charset="0"/>
-                <a:ea typeface="Arial" pitchFamily="34" charset="-122"/>
-                <a:cs typeface="Arial" pitchFamily="34" charset="-120"/>
-              </a:rPr>
-              <a:t>AFTER: Recap Agent</a:t>
-            </a:r>
-          </a:p>
-          <a:p>
-            <a:pPr marL="0" indent="0">
-              <a:buNone/>
-            </a:pPr>
-            <a:r>
-              <a:rPr lang="en-US" sz="900" dirty="0">
-                <a:solidFill>
-                  <a:srgbClr val="666666"/>
-                </a:solidFill>
-                <a:latin typeface="Arial" pitchFamily="34" charset="0"/>
-                <a:ea typeface="Arial" pitchFamily="34" charset="-122"/>
-                <a:cs typeface="Arial" pitchFamily="34" charset="-120"/>
-              </a:rPr>
-              <a:t>One brief. All platforms. Waiting at 8am. 0 minutes of your time.</a:t>
-            </a:r>
-          </a:p>
-        </p:txBody>
-      </p:sp>
-      <p:sp>
-        <p:nvSpPr>
-          <p:cNvPr id="6" name="Arrow1"/>
-          <p:cNvSpPr/>
-          <p:nvPr/>
-        </p:nvSpPr>
-        <p:spPr>
-          <a:xfrm>
-            <a:off x="2985800" y="2337043"/>
-            <a:ext cx="350000" cy="200000"/>
-          </a:xfrm>
-          <a:prstGeom prst="rightArrow">
-            <a:avLst/>
-          </a:prstGeom>
-          <a:solidFill>
-            <a:srgbClr val="E8985E"/>
-          </a:solidFill>
-          <a:ln>
-            <a:noFill/>
-          </a:ln>
-        </p:spPr>
-        <p:txBody>
-          <a:bodyPr wrap="square" lIns="0" tIns="0" rIns="0" bIns="0" rtlCol="0" anchor="ctr"/>
-          <a:lstStyle/>
-          <a:p>
-            <a:pPr marL="0" indent="0">
-              <a:buNone/>
-            </a:pPr>
-            <a:endParaRPr/>
-          </a:p>
-        </p:txBody>
-      </p:sp>
-      <p:sp>
-        <p:nvSpPr>
-          <p:cNvPr id="7" name="Card2"/>
-          <p:cNvSpPr/>
-          <p:nvPr/>
-        </p:nvSpPr>
-        <p:spPr>
-          <a:xfrm>
-            <a:off x="3435800" y="1970843"/>
-            <a:ext cx="2200000" cy="2263806"/>
-          </a:xfrm>
-          <a:prstGeom prst="rect">
-            <a:avLst/>
-          </a:prstGeom>
-          <a:solidFill>
-            <a:srgbClr val="E8985E"/>
-          </a:solidFill>
-          <a:ln>
-            <a:solidFill>
-              <a:srgbClr val="E8985E"/>
-            </a:solidFill>
-            <a:prstDash val="solid"/>
-            <a:round/>
-          </a:ln>
-        </p:spPr>
-        <p:txBody>
-          <a:bodyPr wrap="square" lIns="91440" tIns="45720" rIns="91440" bIns="45720" rtlCol="0" anchor="t"/>
-          <a:lstStyle/>
-          <a:p>
-            <a:pPr marL="0" indent="0">
-              <a:buNone/>
-            </a:pPr>
-            <a:r>
-              <a:rPr lang="en-US" sz="1100" b="1" dirty="0">
-                <a:solidFill>
-                  <a:srgbClr val="FFFFFF"/>
-                </a:solidFill>
-                <a:latin typeface="Arial" pitchFamily="34" charset="0"/>
-                <a:ea typeface="Arial" pitchFamily="34" charset="-122"/>
-                <a:cs typeface="Arial" pitchFamily="34" charset="-120"/>
-              </a:rPr>
-              <a:t>Before: Client Status Update</a:t>
-            </a:r>
-          </a:p>
-          <a:p>
-            <a:pPr marL="0" indent="0">
-              <a:buNone/>
-            </a:pPr>
-            <a:endParaRPr lang="en-US" sz="900" i="1" dirty="0">
-              <a:solidFill>
-                <a:srgbClr val="FFFFFF"/>
-              </a:solidFill>
-              <a:latin typeface="Arial" pitchFamily="34" charset="0"/>
-              <a:ea typeface="Arial" pitchFamily="34" charset="-122"/>
-              <a:cs typeface="Arial" pitchFamily="34" charset="-120"/>
-            </a:endParaRPr>
-          </a:p>
-          <a:p>
-            <a:pPr marL="0" indent="0">
-              <a:buNone/>
-            </a:pPr>
-            <a:r>
-              <a:rPr lang="en-US" sz="900" i="1" dirty="0">
-                <a:solidFill>
-                  <a:srgbClr val="FFFFFF"/>
-                </a:solidFill>
-                <a:latin typeface="Arial" pitchFamily="34" charset="0"/>
-                <a:ea typeface="Arial" pitchFamily="34" charset="-122"/>
-                <a:cs typeface="Arial" pitchFamily="34" charset="-120"/>
-              </a:rPr>
-              <a:t>Copy from Slack. Paste into doc. Check Gmail. Rewrite for client tone. 2 hours, every week.</a:t>
-            </a:r>
-          </a:p>
-          <a:p>
-            <a:pPr marL="0" indent="0">
-              <a:buNone/>
-            </a:pPr>
-            <a:endParaRPr lang="en-US" sz="900" dirty="0">
-              <a:solidFill>
-                <a:srgbClr val="FFFFFF"/>
-              </a:solidFill>
-              <a:latin typeface="Arial" pitchFamily="34" charset="0"/>
-              <a:ea typeface="Arial" pitchFamily="34" charset="-122"/>
-              <a:cs typeface="Arial" pitchFamily="34" charset="-120"/>
-            </a:endParaRPr>
-          </a:p>
-          <a:p>
-            <a:pPr marL="0" indent="0">
-              <a:buNone/>
-            </a:pPr>
-            <a:endParaRPr lang="en-US" sz="900" b="1" dirty="0">
-              <a:solidFill>
-                <a:srgbClr val="FFFFFF"/>
-              </a:solidFill>
-              <a:latin typeface="Arial" pitchFamily="34" charset="0"/>
-              <a:ea typeface="Arial" pitchFamily="34" charset="-122"/>
-              <a:cs typeface="Arial" pitchFamily="34" charset="-120"/>
-            </a:endParaRPr>
-          </a:p>
-          <a:p>
-            <a:pPr marL="0" indent="0">
-              <a:buNone/>
-            </a:pPr>
-            <a:r>
-              <a:rPr lang="en-US" sz="900" b="1" dirty="0">
-                <a:solidFill>
-                  <a:srgbClr val="FFFFFF"/>
-                </a:solidFill>
-                <a:latin typeface="Arial" pitchFamily="34" charset="0"/>
-                <a:ea typeface="Arial" pitchFamily="34" charset="-122"/>
-                <a:cs typeface="Arial" pitchFamily="34" charset="-120"/>
-              </a:rPr>
-              <a:t>AFTER: Status Agent</a:t>
-            </a:r>
-          </a:p>
-          <a:p>
-            <a:pPr marL="0" indent="0">
-              <a:buNone/>
-            </a:pPr>
-            <a:r>
-              <a:rPr lang="en-US" sz="900" dirty="0">
-                <a:solidFill>
-                  <a:srgbClr val="FFFFFF"/>
-                </a:solidFill>
-                <a:latin typeface="Arial" pitchFamily="34" charset="0"/>
-                <a:ea typeface="Arial" pitchFamily="34" charset="-122"/>
-                <a:cs typeface="Arial" pitchFamily="34" charset="-120"/>
-              </a:rPr>
-              <a:t>Pulls from all platforms. 12 weeks of accumulated context. Draft arrives Friday 5pm.</a:t>
-            </a:r>
-          </a:p>
-        </p:txBody>
-      </p:sp>
-      <p:sp>
-        <p:nvSpPr>
-          <p:cNvPr id="8" name="Arrow2"/>
-          <p:cNvSpPr/>
-          <p:nvPr/>
-        </p:nvSpPr>
-        <p:spPr>
-          <a:xfrm>
-            <a:off x="5735800" y="2337043"/>
-            <a:ext cx="350000" cy="200000"/>
-          </a:xfrm>
-          <a:prstGeom prst="rightArrow">
-            <a:avLst/>
-          </a:prstGeom>
-          <a:solidFill>
-            <a:srgbClr val="E8985E"/>
-          </a:solidFill>
-          <a:ln>
-            <a:noFill/>
-          </a:ln>
-        </p:spPr>
-        <p:txBody>
-          <a:bodyPr wrap="square" lIns="0" tIns="0" rIns="0" bIns="0" rtlCol="0" anchor="ctr"/>
-          <a:lstStyle/>
-          <a:p>
-            <a:pPr marL="0" indent="0">
-              <a:buNone/>
-            </a:pPr>
-            <a:endParaRPr/>
-          </a:p>
-        </p:txBody>
-      </p:sp>
-      <p:sp>
-        <p:nvSpPr>
-          <p:cNvPr id="9" name="Card3"/>
-          <p:cNvSpPr/>
-          <p:nvPr/>
-        </p:nvSpPr>
-        <p:spPr>
-          <a:xfrm>
-            <a:off x="6185800" y="1970843"/>
-            <a:ext cx="2200000" cy="2263806"/>
-          </a:xfrm>
-          <a:prstGeom prst="rect">
-            <a:avLst/>
-          </a:prstGeom>
-          <a:solidFill>
-            <a:srgbClr val="F8F8F8"/>
-          </a:solidFill>
-          <a:ln>
-            <a:solidFill>
-              <a:srgbClr val="DEDEDE"/>
-            </a:solidFill>
-            <a:prstDash val="solid"/>
-            <a:round/>
-          </a:ln>
-        </p:spPr>
-        <p:txBody>
-          <a:bodyPr wrap="square" lIns="91440" tIns="45720" rIns="91440" bIns="45720" rtlCol="0" anchor="t"/>
-          <a:lstStyle/>
-          <a:p>
-            <a:pPr marL="0" indent="0">
-              <a:buNone/>
-            </a:pPr>
-            <a:r>
-              <a:rPr lang="en-US" sz="1100" b="1" dirty="0">
-                <a:solidFill>
-                  <a:srgbClr val="111111"/>
-                </a:solidFill>
-                <a:latin typeface="Arial" pitchFamily="34" charset="0"/>
-                <a:ea typeface="Arial" pitchFamily="34" charset="-122"/>
-                <a:cs typeface="Arial" pitchFamily="34" charset="-120"/>
-              </a:rPr>
-              <a:t>Before: Meeting Prep</a:t>
-            </a:r>
-          </a:p>
-          <a:p>
-            <a:pPr marL="0" indent="0">
-              <a:buNone/>
-            </a:pPr>
-            <a:endParaRPr lang="en-US" sz="900" dirty="0">
-              <a:solidFill>
-                <a:srgbClr val="666666"/>
-              </a:solidFill>
-              <a:latin typeface="Arial" pitchFamily="34" charset="0"/>
-              <a:ea typeface="Arial" pitchFamily="34" charset="-122"/>
-              <a:cs typeface="Arial" pitchFamily="34" charset="-120"/>
-            </a:endParaRPr>
-          </a:p>
-          <a:p>
-            <a:pPr marL="0" indent="0">
-              <a:buNone/>
-            </a:pPr>
-            <a:r>
-              <a:rPr lang="en-US" sz="900" dirty="0">
-                <a:solidFill>
-                  <a:srgbClr val="666666"/>
-                </a:solidFill>
-                <a:latin typeface="Arial" pitchFamily="34" charset="0"/>
-                <a:ea typeface="Arial" pitchFamily="34" charset="-122"/>
-                <a:cs typeface="Arial" pitchFamily="34" charset="-120"/>
-              </a:rPr>
-              <a:t>Search Slack. Search Gmail. Check LinkedIn. Skim Notion. Scramble 10 minutes before the call.</a:t>
-            </a:r>
-          </a:p>
-          <a:p>
-            <a:pPr marL="0" indent="0">
-              <a:buNone/>
-            </a:pPr>
-            <a:endParaRPr lang="en-US" sz="900" dirty="0">
-              <a:solidFill>
-                <a:srgbClr val="666666"/>
-              </a:solidFill>
-              <a:latin typeface="Arial" pitchFamily="34" charset="0"/>
-              <a:ea typeface="Arial" pitchFamily="34" charset="-122"/>
-              <a:cs typeface="Arial" pitchFamily="34" charset="-120"/>
-            </a:endParaRPr>
-          </a:p>
-          <a:p>
-            <a:pPr marL="0" indent="0">
-              <a:buNone/>
-            </a:pPr>
-            <a:endParaRPr lang="en-US" sz="900" b="1" dirty="0">
-              <a:solidFill>
-                <a:srgbClr val="E8985E"/>
-              </a:solidFill>
-              <a:latin typeface="Arial" pitchFamily="34" charset="0"/>
-              <a:ea typeface="Arial" pitchFamily="34" charset="-122"/>
-              <a:cs typeface="Arial" pitchFamily="34" charset="-120"/>
-            </a:endParaRPr>
-          </a:p>
-          <a:p>
-            <a:pPr marL="0" indent="0">
-              <a:buNone/>
-            </a:pPr>
-            <a:r>
-              <a:rPr lang="en-US" sz="900" b="1" dirty="0">
-                <a:solidFill>
-                  <a:srgbClr val="E8985E"/>
-                </a:solidFill>
-                <a:latin typeface="Arial" pitchFamily="34" charset="0"/>
-                <a:ea typeface="Arial" pitchFamily="34" charset="-122"/>
-                <a:cs typeface="Arial" pitchFamily="34" charset="-120"/>
-              </a:rPr>
-              <a:t>AFTER: Meeting Prep Agent</a:t>
-            </a:r>
-          </a:p>
-          <a:p>
-            <a:pPr marL="0" indent="0">
-              <a:buNone/>
-            </a:pPr>
-            <a:r>
-              <a:rPr lang="en-US" sz="900" dirty="0">
-                <a:solidFill>
-                  <a:srgbClr val="666666"/>
-                </a:solidFill>
-                <a:latin typeface="Arial" pitchFamily="34" charset="0"/>
-                <a:ea typeface="Arial" pitchFamily="34" charset="-122"/>
-                <a:cs typeface="Arial" pitchFamily="34" charset="-120"/>
-              </a:rPr>
-              <a:t>Brief auto-generated from calendar. Full context. Delivered 30 min before. Every time.</a:t>
-            </a:r>
-          </a:p>
-        </p:txBody>
-      </p:sp>
-      <p:sp>
-        <p:nvSpPr>
-          <p:cNvPr id="10" name="Bottom Insight"/>
-          <p:cNvSpPr/>
-          <p:nvPr/>
-        </p:nvSpPr>
-        <p:spPr>
-          <a:xfrm>
-            <a:off x="685800" y="4572000"/>
-            <a:ext cx="7772400" cy="274320"/>
-          </a:xfrm>
-          <a:prstGeom prst="rect">
-            <a:avLst/>
-          </a:prstGeom>
-          <a:noFill/>
-          <a:ln/>
-        </p:spPr>
-        <p:txBody>
-          <a:bodyPr wrap="square" lIns="0" tIns="0" rIns="0" bIns="0" rtlCol="0" anchor="ctr"/>
-          <a:lstStyle/>
-          <a:p>
-            <a:pPr marL="0" indent="0" algn="ctr">
-              <a:buNone/>
-            </a:pPr>
-            <a:r>
-              <a:rPr lang="en-US" sz="900" i="1" dirty="0">
-                <a:solidFill>
-                  <a:srgbClr val="E8985E"/>
-                </a:solidFill>
-                <a:latin typeface="Arial" pitchFamily="34" charset="0"/>
-                <a:ea typeface="Arial" pitchFamily="34" charset="-122"/>
-                <a:cs typeface="Arial" pitchFamily="34" charset="-120"/>
-              </a:rPr>
-              <a:t>Every agent gets better with tenure. The 12th weekly update needs zero corrections.</a:t>
-            </a:r>
-          </a:p>
-        </p:txBody>
-      </p:sp>
-    </p:spTree>
-    <p:extLst>
-      <p:ext uri="{BB962C8B-B14F-4D97-AF65-F5344CB8AC3E}">
-        <p14:creationId xmlns:p14="http://schemas.microsoft.com/office/powerpoint/2010/main" val="4186313045"/>
-      </p:ext>
-    </p:extLst>
   </p:cSld>
   <p:clrMapOvr>
     <a:masterClrMapping/>
@@ -12662,7 +12548,7 @@
                 <a:ea typeface="Arial" pitchFamily="34" charset="-122"/>
                 <a:cs typeface="Arial" pitchFamily="34" charset="-120"/>
               </a:rPr>
-              <a:t>Claude has coding agents, desktop, cowork. </a:t>
+              <a:t xml:space="preserve">Claude has coding agents, desktop, cowork. </a:t>
             </a:r>
           </a:p>
           <a:p>
@@ -12678,7 +12564,7 @@
                 <a:ea typeface="Arial" pitchFamily="34" charset="-122"/>
                 <a:cs typeface="Arial" pitchFamily="34" charset="-120"/>
               </a:rPr>
-              <a:t>ChatGPT has memory, Codex, Sora. </a:t>
+              <a:t xml:space="preserve">ChatGPT has memory, Codex, Sora. </a:t>
             </a:r>
           </a:p>
           <a:p>
@@ -12760,7 +12646,7 @@
                 <a:ea typeface="Arial" pitchFamily="34" charset="-122"/>
                 <a:cs typeface="Arial" pitchFamily="34" charset="-120"/>
               </a:rPr>
-              <a:t>Every platform cycle looks that way — until it doesn’t.</a:t>
+              <a:t>But every platform cycle looks that way — until it doesn’t.</a:t>
             </a:r>
             <a:endParaRPr lang="en-US" sz="2000" b="1" dirty="0"/>
           </a:p>
@@ -12799,7 +12685,7 @@
                 <a:ea typeface="Arial" pitchFamily="34" charset="-122"/>
                 <a:cs typeface="Arial" pitchFamily="34" charset="-120"/>
               </a:rPr>
-              <a:t>Google didn’t become Salesforce. </a:t>
+              <a:t xml:space="preserve">Google didn’t become Salesforce. </a:t>
             </a:r>
           </a:p>
           <a:p>
@@ -12815,7 +12701,7 @@
                 <a:ea typeface="Arial" pitchFamily="34" charset="-122"/>
                 <a:cs typeface="Arial" pitchFamily="34" charset="-120"/>
               </a:rPr>
-              <a:t>Facebook didn’t become Shopify. </a:t>
+              <a:t xml:space="preserve">Facebook didn’t become Shopify. </a:t>
             </a:r>
           </a:p>
           <a:p>
@@ -12950,7 +12836,7 @@
                 <a:ea typeface="Arial" pitchFamily="34" charset="-122"/>
                 <a:cs typeface="Arial" pitchFamily="34" charset="-120"/>
               </a:rPr>
-              <a:t>Our thesis is that even with the AI tech revolution, </a:t>
+              <a:t xml:space="preserve">Our thesis is that even with the AI tech revolution, </a:t>
             </a:r>
             <a:br>
               <a:rPr lang="en-US" b="1" dirty="0">
@@ -13430,7 +13316,7 @@
                 <a:ea typeface="Arial" pitchFamily="34" charset="-122"/>
                 <a:cs typeface="Arial" pitchFamily="34" charset="-120"/>
               </a:rPr>
-              <a:t>The application layer of the AI platform shift is yet to come, and we’re taking the </a:t>
+              <a:t xml:space="preserve">The application layer of the AI platform shift is yet to come, and we’re taking the </a:t>
             </a:r>
             <a:r>
               <a:rPr lang="en-US" sz="1400" b="1" dirty="0">
@@ -13446,7 +13332,7 @@
                 <a:ea typeface="Arial" pitchFamily="34" charset="-122"/>
                 <a:cs typeface="Arial" pitchFamily="34" charset="-120"/>
               </a:rPr>
-              <a:t> that it will be Agent-native, and the work economy will shift from human -&gt; agents</a:t>
+              <a:t xml:space="preserve"> that it will be Agent-native, and the work economy will shift from human -&gt; agents</a:t>
             </a:r>
             <a:endParaRPr lang="en-US" sz="1400" dirty="0"/>
           </a:p>
@@ -14176,36 +14062,6 @@
           <a:xfrm>
             <a:off x="1569715" y="1819923"/>
             <a:ext cx="946261" cy="946261"/>
-          </a:xfrm>
-          <a:prstGeom prst="rect">
-            <a:avLst/>
-          </a:prstGeom>
-        </p:spPr>
-      </p:pic>
-      <p:pic>
-        <p:nvPicPr>
-          <p:cNvPr id="3" name="Picture 2">
-            <a:extLst>
-              <a:ext uri="{FF2B5EF4-FFF2-40B4-BE49-F238E27FC236}">
-                <a16:creationId xmlns:a16="http://schemas.microsoft.com/office/drawing/2014/main" id="{59DB195E-D9C0-8AD5-534F-AA0A0C933D31}"/>
-              </a:ext>
-            </a:extLst>
-          </p:cNvPr>
-          <p:cNvPicPr>
-            <a:picLocks noChangeAspect="1"/>
-          </p:cNvPicPr>
-          <p:nvPr/>
-        </p:nvPicPr>
-        <p:blipFill>
-          <a:blip r:embed="rId3"/>
-          <a:stretch>
-            <a:fillRect/>
-          </a:stretch>
-        </p:blipFill>
-        <p:spPr>
-          <a:xfrm>
-            <a:off x="1423428" y="2613802"/>
-            <a:ext cx="1117600" cy="419100"/>
           </a:xfrm>
           <a:prstGeom prst="rect">
             <a:avLst/>
@@ -15115,7 +14971,7 @@
         </p:nvSpPr>
         <p:spPr>
           <a:xfrm>
-            <a:off x="685800" y="685800"/>
+            <a:off x="685800" y="594360"/>
             <a:ext cx="7772400" cy="457200"/>
           </a:xfrm>
           <a:prstGeom prst="rect">
@@ -15151,8 +15007,8 @@
         </p:nvSpPr>
         <p:spPr>
           <a:xfrm>
-            <a:off x="685800" y="1211579"/>
-            <a:ext cx="7772400" cy="336974"/>
+            <a:off x="685800" y="1051560"/>
+            <a:ext cx="7772400" cy="228600"/>
           </a:xfrm>
           <a:prstGeom prst="rect">
             <a:avLst/>
@@ -15187,8 +15043,8 @@
         </p:nvSpPr>
         <p:spPr>
           <a:xfrm>
-            <a:off x="643287" y="1862982"/>
-            <a:ext cx="1296609" cy="1234972"/>
+            <a:off x="643287" y="1783080"/>
+            <a:ext cx="1296609" cy="731520"/>
           </a:xfrm>
           <a:prstGeom prst="roundRect">
             <a:avLst>
@@ -15203,7 +15059,7 @@
           </a:ln>
         </p:spPr>
         <p:txBody>
-          <a:bodyPr wrap="square" lIns="54000" tIns="36000" rIns="54000" bIns="36000" rtlCol="0" anchor="t"/>
+          <a:bodyPr wrap="square" lIns="54000" tIns="36000" rIns="54000" bIns="36000" rtlCol="0" anchor="ctr"/>
           <a:lstStyle/>
           <a:p>
             <a:pPr marL="0" indent="0" algn="ctr">
@@ -15218,17 +15074,6 @@
               </a:rPr>
               <a:t>Perception Pipeline</a:t>
             </a:r>
-          </a:p>
-          <a:p>
-            <a:pPr marL="0" indent="0" algn="ctr">
-              <a:buNone/>
-            </a:pPr>
-            <a:endParaRPr lang="en-US" sz="800" dirty="0">
-              <a:solidFill>
-                <a:srgbClr val="FFFFFF"/>
-              </a:solidFill>
-              <a:latin typeface="Arial" pitchFamily="34" charset="0"/>
-            </a:endParaRPr>
           </a:p>
           <a:p>
             <a:pPr marL="0" indent="0" algn="ctr">
@@ -15255,7 +15100,7 @@
         </p:nvSpPr>
         <p:spPr>
           <a:xfrm>
-            <a:off x="2043968" y="2137302"/>
+            <a:off x="2043968" y="2057400"/>
             <a:ext cx="202595" cy="182880"/>
           </a:xfrm>
           <a:prstGeom prst="rect">
@@ -15291,8 +15136,8 @@
         </p:nvSpPr>
         <p:spPr>
           <a:xfrm>
-            <a:off x="2350635" y="1862982"/>
-            <a:ext cx="1296609" cy="1234972"/>
+            <a:off x="2350635" y="1783080"/>
+            <a:ext cx="1296609" cy="731520"/>
           </a:xfrm>
           <a:prstGeom prst="roundRect">
             <a:avLst>
@@ -15307,7 +15152,7 @@
           </a:ln>
         </p:spPr>
         <p:txBody>
-          <a:bodyPr wrap="square" lIns="54000" tIns="36000" rIns="54000" bIns="36000" rtlCol="0" anchor="t"/>
+          <a:bodyPr wrap="square" lIns="54000" tIns="36000" rIns="54000" bIns="36000" rtlCol="0" anchor="ctr"/>
           <a:lstStyle/>
           <a:p>
             <a:pPr marL="0" indent="0" algn="ctr">
@@ -15320,35 +15165,13 @@
                 </a:solidFill>
                 <a:latin typeface="Arial" pitchFamily="34" charset="0"/>
               </a:rPr>
-              <a:t>Context Mgmt.</a:t>
+              <a:t>Knowledge Base</a:t>
             </a:r>
           </a:p>
           <a:p>
             <a:pPr marL="0" indent="0" algn="ctr">
               <a:buNone/>
             </a:pPr>
-            <a:endParaRPr lang="en-US" sz="800" dirty="0">
-              <a:solidFill>
-                <a:srgbClr val="BBBBBB"/>
-              </a:solidFill>
-              <a:latin typeface="Arial" pitchFamily="34" charset="0"/>
-            </a:endParaRPr>
-          </a:p>
-          <a:p>
-            <a:pPr marL="0" indent="0" algn="ctr">
-              <a:buNone/>
-            </a:pPr>
-            <a:endParaRPr lang="en-US" sz="800" dirty="0">
-              <a:solidFill>
-                <a:srgbClr val="BBBBBB"/>
-              </a:solidFill>
-              <a:latin typeface="Arial" pitchFamily="34" charset="0"/>
-            </a:endParaRPr>
-          </a:p>
-          <a:p>
-            <a:pPr marL="0" indent="0" algn="ctr">
-              <a:buNone/>
-            </a:pPr>
             <a:r>
               <a:rPr lang="en-US" sz="800" dirty="0">
                 <a:solidFill>
@@ -15356,39 +15179,8 @@
                 </a:solidFill>
                 <a:latin typeface="Arial" pitchFamily="34" charset="0"/>
               </a:rPr>
-              <a:t>Shared content
-management for </a:t>
-            </a:r>
-            <a:br>
-              <a:rPr lang="en-US" sz="800" dirty="0">
-                <a:solidFill>
-                  <a:srgbClr val="BBBBBB"/>
-                </a:solidFill>
-                <a:latin typeface="Arial" pitchFamily="34" charset="0"/>
-              </a:rPr>
-            </a:br>
-            <a:r>
-              <a:rPr lang="en-US" sz="800" dirty="0">
-                <a:solidFill>
-                  <a:srgbClr val="BBBBBB"/>
-                </a:solidFill>
-                <a:latin typeface="Arial" pitchFamily="34" charset="0"/>
-              </a:rPr>
-              <a:t>multi agents</a:t>
-            </a:r>
-          </a:p>
-          <a:p>
-            <a:pPr marL="0" indent="0" algn="ctr">
-              <a:buNone/>
-            </a:pPr>
-            <a:r>
-              <a:rPr lang="en-US" sz="800" dirty="0">
-                <a:solidFill>
-                  <a:srgbClr val="BBBBBB"/>
-                </a:solidFill>
-                <a:latin typeface="Arial" pitchFamily="34" charset="0"/>
-              </a:rPr>
-              <a:t>Retention + provenance</a:t>
+              <a:t>Unified content
+Retention + provenance</a:t>
             </a:r>
           </a:p>
         </p:txBody>
@@ -15401,7 +15193,7 @@
         </p:nvSpPr>
         <p:spPr>
           <a:xfrm>
-            <a:off x="3751316" y="2137302"/>
+            <a:off x="3751316" y="2057400"/>
             <a:ext cx="202595" cy="182880"/>
           </a:xfrm>
           <a:prstGeom prst="rect">
@@ -15437,8 +15229,8 @@
         </p:nvSpPr>
         <p:spPr>
           <a:xfrm>
-            <a:off x="4057983" y="1862982"/>
-            <a:ext cx="1296609" cy="1234972"/>
+            <a:off x="4057983" y="1783080"/>
+            <a:ext cx="1296609" cy="731520"/>
           </a:xfrm>
           <a:prstGeom prst="roundRect">
             <a:avLst>
@@ -15453,7 +15245,7 @@
           </a:ln>
         </p:spPr>
         <p:txBody>
-          <a:bodyPr wrap="square" lIns="54000" tIns="36000" rIns="54000" bIns="36000" rtlCol="0" anchor="t"/>
+          <a:bodyPr wrap="square" lIns="54000" tIns="36000" rIns="54000" bIns="36000" rtlCol="0" anchor="ctr"/>
           <a:lstStyle/>
           <a:p>
             <a:pPr marL="0" indent="0" algn="ctr">
@@ -15468,28 +15260,6 @@
               </a:rPr>
               <a:t>Memory</a:t>
             </a:r>
-          </a:p>
-          <a:p>
-            <a:pPr marL="0" indent="0" algn="ctr">
-              <a:buNone/>
-            </a:pPr>
-            <a:endParaRPr lang="en-US" sz="800" dirty="0">
-              <a:solidFill>
-                <a:srgbClr val="BBBBBB"/>
-              </a:solidFill>
-              <a:latin typeface="Arial" pitchFamily="34" charset="0"/>
-            </a:endParaRPr>
-          </a:p>
-          <a:p>
-            <a:pPr marL="0" indent="0" algn="ctr">
-              <a:buNone/>
-            </a:pPr>
-            <a:endParaRPr lang="en-US" sz="800" dirty="0">
-              <a:solidFill>
-                <a:srgbClr val="BBBBBB"/>
-              </a:solidFill>
-              <a:latin typeface="Arial" pitchFamily="34" charset="0"/>
-            </a:endParaRPr>
           </a:p>
           <a:p>
             <a:pPr marL="0" indent="0" algn="ctr">
@@ -15516,7 +15286,7 @@
         </p:nvSpPr>
         <p:spPr>
           <a:xfrm>
-            <a:off x="5458664" y="2137302"/>
+            <a:off x="5458664" y="2057400"/>
             <a:ext cx="202595" cy="182880"/>
           </a:xfrm>
           <a:prstGeom prst="rect">
@@ -15552,8 +15322,8 @@
         </p:nvSpPr>
         <p:spPr>
           <a:xfrm>
-            <a:off x="5765331" y="1862982"/>
-            <a:ext cx="1296609" cy="1234972"/>
+            <a:off x="5765331" y="1783080"/>
+            <a:ext cx="1296609" cy="731520"/>
           </a:xfrm>
           <a:prstGeom prst="roundRect">
             <a:avLst>
@@ -15568,7 +15338,7 @@
           </a:ln>
         </p:spPr>
         <p:txBody>
-          <a:bodyPr wrap="square" lIns="54000" tIns="36000" rIns="54000" bIns="36000" rtlCol="0" anchor="t"/>
+          <a:bodyPr wrap="square" lIns="54000" tIns="36000" rIns="54000" bIns="36000" rtlCol="0" anchor="ctr"/>
           <a:lstStyle/>
           <a:p>
             <a:pPr marL="0" indent="0" algn="ctr">
@@ -15581,25 +15351,8 @@
                 </a:solidFill>
                 <a:latin typeface="Arial" pitchFamily="34" charset="0"/>
               </a:rPr>
-              <a:t>Agent Orchestration</a:t>
-            </a:r>
-            <a:endParaRPr lang="en-US" sz="800" dirty="0">
-              <a:solidFill>
-                <a:srgbClr val="BBBBBB"/>
-              </a:solidFill>
-              <a:latin typeface="Arial" pitchFamily="34" charset="0"/>
-            </a:endParaRPr>
-          </a:p>
-          <a:p>
-            <a:pPr marL="0" indent="0" algn="ctr">
-              <a:buNone/>
-            </a:pPr>
-            <a:endParaRPr lang="en-US" sz="800" dirty="0">
-              <a:solidFill>
-                <a:srgbClr val="BBBBBB"/>
-              </a:solidFill>
-              <a:latin typeface="Arial" pitchFamily="34" charset="0"/>
-            </a:endParaRPr>
+              <a:t>Agent Engine</a:t>
+            </a:r>
           </a:p>
           <a:p>
             <a:pPr marL="0" indent="0" algn="ctr">
@@ -15616,38 +15369,6 @@
 Chat + headless</a:t>
             </a:r>
           </a:p>
-          <a:p>
-            <a:pPr marL="0" indent="0" algn="ctr">
-              <a:buNone/>
-            </a:pPr>
-            <a:r>
-              <a:rPr lang="en-US" sz="800" dirty="0">
-                <a:solidFill>
-                  <a:srgbClr val="BBBBBB"/>
-                </a:solidFill>
-                <a:latin typeface="Arial" pitchFamily="34" charset="0"/>
-              </a:rPr>
-              <a:t>(</a:t>
-            </a:r>
-            <a:r>
-              <a:rPr lang="en-US" sz="800" dirty="0" err="1">
-                <a:solidFill>
-                  <a:srgbClr val="BBBBBB"/>
-                </a:solidFill>
-                <a:latin typeface="Arial" pitchFamily="34" charset="0"/>
-              </a:rPr>
-              <a:t>cron</a:t>
-            </a:r>
-            <a:r>
-              <a:rPr lang="en-US" sz="800" dirty="0">
-                <a:solidFill>
-                  <a:srgbClr val="BBBBBB"/>
-                </a:solidFill>
-                <a:latin typeface="Arial" pitchFamily="34" charset="0"/>
-              </a:rPr>
-              <a:t>-jobs, sync processors, etc.)</a:t>
-            </a:r>
-          </a:p>
         </p:txBody>
       </p:sp>
       <p:sp>
@@ -15658,7 +15379,7 @@
         </p:nvSpPr>
         <p:spPr>
           <a:xfrm>
-            <a:off x="7166012" y="2137302"/>
+            <a:off x="7166012" y="2057400"/>
             <a:ext cx="202595" cy="182880"/>
           </a:xfrm>
           <a:prstGeom prst="rect">
@@ -15694,8 +15415,8 @@
         </p:nvSpPr>
         <p:spPr>
           <a:xfrm>
-            <a:off x="7472680" y="1857055"/>
-            <a:ext cx="1134533" cy="1234972"/>
+            <a:off x="7472680" y="1777153"/>
+            <a:ext cx="1134533" cy="731520"/>
           </a:xfrm>
           <a:prstGeom prst="roundRect">
             <a:avLst>
@@ -15710,7 +15431,7 @@
           </a:ln>
         </p:spPr>
         <p:txBody>
-          <a:bodyPr wrap="square" lIns="54000" tIns="36000" rIns="54000" bIns="36000" rtlCol="0" anchor="t"/>
+          <a:bodyPr wrap="square" lIns="54000" tIns="36000" rIns="54000" bIns="36000" rtlCol="0" anchor="ctr"/>
           <a:lstStyle/>
           <a:p>
             <a:pPr marL="0" indent="0" algn="ctr">
@@ -15725,28 +15446,6 @@
               </a:rPr>
               <a:t>Agents</a:t>
             </a:r>
-          </a:p>
-          <a:p>
-            <a:pPr marL="0" indent="0" algn="ctr">
-              <a:buNone/>
-            </a:pPr>
-            <a:endParaRPr lang="en-US" sz="800" dirty="0">
-              <a:solidFill>
-                <a:srgbClr val="FFFFFF"/>
-              </a:solidFill>
-              <a:latin typeface="Arial" pitchFamily="34" charset="0"/>
-            </a:endParaRPr>
-          </a:p>
-          <a:p>
-            <a:pPr marL="0" indent="0" algn="ctr">
-              <a:buNone/>
-            </a:pPr>
-            <a:endParaRPr lang="en-US" sz="800" dirty="0">
-              <a:solidFill>
-                <a:srgbClr val="FFFFFF"/>
-              </a:solidFill>
-              <a:latin typeface="Arial" pitchFamily="34" charset="0"/>
-            </a:endParaRPr>
           </a:p>
           <a:p>
             <a:pPr marL="0" indent="0" algn="ctr">
@@ -15773,7 +15472,7 @@
         </p:nvSpPr>
         <p:spPr>
           <a:xfrm>
-            <a:off x="706120" y="3497580"/>
+            <a:off x="685800" y="3017520"/>
             <a:ext cx="7315200" cy="228600"/>
           </a:xfrm>
           <a:prstGeom prst="rect">
@@ -15809,7 +15508,7 @@
         </p:nvSpPr>
         <p:spPr>
           <a:xfrm>
-            <a:off x="706120" y="3817620"/>
+            <a:off x="685800" y="3337560"/>
             <a:ext cx="2560320" cy="182880"/>
           </a:xfrm>
           <a:prstGeom prst="rect">
@@ -15845,7 +15544,7 @@
         </p:nvSpPr>
         <p:spPr>
           <a:xfrm>
-            <a:off x="706120" y="4000500"/>
+            <a:off x="685800" y="3520440"/>
             <a:ext cx="2560320" cy="457200"/>
           </a:xfrm>
           <a:prstGeom prst="rect">
@@ -15865,7 +15564,7 @@
                 </a:solidFill>
                 <a:latin typeface="Arial" pitchFamily="34" charset="0"/>
               </a:rPr>
-              <a:t>Cross-platform knowledge not possible.</a:t>
+              <a:t>No persistent cross-platform knowledge.</a:t>
             </a:r>
           </a:p>
           <a:p>
@@ -15879,7 +15578,7 @@
                 </a:solidFill>
                 <a:latin typeface="Arial" pitchFamily="34" charset="0"/>
               </a:rPr>
-              <a:t>Optimized for horizontal, not individual depth. </a:t>
+              <a:t xml:space="preserve">Optimized for breadth, not individual depth. </a:t>
             </a:r>
           </a:p>
         </p:txBody>
@@ -15892,7 +15591,7 @@
         </p:nvSpPr>
         <p:spPr>
           <a:xfrm>
-            <a:off x="3449320" y="3817620"/>
+            <a:off x="3429000" y="3337560"/>
             <a:ext cx="2560320" cy="182880"/>
           </a:xfrm>
           <a:prstGeom prst="rect">
@@ -15915,179 +15614,190 @@
                 </a:solidFill>
                 <a:latin typeface="Arial" pitchFamily="34" charset="0"/>
               </a:rPr>
-              <a:t>Agent Startups (</a:t>
-            </a:r>
-            <a:r>
-              <a:rPr lang="en-US" sz="1000" b="1" dirty="0" err="1">
+              <a:t>Agent Startups</a:t>
+            </a:r>
+          </a:p>
+        </p:txBody>
+      </p:sp>
+      <p:sp>
+        <p:nvSpPr>
+          <p:cNvPr id="19" name="Text 17"/>
+          <p:cNvSpPr/>
+          <p:nvPr/>
+        </p:nvSpPr>
+        <p:spPr>
+          <a:xfrm>
+            <a:off x="3429000" y="3520440"/>
+            <a:ext cx="2560320" cy="457200"/>
+          </a:xfrm>
+          <a:prstGeom prst="rect">
+            <a:avLst/>
+          </a:prstGeom>
+          <a:noFill/>
+          <a:ln/>
+        </p:spPr>
+        <p:txBody>
+          <a:bodyPr wrap="square" lIns="0" tIns="0" rIns="0" bIns="0" rtlCol="0" anchor="t"/>
+          <a:lstStyle/>
+          <a:p>
+            <a:pPr marL="0" indent="0">
+              <a:buNone/>
+            </a:pPr>
+            <a:r>
+              <a:rPr lang="en-US" sz="900" dirty="0">
+                <a:solidFill>
+                  <a:srgbClr val="666666"/>
+                </a:solidFill>
+                <a:latin typeface="Arial" pitchFamily="34" charset="0"/>
+              </a:rPr>
+              <a:t>Architectural gap.</a:t>
+            </a:r>
+          </a:p>
+          <a:p>
+            <a:pPr marL="0" indent="0">
+              <a:buNone/>
+            </a:pPr>
+            <a:r>
+              <a:rPr lang="en-US" sz="900" dirty="0">
+                <a:solidFill>
+                  <a:srgbClr val="666666"/>
+                </a:solidFill>
+                <a:latin typeface="Arial" pitchFamily="34" charset="0"/>
+              </a:rPr>
+              <a:t xml:space="preserve">Task execution focused. </a:t>
+            </a:r>
+          </a:p>
+          <a:p>
+            <a:pPr marL="0" indent="0">
+              <a:buNone/>
+            </a:pPr>
+            <a:r>
+              <a:rPr lang="en-US" sz="900" dirty="0">
+                <a:solidFill>
+                  <a:srgbClr val="666666"/>
+                </a:solidFill>
+                <a:latin typeface="Arial" pitchFamily="34" charset="0"/>
+              </a:rPr>
+              <a:t>No accumulated knowledge layer with feedback loop</a:t>
+            </a:r>
+          </a:p>
+        </p:txBody>
+      </p:sp>
+      <p:sp>
+        <p:nvSpPr>
+          <p:cNvPr id="24" name="Text 18"/>
+          <p:cNvSpPr/>
+          <p:nvPr/>
+        </p:nvSpPr>
+        <p:spPr>
+          <a:xfrm>
+            <a:off x="6172200" y="3337560"/>
+            <a:ext cx="2560320" cy="182880"/>
+          </a:xfrm>
+          <a:prstGeom prst="rect">
+            <a:avLst/>
+          </a:prstGeom>
+          <a:noFill/>
+          <a:ln/>
+        </p:spPr>
+        <p:txBody>
+          <a:bodyPr wrap="square" lIns="0" tIns="0" rIns="0" bIns="0" rtlCol="0" anchor="ctr"/>
+          <a:lstStyle/>
+          <a:p>
+            <a:pPr marL="0" indent="0">
+              <a:buNone/>
+            </a:pPr>
+            <a:r>
+              <a:rPr lang="en-US" sz="1000" b="1" dirty="0">
                 <a:solidFill>
                   <a:srgbClr val="111111"/>
                 </a:solidFill>
                 <a:latin typeface="Arial" pitchFamily="34" charset="0"/>
               </a:rPr>
-              <a:t>mem.ai</a:t>
-            </a:r>
+              <a:t>Workspace AI</a:t>
+            </a:r>
+          </a:p>
+        </p:txBody>
+      </p:sp>
+      <p:sp>
+        <p:nvSpPr>
+          <p:cNvPr id="25" name="Text 19"/>
+          <p:cNvSpPr/>
+          <p:nvPr/>
+        </p:nvSpPr>
+        <p:spPr>
+          <a:xfrm>
+            <a:off x="6172200" y="3520440"/>
+            <a:ext cx="2560320" cy="457200"/>
+          </a:xfrm>
+          <a:prstGeom prst="rect">
+            <a:avLst/>
+          </a:prstGeom>
+          <a:noFill/>
+          <a:ln/>
+        </p:spPr>
+        <p:txBody>
+          <a:bodyPr wrap="square" lIns="0" tIns="0" rIns="0" bIns="0" rtlCol="0" anchor="t"/>
+          <a:lstStyle/>
+          <a:p>
+            <a:pPr marL="0" indent="0">
+              <a:buNone/>
+            </a:pPr>
+            <a:r>
+              <a:rPr lang="en-US" sz="900" dirty="0">
+                <a:solidFill>
+                  <a:srgbClr val="666666"/>
+                </a:solidFill>
+                <a:latin typeface="Arial" pitchFamily="34" charset="0"/>
+              </a:rPr>
+              <a:t xml:space="preserve">Single-platform. Can’t synthesize across tools. </a:t>
+            </a:r>
+          </a:p>
+          <a:p>
+            <a:pPr marL="0" indent="0">
+              <a:buNone/>
+            </a:pPr>
+            <a:r>
+              <a:rPr lang="en-US" sz="900" dirty="0">
+                <a:solidFill>
+                  <a:srgbClr val="666666"/>
+                </a:solidFill>
+                <a:latin typeface="Arial" pitchFamily="34" charset="0"/>
+              </a:rPr>
+              <a:t>No persistent agents.</a:t>
+            </a:r>
+          </a:p>
+        </p:txBody>
+      </p:sp>
+      <p:sp>
+        <p:nvSpPr>
+          <p:cNvPr id="26" name="Text 20"/>
+          <p:cNvSpPr/>
+          <p:nvPr/>
+        </p:nvSpPr>
+        <p:spPr>
+          <a:xfrm>
+            <a:off x="685800" y="4206240"/>
+            <a:ext cx="7772400" cy="274320"/>
+          </a:xfrm>
+          <a:prstGeom prst="rect">
+            <a:avLst/>
+          </a:prstGeom>
+          <a:noFill/>
+          <a:ln/>
+        </p:spPr>
+        <p:txBody>
+          <a:bodyPr wrap="square" lIns="0" tIns="0" rIns="0" bIns="0" rtlCol="0" anchor="ctr"/>
+          <a:lstStyle/>
+          <a:p>
             <a:r>
               <a:rPr lang="en-US" sz="1000" b="1" dirty="0">
                 <a:solidFill>
-                  <a:srgbClr val="111111"/>
-                </a:solidFill>
-                <a:latin typeface="Arial" pitchFamily="34" charset="0"/>
-              </a:rPr>
-              <a:t>, </a:t>
-            </a:r>
-            <a:r>
-              <a:rPr lang="en-US" sz="1000" b="1" dirty="0" err="1">
-                <a:solidFill>
-                  <a:srgbClr val="111111"/>
-                </a:solidFill>
-                <a:latin typeface="Arial" pitchFamily="34" charset="0"/>
-              </a:rPr>
-              <a:t>openclaw</a:t>
-            </a:r>
-            <a:r>
-              <a:rPr lang="en-US" sz="1000" b="1" dirty="0">
-                <a:solidFill>
-                  <a:srgbClr val="111111"/>
-                </a:solidFill>
-                <a:latin typeface="Arial" pitchFamily="34" charset="0"/>
-              </a:rPr>
-              <a:t>)</a:t>
-            </a:r>
-          </a:p>
-        </p:txBody>
-      </p:sp>
-      <p:sp>
-        <p:nvSpPr>
-          <p:cNvPr id="19" name="Text 17"/>
-          <p:cNvSpPr/>
-          <p:nvPr/>
-        </p:nvSpPr>
-        <p:spPr>
-          <a:xfrm>
-            <a:off x="3449320" y="4000500"/>
-            <a:ext cx="2560320" cy="457200"/>
-          </a:xfrm>
-          <a:prstGeom prst="rect">
-            <a:avLst/>
-          </a:prstGeom>
-          <a:noFill/>
-          <a:ln/>
-        </p:spPr>
-        <p:txBody>
-          <a:bodyPr wrap="square" lIns="0" tIns="0" rIns="0" bIns="0" rtlCol="0" anchor="t"/>
-          <a:lstStyle/>
-          <a:p>
-            <a:pPr marL="0" indent="0">
-              <a:buNone/>
-            </a:pPr>
-            <a:r>
-              <a:rPr lang="en-US" sz="900" dirty="0">
-                <a:solidFill>
-                  <a:srgbClr val="666666"/>
-                </a:solidFill>
-                <a:latin typeface="Arial" pitchFamily="34" charset="0"/>
-              </a:rPr>
-              <a:t>Architectural gap. (hardware or agent framework)</a:t>
-            </a:r>
-          </a:p>
-          <a:p>
-            <a:pPr marL="0" indent="0">
-              <a:buNone/>
-            </a:pPr>
-            <a:r>
-              <a:rPr lang="en-US" sz="900" dirty="0">
-                <a:solidFill>
-                  <a:srgbClr val="666666"/>
-                </a:solidFill>
-                <a:latin typeface="Arial" pitchFamily="34" charset="0"/>
-              </a:rPr>
-              <a:t>No accumulated knowledge layer with feedback loop</a:t>
-            </a:r>
-          </a:p>
-        </p:txBody>
-      </p:sp>
-      <p:sp>
-        <p:nvSpPr>
-          <p:cNvPr id="24" name="Text 18"/>
-          <p:cNvSpPr/>
-          <p:nvPr/>
-        </p:nvSpPr>
-        <p:spPr>
-          <a:xfrm>
-            <a:off x="6192520" y="3817620"/>
-            <a:ext cx="2560320" cy="182880"/>
-          </a:xfrm>
-          <a:prstGeom prst="rect">
-            <a:avLst/>
-          </a:prstGeom>
-          <a:noFill/>
-          <a:ln/>
-        </p:spPr>
-        <p:txBody>
-          <a:bodyPr wrap="square" lIns="0" tIns="0" rIns="0" bIns="0" rtlCol="0" anchor="ctr"/>
-          <a:lstStyle/>
-          <a:p>
-            <a:pPr marL="0" indent="0">
-              <a:buNone/>
-            </a:pPr>
-            <a:r>
-              <a:rPr lang="en-US" sz="1000" b="1" dirty="0">
-                <a:solidFill>
-                  <a:srgbClr val="111111"/>
-                </a:solidFill>
-                <a:latin typeface="Arial" pitchFamily="34" charset="0"/>
-              </a:rPr>
-              <a:t>Workspace AI (Notion AI, Slack)</a:t>
-            </a:r>
-          </a:p>
-        </p:txBody>
-      </p:sp>
-      <p:sp>
-        <p:nvSpPr>
-          <p:cNvPr id="25" name="Text 19"/>
-          <p:cNvSpPr/>
-          <p:nvPr/>
-        </p:nvSpPr>
-        <p:spPr>
-          <a:xfrm>
-            <a:off x="6192520" y="4000500"/>
-            <a:ext cx="2560320" cy="457200"/>
-          </a:xfrm>
-          <a:prstGeom prst="rect">
-            <a:avLst/>
-          </a:prstGeom>
-          <a:noFill/>
-          <a:ln/>
-        </p:spPr>
-        <p:txBody>
-          <a:bodyPr wrap="square" lIns="0" tIns="0" rIns="0" bIns="0" rtlCol="0" anchor="t"/>
-          <a:lstStyle/>
-          <a:p>
-            <a:pPr marL="0" indent="0">
-              <a:buNone/>
-            </a:pPr>
-            <a:r>
-              <a:rPr lang="en-US" sz="900" dirty="0">
-                <a:solidFill>
-                  <a:srgbClr val="666666"/>
-                </a:solidFill>
-                <a:latin typeface="Arial" pitchFamily="34" charset="0"/>
-              </a:rPr>
-              <a:t>Single-platform. Can’t synthesize across tools. </a:t>
-            </a:r>
-          </a:p>
-          <a:p>
-            <a:pPr marL="0" indent="0">
-              <a:buNone/>
-            </a:pPr>
-            <a:r>
-              <a:rPr lang="en-US" sz="900" dirty="0">
-                <a:solidFill>
-                  <a:srgbClr val="666666"/>
-                </a:solidFill>
-                <a:latin typeface="Arial" pitchFamily="34" charset="0"/>
-              </a:rPr>
-              <a:t>No persistent agents.</a:t>
+                  <a:srgbClr val="E8985E"/>
+                </a:solidFill>
+                <a:latin typeface="Arial" pitchFamily="34" charset="0"/>
+              </a:rPr>
+              <a:t>Every layer purpose-built for knowledge accumulation, true autonomy + intelligence</a:t>
             </a:r>
           </a:p>
         </p:txBody>
@@ -16950,241 +16660,6 @@
           </a:p>
         </p:txBody>
       </p:sp>
-      <p:pic>
-        <p:nvPicPr>
-          <p:cNvPr id="1026" name="Picture 2" descr="Slack logo - free Icon PNG, SVG">
-            <a:extLst>
-              <a:ext uri="{FF2B5EF4-FFF2-40B4-BE49-F238E27FC236}">
-                <a16:creationId xmlns:a16="http://schemas.microsoft.com/office/drawing/2014/main" id="{41B8F80D-AC21-0546-BB33-708657AAAAF4}"/>
-              </a:ext>
-            </a:extLst>
-          </p:cNvPr>
-          <p:cNvPicPr>
-            <a:picLocks noChangeAspect="1" noChangeArrowheads="1"/>
-          </p:cNvPicPr>
-          <p:nvPr/>
-        </p:nvPicPr>
-        <p:blipFill>
-          <a:blip r:embed="rId3">
-            <a:extLst>
-              <a:ext uri="{28A0092B-C50C-407E-A947-70E740481C1C}">
-                <a14:useLocalDpi xmlns:a14="http://schemas.microsoft.com/office/drawing/2010/main" val="0"/>
-              </a:ext>
-            </a:extLst>
-          </a:blip>
-          <a:srcRect/>
-          <a:stretch>
-            <a:fillRect/>
-          </a:stretch>
-        </p:blipFill>
-        <p:spPr bwMode="auto">
-          <a:xfrm>
-            <a:off x="1026468" y="3615163"/>
-            <a:ext cx="327232" cy="327232"/>
-          </a:xfrm>
-          <a:prstGeom prst="rect">
-            <a:avLst/>
-          </a:prstGeom>
-          <a:noFill/>
-          <a:extLst>
-            <a:ext uri="{909E8E84-426E-40DD-AFC4-6F175D3DCCD1}">
-              <a14:hiddenFill xmlns:a14="http://schemas.microsoft.com/office/drawing/2010/main">
-                <a:solidFill>
-                  <a:srgbClr val="FFFFFF"/>
-                </a:solidFill>
-              </a14:hiddenFill>
-            </a:ext>
-          </a:extLst>
-        </p:spPr>
-      </p:pic>
-      <p:pic>
-        <p:nvPicPr>
-          <p:cNvPr id="1028" name="Picture 4" descr="Gmail new logo - free Icon PNG, SVG">
-            <a:extLst>
-              <a:ext uri="{FF2B5EF4-FFF2-40B4-BE49-F238E27FC236}">
-                <a16:creationId xmlns:a16="http://schemas.microsoft.com/office/drawing/2014/main" id="{977D2602-1FC1-B338-DD80-43810A7406BC}"/>
-              </a:ext>
-            </a:extLst>
-          </p:cNvPr>
-          <p:cNvPicPr>
-            <a:picLocks noChangeAspect="1" noChangeArrowheads="1"/>
-          </p:cNvPicPr>
-          <p:nvPr/>
-        </p:nvPicPr>
-        <p:blipFill>
-          <a:blip r:embed="rId4">
-            <a:extLst>
-              <a:ext uri="{28A0092B-C50C-407E-A947-70E740481C1C}">
-                <a14:useLocalDpi xmlns:a14="http://schemas.microsoft.com/office/drawing/2010/main" val="0"/>
-              </a:ext>
-            </a:extLst>
-          </a:blip>
-          <a:srcRect/>
-          <a:stretch>
-            <a:fillRect/>
-          </a:stretch>
-        </p:blipFill>
-        <p:spPr bwMode="auto">
-          <a:xfrm>
-            <a:off x="1713657" y="3565760"/>
-            <a:ext cx="426038" cy="426038"/>
-          </a:xfrm>
-          <a:prstGeom prst="rect">
-            <a:avLst/>
-          </a:prstGeom>
-          <a:noFill/>
-          <a:extLst>
-            <a:ext uri="{909E8E84-426E-40DD-AFC4-6F175D3DCCD1}">
-              <a14:hiddenFill xmlns:a14="http://schemas.microsoft.com/office/drawing/2010/main">
-                <a:solidFill>
-                  <a:srgbClr val="FFFFFF"/>
-                </a:solidFill>
-              </a14:hiddenFill>
-            </a:ext>
-          </a:extLst>
-        </p:spPr>
-      </p:pic>
-      <p:pic>
-        <p:nvPicPr>
-          <p:cNvPr id="1032" name="Picture 8" descr="Notion-style Icons">
-            <a:extLst>
-              <a:ext uri="{FF2B5EF4-FFF2-40B4-BE49-F238E27FC236}">
-                <a16:creationId xmlns:a16="http://schemas.microsoft.com/office/drawing/2014/main" id="{152A952D-5370-40F6-A8C2-803C8A1B7EE3}"/>
-              </a:ext>
-            </a:extLst>
-          </p:cNvPr>
-          <p:cNvPicPr>
-            <a:picLocks noChangeAspect="1" noChangeArrowheads="1"/>
-          </p:cNvPicPr>
-          <p:nvPr/>
-        </p:nvPicPr>
-        <p:blipFill>
-          <a:blip r:embed="rId5">
-            <a:extLst>
-              <a:ext uri="{28A0092B-C50C-407E-A947-70E740481C1C}">
-                <a14:useLocalDpi xmlns:a14="http://schemas.microsoft.com/office/drawing/2010/main" val="0"/>
-              </a:ext>
-            </a:extLst>
-          </a:blip>
-          <a:srcRect/>
-          <a:stretch>
-            <a:fillRect/>
-          </a:stretch>
-        </p:blipFill>
-        <p:spPr bwMode="auto">
-          <a:xfrm>
-            <a:off x="2499652" y="3571132"/>
-            <a:ext cx="426038" cy="426038"/>
-          </a:xfrm>
-          <a:prstGeom prst="rect">
-            <a:avLst/>
-          </a:prstGeom>
-          <a:noFill/>
-          <a:extLst>
-            <a:ext uri="{909E8E84-426E-40DD-AFC4-6F175D3DCCD1}">
-              <a14:hiddenFill xmlns:a14="http://schemas.microsoft.com/office/drawing/2010/main">
-                <a:solidFill>
-                  <a:srgbClr val="FFFFFF"/>
-                </a:solidFill>
-              </a14:hiddenFill>
-            </a:ext>
-          </a:extLst>
-        </p:spPr>
-      </p:pic>
-      <p:pic>
-        <p:nvPicPr>
-          <p:cNvPr id="1034" name="Picture 10" descr="calendar icon vector 24150216 Vector Art at Vecteezy">
-            <a:extLst>
-              <a:ext uri="{FF2B5EF4-FFF2-40B4-BE49-F238E27FC236}">
-                <a16:creationId xmlns:a16="http://schemas.microsoft.com/office/drawing/2014/main" id="{ED7105D5-D07A-D7C8-CA39-05077DA0FFC6}"/>
-              </a:ext>
-            </a:extLst>
-          </p:cNvPr>
-          <p:cNvPicPr>
-            <a:picLocks noChangeAspect="1" noChangeArrowheads="1"/>
-          </p:cNvPicPr>
-          <p:nvPr/>
-        </p:nvPicPr>
-        <p:blipFill>
-          <a:blip r:embed="rId6">
-            <a:extLst>
-              <a:ext uri="{28A0092B-C50C-407E-A947-70E740481C1C}">
-                <a14:useLocalDpi xmlns:a14="http://schemas.microsoft.com/office/drawing/2010/main" val="0"/>
-              </a:ext>
-            </a:extLst>
-          </a:blip>
-          <a:srcRect/>
-          <a:stretch>
-            <a:fillRect/>
-          </a:stretch>
-        </p:blipFill>
-        <p:spPr bwMode="auto">
-          <a:xfrm>
-            <a:off x="4469130" y="3557721"/>
-            <a:ext cx="499402" cy="499402"/>
-          </a:xfrm>
-          <a:prstGeom prst="rect">
-            <a:avLst/>
-          </a:prstGeom>
-          <a:noFill/>
-          <a:extLst>
-            <a:ext uri="{909E8E84-426E-40DD-AFC4-6F175D3DCCD1}">
-              <a14:hiddenFill xmlns:a14="http://schemas.microsoft.com/office/drawing/2010/main">
-                <a:solidFill>
-                  <a:srgbClr val="FFFFFF"/>
-                </a:solidFill>
-              </a14:hiddenFill>
-            </a:ext>
-          </a:extLst>
-        </p:spPr>
-      </p:pic>
-      <p:pic>
-        <p:nvPicPr>
-          <p:cNvPr id="1036" name="Picture 12" descr="55,636 Crossroad Icon Stock Vectors and Vector Art | Shutterstock">
-            <a:extLst>
-              <a:ext uri="{FF2B5EF4-FFF2-40B4-BE49-F238E27FC236}">
-                <a16:creationId xmlns:a16="http://schemas.microsoft.com/office/drawing/2014/main" id="{42C2C16F-9F74-9824-4912-86950CD98020}"/>
-              </a:ext>
-            </a:extLst>
-          </p:cNvPr>
-          <p:cNvPicPr>
-            <a:picLocks noChangeAspect="1" noChangeArrowheads="1"/>
-          </p:cNvPicPr>
-          <p:nvPr/>
-        </p:nvPicPr>
-        <p:blipFill rotWithShape="1">
-          <a:blip r:embed="rId7">
-            <a:extLst>
-              <a:ext uri="{28A0092B-C50C-407E-A947-70E740481C1C}">
-                <a14:useLocalDpi xmlns:a14="http://schemas.microsoft.com/office/drawing/2010/main" val="0"/>
-              </a:ext>
-            </a:extLst>
-          </a:blip>
-          <a:srcRect l="53403" t="13395" r="7919" b="14233"/>
-          <a:stretch>
-            <a:fillRect/>
-          </a:stretch>
-        </p:blipFill>
-        <p:spPr bwMode="auto">
-          <a:xfrm>
-            <a:off x="7408399" y="3542913"/>
-            <a:ext cx="499402" cy="509274"/>
-          </a:xfrm>
-          <a:prstGeom prst="rect">
-            <a:avLst/>
-          </a:prstGeom>
-          <a:noFill/>
-          <a:extLst>
-            <a:ext uri="{909E8E84-426E-40DD-AFC4-6F175D3DCCD1}">
-              <a14:hiddenFill xmlns:a14="http://schemas.microsoft.com/office/drawing/2010/main">
-                <a:solidFill>
-                  <a:srgbClr val="FFFFFF"/>
-                </a:solidFill>
-              </a14:hiddenFill>
-            </a:ext>
-          </a:extLst>
-        </p:spPr>
-      </p:pic>
     </p:spTree>
   </p:cSld>
   <p:clrMapOvr>
@@ -17304,57 +16779,34 @@
         </p:nvSpPr>
         <p:spPr>
           <a:xfrm>
-            <a:off x="685800" y="1486028"/>
-            <a:ext cx="4274507" cy="610259"/>
-          </a:xfrm>
-          <a:prstGeom prst="rect">
-            <a:avLst/>
-          </a:prstGeom>
-          <a:noFill/>
-          <a:ln/>
-        </p:spPr>
-        <p:txBody>
-          <a:bodyPr wrap="square" lIns="0" tIns="0" rIns="0" bIns="0" rtlCol="0" anchor="ctr"/>
-          <a:lstStyle/>
-          <a:p>
-            <a:pPr marL="0" indent="0">
-              <a:buNone/>
-            </a:pPr>
-            <a:r>
-              <a:rPr lang="en-US" sz="1200" b="1" dirty="0">
-                <a:latin typeface="Arial" pitchFamily="34" charset="0"/>
-                <a:ea typeface="Arial" pitchFamily="34" charset="-122"/>
-                <a:cs typeface="Arial" pitchFamily="34" charset="-120"/>
-              </a:rPr>
-              <a:t>Every agent run makes the next one better. </a:t>
-            </a:r>
-          </a:p>
-          <a:p>
-            <a:pPr marL="0" indent="0">
-              <a:buNone/>
-            </a:pPr>
-            <a:r>
-              <a:rPr lang="en-US" sz="1200" b="1" dirty="0">
-                <a:latin typeface="Arial" pitchFamily="34" charset="0"/>
-                <a:ea typeface="Arial" pitchFamily="34" charset="-122"/>
-                <a:cs typeface="Arial" pitchFamily="34" charset="-120"/>
-              </a:rPr>
-              <a:t>Every edit teaches the system. </a:t>
-            </a:r>
-          </a:p>
-          <a:p>
-            <a:pPr marL="0" indent="0">
-              <a:buNone/>
-            </a:pPr>
-            <a:r>
-              <a:rPr lang="en-US" sz="1200" b="1" dirty="0">
-                <a:latin typeface="Arial" pitchFamily="34" charset="0"/>
-                <a:ea typeface="Arial" pitchFamily="34" charset="-122"/>
-                <a:cs typeface="Arial" pitchFamily="34" charset="-120"/>
-              </a:rPr>
-              <a:t>Every sync deepens the knowledge base.</a:t>
-            </a:r>
-            <a:endParaRPr lang="en-US" sz="1200" b="1" dirty="0"/>
+            <a:off x="685800" y="1356116"/>
+            <a:ext cx="7772400" cy="274320"/>
+          </a:xfrm>
+          <a:prstGeom prst="rect">
+            <a:avLst/>
+          </a:prstGeom>
+          <a:noFill/>
+          <a:ln/>
+        </p:spPr>
+        <p:txBody>
+          <a:bodyPr wrap="square" lIns="0" tIns="0" rIns="0" bIns="0" rtlCol="0" anchor="ctr"/>
+          <a:lstStyle/>
+          <a:p>
+            <a:pPr marL="0" indent="0">
+              <a:buNone/>
+            </a:pPr>
+            <a:r>
+              <a:rPr lang="en-US" sz="1100" dirty="0">
+                <a:solidFill>
+                  <a:srgbClr val="999999"/>
+                </a:solidFill>
+                <a:latin typeface="Arial" pitchFamily="34" charset="0"/>
+                <a:ea typeface="Arial" pitchFamily="34" charset="-122"/>
+                <a:cs typeface="Arial" pitchFamily="34" charset="-120"/>
+              </a:rPr>
+              <a:t>Every agent run makes the next one better. Every edit teaches the system. Every sync deepens the knowledge base.</a:t>
+            </a:r>
+            <a:endParaRPr lang="en-US" sz="1100" dirty="0"/>
           </a:p>
         </p:txBody>
       </p:sp>
@@ -17366,7 +16818,7 @@
         </p:nvSpPr>
         <p:spPr>
           <a:xfrm>
-            <a:off x="713658" y="2261094"/>
+            <a:off x="926600" y="1930583"/>
             <a:ext cx="3657600" cy="274320"/>
           </a:xfrm>
           <a:prstGeom prst="rect">
@@ -17405,7 +16857,7 @@
         </p:nvSpPr>
         <p:spPr>
           <a:xfrm>
-            <a:off x="729316" y="2672574"/>
+            <a:off x="1155200" y="2342063"/>
             <a:ext cx="274320" cy="274320"/>
           </a:xfrm>
           <a:prstGeom prst="line">
@@ -17432,7 +16884,7 @@
         </p:nvSpPr>
         <p:spPr>
           <a:xfrm>
-            <a:off x="729316" y="2672574"/>
+            <a:off x="1155200" y="2342063"/>
             <a:ext cx="274320" cy="274320"/>
           </a:xfrm>
           <a:prstGeom prst="rect">
@@ -17468,8 +16920,8 @@
         </p:nvSpPr>
         <p:spPr>
           <a:xfrm>
-            <a:off x="1186516" y="2697626"/>
-            <a:ext cx="3960000" cy="274320"/>
+            <a:off x="1612400" y="2342063"/>
+            <a:ext cx="3200400" cy="274320"/>
           </a:xfrm>
           <a:prstGeom prst="rect">
             <a:avLst/>
@@ -17507,7 +16959,7 @@
         </p:nvSpPr>
         <p:spPr>
           <a:xfrm>
-            <a:off x="729316" y="3129774"/>
+            <a:off x="1155200" y="2799263"/>
             <a:ext cx="274320" cy="274320"/>
           </a:xfrm>
           <a:prstGeom prst="line">
@@ -17534,7 +16986,7 @@
         </p:nvSpPr>
         <p:spPr>
           <a:xfrm>
-            <a:off x="729316" y="3129774"/>
+            <a:off x="1155200" y="2799263"/>
             <a:ext cx="274320" cy="274320"/>
           </a:xfrm>
           <a:prstGeom prst="rect">
@@ -17570,8 +17022,8 @@
         </p:nvSpPr>
         <p:spPr>
           <a:xfrm>
-            <a:off x="1186516" y="3179878"/>
-            <a:ext cx="3960000" cy="274320"/>
+            <a:off x="1612400" y="2799263"/>
+            <a:ext cx="3200400" cy="274320"/>
           </a:xfrm>
           <a:prstGeom prst="rect">
             <a:avLst/>
@@ -17609,7 +17061,7 @@
         </p:nvSpPr>
         <p:spPr>
           <a:xfrm>
-            <a:off x="729316" y="3586974"/>
+            <a:off x="1155200" y="3256463"/>
             <a:ext cx="274320" cy="274320"/>
           </a:xfrm>
           <a:prstGeom prst="line">
@@ -17636,7 +17088,7 @@
         </p:nvSpPr>
         <p:spPr>
           <a:xfrm>
-            <a:off x="729316" y="3586974"/>
+            <a:off x="1155200" y="3256463"/>
             <a:ext cx="274320" cy="274320"/>
           </a:xfrm>
           <a:prstGeom prst="rect">
@@ -17672,8 +17124,8 @@
         </p:nvSpPr>
         <p:spPr>
           <a:xfrm>
-            <a:off x="1186516" y="3649604"/>
-            <a:ext cx="3960000" cy="274320"/>
+            <a:off x="1612400" y="3256463"/>
+            <a:ext cx="3200400" cy="274320"/>
           </a:xfrm>
           <a:prstGeom prst="rect">
             <a:avLst/>
@@ -17711,7 +17163,7 @@
         </p:nvSpPr>
         <p:spPr>
           <a:xfrm>
-            <a:off x="729316" y="4044174"/>
+            <a:off x="1155200" y="3713663"/>
             <a:ext cx="274320" cy="274320"/>
           </a:xfrm>
           <a:prstGeom prst="line">
@@ -17738,7 +17190,7 @@
         </p:nvSpPr>
         <p:spPr>
           <a:xfrm>
-            <a:off x="729316" y="4044174"/>
+            <a:off x="1155200" y="3713663"/>
             <a:ext cx="274320" cy="274320"/>
           </a:xfrm>
           <a:prstGeom prst="rect">
@@ -17760,7 +17212,7 @@
                 <a:ea typeface="Arial" pitchFamily="34" charset="-122"/>
                 <a:cs typeface="Arial" pitchFamily="34" charset="-120"/>
               </a:rPr>
-              <a:t> </a:t>
+              <a:t xml:space="preserve"> </a:t>
             </a:r>
             <a:endParaRPr lang="en-US" sz="1100" dirty="0"/>
           </a:p>
@@ -17774,7 +17226,7 @@
         </p:nvSpPr>
         <p:spPr>
           <a:xfrm>
-            <a:off x="1186516" y="4044174"/>
+            <a:off x="1612400" y="3713663"/>
             <a:ext cx="3200400" cy="274320"/>
           </a:xfrm>
           <a:prstGeom prst="rect">
@@ -17799,7 +17251,7 @@
                 <a:ea typeface="Arial" pitchFamily="34" charset="-122"/>
                 <a:cs typeface="Arial" pitchFamily="34" charset="-120"/>
               </a:rPr>
-              <a:t> </a:t>
+              <a:t xml:space="preserve"> </a:t>
             </a:r>
             <a:endParaRPr lang="en-US" sz="1100" dirty="0"/>
           </a:p>
@@ -17868,7 +17320,7 @@
                 <a:ea typeface="Arial" pitchFamily="34" charset="-122"/>
                 <a:cs typeface="Arial" pitchFamily="34" charset="-120"/>
               </a:rPr>
-              <a:t>Platforms </a:t>
+              <a:t xml:space="preserve">Platforms </a:t>
             </a:r>
             <a:br>
               <a:rPr lang="en-US" sz="700" dirty="0">

</xml_diff>